<commit_message>
Regenerate RTR launch schedule presentation
Update График_запуска_RTR.pptx after sorting timeline columns and
removing months before Jul 2026.

Co-authored-by: Artem Kostin <kostin.artem@gmail.com>
</commit_message>
<xml_diff>
--- a/График_запуска_RTR.pptx
+++ b/График_запуска_RTR.pptx
@@ -3490,7 +3490,7 @@
                     </a:lnB>
                   </a:tcPr>
                 </a:tc>
-                <a:tc gridSpan="3">
+                <a:tc gridSpan="8">
                   <a:txBody>
                     <a:bodyPr wrap="square"/>
                     <a:lstStyle/>
@@ -3601,6 +3601,151 @@
                     </a:lnB>
                   </a:tcPr>
                 </a:tc>
+                <a:tc hMerge="1">
+                  <a:txBody>
+                    <a:bodyPr/>
+                    <a:lstStyle/>
+                    <a:p/>
+                  </a:txBody>
+                  <a:tcPr>
+                    <a:lnL w="6350" cap="flat" cmpd="sng" algn="ctr">
+                      <a:solidFill>
+                        <a:srgbClr val="E8C4C8"/>
+                      </a:solidFill>
+                    </a:lnL>
+                    <a:lnR w="6350" cap="flat" cmpd="sng" algn="ctr">
+                      <a:solidFill>
+                        <a:srgbClr val="E8C4C8"/>
+                      </a:solidFill>
+                    </a:lnR>
+                    <a:lnT w="6350" cap="flat" cmpd="sng" algn="ctr">
+                      <a:solidFill>
+                        <a:srgbClr val="E8C4C8"/>
+                      </a:solidFill>
+                    </a:lnT>
+                    <a:lnB w="6350" cap="flat" cmpd="sng" algn="ctr">
+                      <a:solidFill>
+                        <a:srgbClr val="E8C4C8"/>
+                      </a:solidFill>
+                    </a:lnB>
+                  </a:tcPr>
+                </a:tc>
+                <a:tc hMerge="1">
+                  <a:txBody>
+                    <a:bodyPr/>
+                    <a:lstStyle/>
+                    <a:p/>
+                  </a:txBody>
+                  <a:tcPr>
+                    <a:lnL w="6350" cap="flat" cmpd="sng" algn="ctr">
+                      <a:solidFill>
+                        <a:srgbClr val="E8C4C8"/>
+                      </a:solidFill>
+                    </a:lnL>
+                    <a:lnR w="6350" cap="flat" cmpd="sng" algn="ctr">
+                      <a:solidFill>
+                        <a:srgbClr val="E8C4C8"/>
+                      </a:solidFill>
+                    </a:lnR>
+                    <a:lnT w="6350" cap="flat" cmpd="sng" algn="ctr">
+                      <a:solidFill>
+                        <a:srgbClr val="E8C4C8"/>
+                      </a:solidFill>
+                    </a:lnT>
+                    <a:lnB w="6350" cap="flat" cmpd="sng" algn="ctr">
+                      <a:solidFill>
+                        <a:srgbClr val="E8C4C8"/>
+                      </a:solidFill>
+                    </a:lnB>
+                  </a:tcPr>
+                </a:tc>
+                <a:tc hMerge="1">
+                  <a:txBody>
+                    <a:bodyPr/>
+                    <a:lstStyle/>
+                    <a:p/>
+                  </a:txBody>
+                  <a:tcPr>
+                    <a:lnL w="6350" cap="flat" cmpd="sng" algn="ctr">
+                      <a:solidFill>
+                        <a:srgbClr val="E8C4C8"/>
+                      </a:solidFill>
+                    </a:lnL>
+                    <a:lnR w="6350" cap="flat" cmpd="sng" algn="ctr">
+                      <a:solidFill>
+                        <a:srgbClr val="E8C4C8"/>
+                      </a:solidFill>
+                    </a:lnR>
+                    <a:lnT w="6350" cap="flat" cmpd="sng" algn="ctr">
+                      <a:solidFill>
+                        <a:srgbClr val="E8C4C8"/>
+                      </a:solidFill>
+                    </a:lnT>
+                    <a:lnB w="6350" cap="flat" cmpd="sng" algn="ctr">
+                      <a:solidFill>
+                        <a:srgbClr val="E8C4C8"/>
+                      </a:solidFill>
+                    </a:lnB>
+                  </a:tcPr>
+                </a:tc>
+                <a:tc hMerge="1">
+                  <a:txBody>
+                    <a:bodyPr/>
+                    <a:lstStyle/>
+                    <a:p/>
+                  </a:txBody>
+                  <a:tcPr>
+                    <a:lnL w="6350" cap="flat" cmpd="sng" algn="ctr">
+                      <a:solidFill>
+                        <a:srgbClr val="E8C4C8"/>
+                      </a:solidFill>
+                    </a:lnL>
+                    <a:lnR w="6350" cap="flat" cmpd="sng" algn="ctr">
+                      <a:solidFill>
+                        <a:srgbClr val="E8C4C8"/>
+                      </a:solidFill>
+                    </a:lnR>
+                    <a:lnT w="6350" cap="flat" cmpd="sng" algn="ctr">
+                      <a:solidFill>
+                        <a:srgbClr val="E8C4C8"/>
+                      </a:solidFill>
+                    </a:lnT>
+                    <a:lnB w="6350" cap="flat" cmpd="sng" algn="ctr">
+                      <a:solidFill>
+                        <a:srgbClr val="E8C4C8"/>
+                      </a:solidFill>
+                    </a:lnB>
+                  </a:tcPr>
+                </a:tc>
+                <a:tc hMerge="1">
+                  <a:txBody>
+                    <a:bodyPr/>
+                    <a:lstStyle/>
+                    <a:p/>
+                  </a:txBody>
+                  <a:tcPr>
+                    <a:lnL w="6350" cap="flat" cmpd="sng" algn="ctr">
+                      <a:solidFill>
+                        <a:srgbClr val="E8C4C8"/>
+                      </a:solidFill>
+                    </a:lnL>
+                    <a:lnR w="6350" cap="flat" cmpd="sng" algn="ctr">
+                      <a:solidFill>
+                        <a:srgbClr val="E8C4C8"/>
+                      </a:solidFill>
+                    </a:lnR>
+                    <a:lnT w="6350" cap="flat" cmpd="sng" algn="ctr">
+                      <a:solidFill>
+                        <a:srgbClr val="E8C4C8"/>
+                      </a:solidFill>
+                    </a:lnT>
+                    <a:lnB w="6350" cap="flat" cmpd="sng" algn="ctr">
+                      <a:solidFill>
+                        <a:srgbClr val="E8C4C8"/>
+                      </a:solidFill>
+                    </a:lnB>
+                  </a:tcPr>
+                </a:tc>
                 <a:tc>
                   <a:txBody>
                     <a:bodyPr wrap="square"/>
@@ -3632,175 +3777,6 @@
                     <a:solidFill>
                       <a:srgbClr val="570C17"/>
                     </a:solidFill>
-                    <a:lnL w="6350" cap="flat" cmpd="sng" algn="ctr">
-                      <a:solidFill>
-                        <a:srgbClr val="E8C4C8"/>
-                      </a:solidFill>
-                    </a:lnL>
-                    <a:lnR w="6350" cap="flat" cmpd="sng" algn="ctr">
-                      <a:solidFill>
-                        <a:srgbClr val="E8C4C8"/>
-                      </a:solidFill>
-                    </a:lnR>
-                    <a:lnT w="6350" cap="flat" cmpd="sng" algn="ctr">
-                      <a:solidFill>
-                        <a:srgbClr val="E8C4C8"/>
-                      </a:solidFill>
-                    </a:lnT>
-                    <a:lnB w="6350" cap="flat" cmpd="sng" algn="ctr">
-                      <a:solidFill>
-                        <a:srgbClr val="E8C4C8"/>
-                      </a:solidFill>
-                    </a:lnB>
-                  </a:tcPr>
-                </a:tc>
-                <a:tc gridSpan="5">
-                  <a:txBody>
-                    <a:bodyPr wrap="square"/>
-                    <a:lstStyle/>
-                    <a:p>
-                      <a:pPr algn="ctr">
-                        <a:lnSpc>
-                          <a:spcPct val="100000"/>
-                        </a:lnSpc>
-                        <a:spcBef>
-                          <a:spcPts val="0"/>
-                        </a:spcBef>
-                        <a:spcAft>
-                          <a:spcPts val="0"/>
-                        </a:spcAft>
-                      </a:pPr>
-                      <a:r>
-                        <a:rPr sz="700" b="1">
-                          <a:solidFill>
-                            <a:srgbClr val="FFFFFF"/>
-                          </a:solidFill>
-                          <a:latin typeface="Calibri"/>
-                        </a:rPr>
-                        <a:t>2027</a:t>
-                      </a:r>
-                    </a:p>
-                  </a:txBody>
-                  <a:tcPr anchor="ctr" marL="25400" marR="25400" marT="12700" marB="12700">
-                    <a:solidFill>
-                      <a:srgbClr val="570C17"/>
-                    </a:solidFill>
-                    <a:lnL w="6350" cap="flat" cmpd="sng" algn="ctr">
-                      <a:solidFill>
-                        <a:srgbClr val="E8C4C8"/>
-                      </a:solidFill>
-                    </a:lnL>
-                    <a:lnR w="6350" cap="flat" cmpd="sng" algn="ctr">
-                      <a:solidFill>
-                        <a:srgbClr val="E8C4C8"/>
-                      </a:solidFill>
-                    </a:lnR>
-                    <a:lnT w="6350" cap="flat" cmpd="sng" algn="ctr">
-                      <a:solidFill>
-                        <a:srgbClr val="E8C4C8"/>
-                      </a:solidFill>
-                    </a:lnT>
-                    <a:lnB w="6350" cap="flat" cmpd="sng" algn="ctr">
-                      <a:solidFill>
-                        <a:srgbClr val="E8C4C8"/>
-                      </a:solidFill>
-                    </a:lnB>
-                  </a:tcPr>
-                </a:tc>
-                <a:tc hMerge="1">
-                  <a:txBody>
-                    <a:bodyPr/>
-                    <a:lstStyle/>
-                    <a:p/>
-                  </a:txBody>
-                  <a:tcPr>
-                    <a:lnL w="6350" cap="flat" cmpd="sng" algn="ctr">
-                      <a:solidFill>
-                        <a:srgbClr val="E8C4C8"/>
-                      </a:solidFill>
-                    </a:lnL>
-                    <a:lnR w="6350" cap="flat" cmpd="sng" algn="ctr">
-                      <a:solidFill>
-                        <a:srgbClr val="E8C4C8"/>
-                      </a:solidFill>
-                    </a:lnR>
-                    <a:lnT w="6350" cap="flat" cmpd="sng" algn="ctr">
-                      <a:solidFill>
-                        <a:srgbClr val="E8C4C8"/>
-                      </a:solidFill>
-                    </a:lnT>
-                    <a:lnB w="6350" cap="flat" cmpd="sng" algn="ctr">
-                      <a:solidFill>
-                        <a:srgbClr val="E8C4C8"/>
-                      </a:solidFill>
-                    </a:lnB>
-                  </a:tcPr>
-                </a:tc>
-                <a:tc hMerge="1">
-                  <a:txBody>
-                    <a:bodyPr/>
-                    <a:lstStyle/>
-                    <a:p/>
-                  </a:txBody>
-                  <a:tcPr>
-                    <a:lnL w="6350" cap="flat" cmpd="sng" algn="ctr">
-                      <a:solidFill>
-                        <a:srgbClr val="E8C4C8"/>
-                      </a:solidFill>
-                    </a:lnL>
-                    <a:lnR w="6350" cap="flat" cmpd="sng" algn="ctr">
-                      <a:solidFill>
-                        <a:srgbClr val="E8C4C8"/>
-                      </a:solidFill>
-                    </a:lnR>
-                    <a:lnT w="6350" cap="flat" cmpd="sng" algn="ctr">
-                      <a:solidFill>
-                        <a:srgbClr val="E8C4C8"/>
-                      </a:solidFill>
-                    </a:lnT>
-                    <a:lnB w="6350" cap="flat" cmpd="sng" algn="ctr">
-                      <a:solidFill>
-                        <a:srgbClr val="E8C4C8"/>
-                      </a:solidFill>
-                    </a:lnB>
-                  </a:tcPr>
-                </a:tc>
-                <a:tc hMerge="1">
-                  <a:txBody>
-                    <a:bodyPr/>
-                    <a:lstStyle/>
-                    <a:p/>
-                  </a:txBody>
-                  <a:tcPr>
-                    <a:lnL w="6350" cap="flat" cmpd="sng" algn="ctr">
-                      <a:solidFill>
-                        <a:srgbClr val="E8C4C8"/>
-                      </a:solidFill>
-                    </a:lnL>
-                    <a:lnR w="6350" cap="flat" cmpd="sng" algn="ctr">
-                      <a:solidFill>
-                        <a:srgbClr val="E8C4C8"/>
-                      </a:solidFill>
-                    </a:lnR>
-                    <a:lnT w="6350" cap="flat" cmpd="sng" algn="ctr">
-                      <a:solidFill>
-                        <a:srgbClr val="E8C4C8"/>
-                      </a:solidFill>
-                    </a:lnT>
-                    <a:lnB w="6350" cap="flat" cmpd="sng" algn="ctr">
-                      <a:solidFill>
-                        <a:srgbClr val="E8C4C8"/>
-                      </a:solidFill>
-                    </a:lnB>
-                  </a:tcPr>
-                </a:tc>
-                <a:tc hMerge="1">
-                  <a:txBody>
-                    <a:bodyPr/>
-                    <a:lstStyle/>
-                    <a:p/>
-                  </a:txBody>
-                  <a:tcPr>
                     <a:lnL w="6350" cap="flat" cmpd="sng" algn="ctr">
                       <a:solidFill>
                         <a:srgbClr val="E8C4C8"/>
@@ -4383,272 +4359,272 @@
                           </a:solidFill>
                           <a:latin typeface="Calibri"/>
                         </a:rPr>
+                        <a:t>05.27</a:t>
+                      </a:r>
+                    </a:p>
+                  </a:txBody>
+                  <a:tcPr anchor="ctr" marL="25400" marR="25400" marT="12700" marB="12700">
+                    <a:solidFill>
+                      <a:srgbClr val="570C17"/>
+                    </a:solidFill>
+                    <a:lnL w="6350" cap="flat" cmpd="sng" algn="ctr">
+                      <a:solidFill>
+                        <a:srgbClr val="E8C4C8"/>
+                      </a:solidFill>
+                    </a:lnL>
+                    <a:lnR w="6350" cap="flat" cmpd="sng" algn="ctr">
+                      <a:solidFill>
+                        <a:srgbClr val="E8C4C8"/>
+                      </a:solidFill>
+                    </a:lnR>
+                    <a:lnT w="6350" cap="flat" cmpd="sng" algn="ctr">
+                      <a:solidFill>
+                        <a:srgbClr val="E8C4C8"/>
+                      </a:solidFill>
+                    </a:lnT>
+                    <a:lnB w="6350" cap="flat" cmpd="sng" algn="ctr">
+                      <a:solidFill>
+                        <a:srgbClr val="E8C4C8"/>
+                      </a:solidFill>
+                    </a:lnB>
+                  </a:tcPr>
+                </a:tc>
+                <a:tc>
+                  <a:txBody>
+                    <a:bodyPr wrap="square"/>
+                    <a:lstStyle/>
+                    <a:p>
+                      <a:pPr algn="ctr">
+                        <a:lnSpc>
+                          <a:spcPct val="100000"/>
+                        </a:lnSpc>
+                        <a:spcBef>
+                          <a:spcPts val="0"/>
+                        </a:spcBef>
+                        <a:spcAft>
+                          <a:spcPts val="0"/>
+                        </a:spcAft>
+                      </a:pPr>
+                      <a:r>
+                        <a:rPr sz="600" b="1">
+                          <a:solidFill>
+                            <a:srgbClr val="FFFFFF"/>
+                          </a:solidFill>
+                          <a:latin typeface="Calibri"/>
+                        </a:rPr>
+                        <a:t>06.27</a:t>
+                      </a:r>
+                    </a:p>
+                  </a:txBody>
+                  <a:tcPr anchor="ctr" marL="25400" marR="25400" marT="12700" marB="12700">
+                    <a:solidFill>
+                      <a:srgbClr val="570C17"/>
+                    </a:solidFill>
+                    <a:lnL w="6350" cap="flat" cmpd="sng" algn="ctr">
+                      <a:solidFill>
+                        <a:srgbClr val="E8C4C8"/>
+                      </a:solidFill>
+                    </a:lnL>
+                    <a:lnR w="6350" cap="flat" cmpd="sng" algn="ctr">
+                      <a:solidFill>
+                        <a:srgbClr val="E8C4C8"/>
+                      </a:solidFill>
+                    </a:lnR>
+                    <a:lnT w="6350" cap="flat" cmpd="sng" algn="ctr">
+                      <a:solidFill>
+                        <a:srgbClr val="E8C4C8"/>
+                      </a:solidFill>
+                    </a:lnT>
+                    <a:lnB w="6350" cap="flat" cmpd="sng" algn="ctr">
+                      <a:solidFill>
+                        <a:srgbClr val="E8C4C8"/>
+                      </a:solidFill>
+                    </a:lnB>
+                  </a:tcPr>
+                </a:tc>
+                <a:tc>
+                  <a:txBody>
+                    <a:bodyPr wrap="square"/>
+                    <a:lstStyle/>
+                    <a:p>
+                      <a:pPr algn="ctr">
+                        <a:lnSpc>
+                          <a:spcPct val="100000"/>
+                        </a:lnSpc>
+                        <a:spcBef>
+                          <a:spcPts val="0"/>
+                        </a:spcBef>
+                        <a:spcAft>
+                          <a:spcPts val="0"/>
+                        </a:spcAft>
+                      </a:pPr>
+                      <a:r>
+                        <a:rPr sz="600" b="1">
+                          <a:solidFill>
+                            <a:srgbClr val="FFFFFF"/>
+                          </a:solidFill>
+                          <a:latin typeface="Calibri"/>
+                        </a:rPr>
+                        <a:t>07.27</a:t>
+                      </a:r>
+                    </a:p>
+                  </a:txBody>
+                  <a:tcPr anchor="ctr" marL="25400" marR="25400" marT="12700" marB="12700">
+                    <a:solidFill>
+                      <a:srgbClr val="570C17"/>
+                    </a:solidFill>
+                    <a:lnL w="6350" cap="flat" cmpd="sng" algn="ctr">
+                      <a:solidFill>
+                        <a:srgbClr val="E8C4C8"/>
+                      </a:solidFill>
+                    </a:lnL>
+                    <a:lnR w="6350" cap="flat" cmpd="sng" algn="ctr">
+                      <a:solidFill>
+                        <a:srgbClr val="E8C4C8"/>
+                      </a:solidFill>
+                    </a:lnR>
+                    <a:lnT w="6350" cap="flat" cmpd="sng" algn="ctr">
+                      <a:solidFill>
+                        <a:srgbClr val="E8C4C8"/>
+                      </a:solidFill>
+                    </a:lnT>
+                    <a:lnB w="6350" cap="flat" cmpd="sng" algn="ctr">
+                      <a:solidFill>
+                        <a:srgbClr val="E8C4C8"/>
+                      </a:solidFill>
+                    </a:lnB>
+                  </a:tcPr>
+                </a:tc>
+                <a:tc>
+                  <a:txBody>
+                    <a:bodyPr wrap="square"/>
+                    <a:lstStyle/>
+                    <a:p>
+                      <a:pPr algn="ctr">
+                        <a:lnSpc>
+                          <a:spcPct val="100000"/>
+                        </a:lnSpc>
+                        <a:spcBef>
+                          <a:spcPts val="0"/>
+                        </a:spcBef>
+                        <a:spcAft>
+                          <a:spcPts val="0"/>
+                        </a:spcAft>
+                      </a:pPr>
+                      <a:r>
+                        <a:rPr sz="600" b="1">
+                          <a:solidFill>
+                            <a:srgbClr val="FFFFFF"/>
+                          </a:solidFill>
+                          <a:latin typeface="Calibri"/>
+                        </a:rPr>
+                        <a:t>08.27</a:t>
+                      </a:r>
+                    </a:p>
+                  </a:txBody>
+                  <a:tcPr anchor="ctr" marL="25400" marR="25400" marT="12700" marB="12700">
+                    <a:solidFill>
+                      <a:srgbClr val="570C17"/>
+                    </a:solidFill>
+                    <a:lnL w="6350" cap="flat" cmpd="sng" algn="ctr">
+                      <a:solidFill>
+                        <a:srgbClr val="E8C4C8"/>
+                      </a:solidFill>
+                    </a:lnL>
+                    <a:lnR w="6350" cap="flat" cmpd="sng" algn="ctr">
+                      <a:solidFill>
+                        <a:srgbClr val="E8C4C8"/>
+                      </a:solidFill>
+                    </a:lnR>
+                    <a:lnT w="6350" cap="flat" cmpd="sng" algn="ctr">
+                      <a:solidFill>
+                        <a:srgbClr val="E8C4C8"/>
+                      </a:solidFill>
+                    </a:lnT>
+                    <a:lnB w="6350" cap="flat" cmpd="sng" algn="ctr">
+                      <a:solidFill>
+                        <a:srgbClr val="E8C4C8"/>
+                      </a:solidFill>
+                    </a:lnB>
+                  </a:tcPr>
+                </a:tc>
+                <a:tc>
+                  <a:txBody>
+                    <a:bodyPr wrap="square"/>
+                    <a:lstStyle/>
+                    <a:p>
+                      <a:pPr algn="ctr">
+                        <a:lnSpc>
+                          <a:spcPct val="100000"/>
+                        </a:lnSpc>
+                        <a:spcBef>
+                          <a:spcPts val="0"/>
+                        </a:spcBef>
+                        <a:spcAft>
+                          <a:spcPts val="0"/>
+                        </a:spcAft>
+                      </a:pPr>
+                      <a:r>
+                        <a:rPr sz="600" b="1">
+                          <a:solidFill>
+                            <a:srgbClr val="FFFFFF"/>
+                          </a:solidFill>
+                          <a:latin typeface="Calibri"/>
+                        </a:rPr>
+                        <a:t>09.27</a:t>
+                      </a:r>
+                    </a:p>
+                  </a:txBody>
+                  <a:tcPr anchor="ctr" marL="25400" marR="25400" marT="12700" marB="12700">
+                    <a:solidFill>
+                      <a:srgbClr val="570C17"/>
+                    </a:solidFill>
+                    <a:lnL w="6350" cap="flat" cmpd="sng" algn="ctr">
+                      <a:solidFill>
+                        <a:srgbClr val="E8C4C8"/>
+                      </a:solidFill>
+                    </a:lnL>
+                    <a:lnR w="6350" cap="flat" cmpd="sng" algn="ctr">
+                      <a:solidFill>
+                        <a:srgbClr val="E8C4C8"/>
+                      </a:solidFill>
+                    </a:lnR>
+                    <a:lnT w="6350" cap="flat" cmpd="sng" algn="ctr">
+                      <a:solidFill>
+                        <a:srgbClr val="E8C4C8"/>
+                      </a:solidFill>
+                    </a:lnT>
+                    <a:lnB w="6350" cap="flat" cmpd="sng" algn="ctr">
+                      <a:solidFill>
+                        <a:srgbClr val="E8C4C8"/>
+                      </a:solidFill>
+                    </a:lnB>
+                  </a:tcPr>
+                </a:tc>
+                <a:tc>
+                  <a:txBody>
+                    <a:bodyPr wrap="square"/>
+                    <a:lstStyle/>
+                    <a:p>
+                      <a:pPr algn="ctr">
+                        <a:lnSpc>
+                          <a:spcPct val="100000"/>
+                        </a:lnSpc>
+                        <a:spcBef>
+                          <a:spcPts val="0"/>
+                        </a:spcBef>
+                        <a:spcAft>
+                          <a:spcPts val="0"/>
+                        </a:spcAft>
+                      </a:pPr>
+                      <a:r>
+                        <a:rPr sz="600" b="1">
+                          <a:solidFill>
+                            <a:srgbClr val="FFFFFF"/>
+                          </a:solidFill>
+                          <a:latin typeface="Calibri"/>
+                        </a:rPr>
                         <a:t>04.28</a:t>
-                      </a:r>
-                    </a:p>
-                  </a:txBody>
-                  <a:tcPr anchor="ctr" marL="25400" marR="25400" marT="12700" marB="12700">
-                    <a:solidFill>
-                      <a:srgbClr val="570C17"/>
-                    </a:solidFill>
-                    <a:lnL w="6350" cap="flat" cmpd="sng" algn="ctr">
-                      <a:solidFill>
-                        <a:srgbClr val="E8C4C8"/>
-                      </a:solidFill>
-                    </a:lnL>
-                    <a:lnR w="6350" cap="flat" cmpd="sng" algn="ctr">
-                      <a:solidFill>
-                        <a:srgbClr val="E8C4C8"/>
-                      </a:solidFill>
-                    </a:lnR>
-                    <a:lnT w="6350" cap="flat" cmpd="sng" algn="ctr">
-                      <a:solidFill>
-                        <a:srgbClr val="E8C4C8"/>
-                      </a:solidFill>
-                    </a:lnT>
-                    <a:lnB w="6350" cap="flat" cmpd="sng" algn="ctr">
-                      <a:solidFill>
-                        <a:srgbClr val="E8C4C8"/>
-                      </a:solidFill>
-                    </a:lnB>
-                  </a:tcPr>
-                </a:tc>
-                <a:tc>
-                  <a:txBody>
-                    <a:bodyPr wrap="square"/>
-                    <a:lstStyle/>
-                    <a:p>
-                      <a:pPr algn="ctr">
-                        <a:lnSpc>
-                          <a:spcPct val="100000"/>
-                        </a:lnSpc>
-                        <a:spcBef>
-                          <a:spcPts val="0"/>
-                        </a:spcBef>
-                        <a:spcAft>
-                          <a:spcPts val="0"/>
-                        </a:spcAft>
-                      </a:pPr>
-                      <a:r>
-                        <a:rPr sz="600" b="1">
-                          <a:solidFill>
-                            <a:srgbClr val="FFFFFF"/>
-                          </a:solidFill>
-                          <a:latin typeface="Calibri"/>
-                        </a:rPr>
-                        <a:t>05.27</a:t>
-                      </a:r>
-                    </a:p>
-                  </a:txBody>
-                  <a:tcPr anchor="ctr" marL="25400" marR="25400" marT="12700" marB="12700">
-                    <a:solidFill>
-                      <a:srgbClr val="570C17"/>
-                    </a:solidFill>
-                    <a:lnL w="6350" cap="flat" cmpd="sng" algn="ctr">
-                      <a:solidFill>
-                        <a:srgbClr val="E8C4C8"/>
-                      </a:solidFill>
-                    </a:lnL>
-                    <a:lnR w="6350" cap="flat" cmpd="sng" algn="ctr">
-                      <a:solidFill>
-                        <a:srgbClr val="E8C4C8"/>
-                      </a:solidFill>
-                    </a:lnR>
-                    <a:lnT w="6350" cap="flat" cmpd="sng" algn="ctr">
-                      <a:solidFill>
-                        <a:srgbClr val="E8C4C8"/>
-                      </a:solidFill>
-                    </a:lnT>
-                    <a:lnB w="6350" cap="flat" cmpd="sng" algn="ctr">
-                      <a:solidFill>
-                        <a:srgbClr val="E8C4C8"/>
-                      </a:solidFill>
-                    </a:lnB>
-                  </a:tcPr>
-                </a:tc>
-                <a:tc>
-                  <a:txBody>
-                    <a:bodyPr wrap="square"/>
-                    <a:lstStyle/>
-                    <a:p>
-                      <a:pPr algn="ctr">
-                        <a:lnSpc>
-                          <a:spcPct val="100000"/>
-                        </a:lnSpc>
-                        <a:spcBef>
-                          <a:spcPts val="0"/>
-                        </a:spcBef>
-                        <a:spcAft>
-                          <a:spcPts val="0"/>
-                        </a:spcAft>
-                      </a:pPr>
-                      <a:r>
-                        <a:rPr sz="600" b="1">
-                          <a:solidFill>
-                            <a:srgbClr val="FFFFFF"/>
-                          </a:solidFill>
-                          <a:latin typeface="Calibri"/>
-                        </a:rPr>
-                        <a:t>06.27</a:t>
-                      </a:r>
-                    </a:p>
-                  </a:txBody>
-                  <a:tcPr anchor="ctr" marL="25400" marR="25400" marT="12700" marB="12700">
-                    <a:solidFill>
-                      <a:srgbClr val="570C17"/>
-                    </a:solidFill>
-                    <a:lnL w="6350" cap="flat" cmpd="sng" algn="ctr">
-                      <a:solidFill>
-                        <a:srgbClr val="E8C4C8"/>
-                      </a:solidFill>
-                    </a:lnL>
-                    <a:lnR w="6350" cap="flat" cmpd="sng" algn="ctr">
-                      <a:solidFill>
-                        <a:srgbClr val="E8C4C8"/>
-                      </a:solidFill>
-                    </a:lnR>
-                    <a:lnT w="6350" cap="flat" cmpd="sng" algn="ctr">
-                      <a:solidFill>
-                        <a:srgbClr val="E8C4C8"/>
-                      </a:solidFill>
-                    </a:lnT>
-                    <a:lnB w="6350" cap="flat" cmpd="sng" algn="ctr">
-                      <a:solidFill>
-                        <a:srgbClr val="E8C4C8"/>
-                      </a:solidFill>
-                    </a:lnB>
-                  </a:tcPr>
-                </a:tc>
-                <a:tc>
-                  <a:txBody>
-                    <a:bodyPr wrap="square"/>
-                    <a:lstStyle/>
-                    <a:p>
-                      <a:pPr algn="ctr">
-                        <a:lnSpc>
-                          <a:spcPct val="100000"/>
-                        </a:lnSpc>
-                        <a:spcBef>
-                          <a:spcPts val="0"/>
-                        </a:spcBef>
-                        <a:spcAft>
-                          <a:spcPts val="0"/>
-                        </a:spcAft>
-                      </a:pPr>
-                      <a:r>
-                        <a:rPr sz="600" b="1">
-                          <a:solidFill>
-                            <a:srgbClr val="FFFFFF"/>
-                          </a:solidFill>
-                          <a:latin typeface="Calibri"/>
-                        </a:rPr>
-                        <a:t>07.27</a:t>
-                      </a:r>
-                    </a:p>
-                  </a:txBody>
-                  <a:tcPr anchor="ctr" marL="25400" marR="25400" marT="12700" marB="12700">
-                    <a:solidFill>
-                      <a:srgbClr val="570C17"/>
-                    </a:solidFill>
-                    <a:lnL w="6350" cap="flat" cmpd="sng" algn="ctr">
-                      <a:solidFill>
-                        <a:srgbClr val="E8C4C8"/>
-                      </a:solidFill>
-                    </a:lnL>
-                    <a:lnR w="6350" cap="flat" cmpd="sng" algn="ctr">
-                      <a:solidFill>
-                        <a:srgbClr val="E8C4C8"/>
-                      </a:solidFill>
-                    </a:lnR>
-                    <a:lnT w="6350" cap="flat" cmpd="sng" algn="ctr">
-                      <a:solidFill>
-                        <a:srgbClr val="E8C4C8"/>
-                      </a:solidFill>
-                    </a:lnT>
-                    <a:lnB w="6350" cap="flat" cmpd="sng" algn="ctr">
-                      <a:solidFill>
-                        <a:srgbClr val="E8C4C8"/>
-                      </a:solidFill>
-                    </a:lnB>
-                  </a:tcPr>
-                </a:tc>
-                <a:tc>
-                  <a:txBody>
-                    <a:bodyPr wrap="square"/>
-                    <a:lstStyle/>
-                    <a:p>
-                      <a:pPr algn="ctr">
-                        <a:lnSpc>
-                          <a:spcPct val="100000"/>
-                        </a:lnSpc>
-                        <a:spcBef>
-                          <a:spcPts val="0"/>
-                        </a:spcBef>
-                        <a:spcAft>
-                          <a:spcPts val="0"/>
-                        </a:spcAft>
-                      </a:pPr>
-                      <a:r>
-                        <a:rPr sz="600" b="1">
-                          <a:solidFill>
-                            <a:srgbClr val="FFFFFF"/>
-                          </a:solidFill>
-                          <a:latin typeface="Calibri"/>
-                        </a:rPr>
-                        <a:t>08.27</a:t>
-                      </a:r>
-                    </a:p>
-                  </a:txBody>
-                  <a:tcPr anchor="ctr" marL="25400" marR="25400" marT="12700" marB="12700">
-                    <a:solidFill>
-                      <a:srgbClr val="570C17"/>
-                    </a:solidFill>
-                    <a:lnL w="6350" cap="flat" cmpd="sng" algn="ctr">
-                      <a:solidFill>
-                        <a:srgbClr val="E8C4C8"/>
-                      </a:solidFill>
-                    </a:lnL>
-                    <a:lnR w="6350" cap="flat" cmpd="sng" algn="ctr">
-                      <a:solidFill>
-                        <a:srgbClr val="E8C4C8"/>
-                      </a:solidFill>
-                    </a:lnR>
-                    <a:lnT w="6350" cap="flat" cmpd="sng" algn="ctr">
-                      <a:solidFill>
-                        <a:srgbClr val="E8C4C8"/>
-                      </a:solidFill>
-                    </a:lnT>
-                    <a:lnB w="6350" cap="flat" cmpd="sng" algn="ctr">
-                      <a:solidFill>
-                        <a:srgbClr val="E8C4C8"/>
-                      </a:solidFill>
-                    </a:lnB>
-                  </a:tcPr>
-                </a:tc>
-                <a:tc>
-                  <a:txBody>
-                    <a:bodyPr wrap="square"/>
-                    <a:lstStyle/>
-                    <a:p>
-                      <a:pPr algn="ctr">
-                        <a:lnSpc>
-                          <a:spcPct val="100000"/>
-                        </a:lnSpc>
-                        <a:spcBef>
-                          <a:spcPts val="0"/>
-                        </a:spcBef>
-                        <a:spcAft>
-                          <a:spcPts val="0"/>
-                        </a:spcAft>
-                      </a:pPr>
-                      <a:r>
-                        <a:rPr sz="600" b="1">
-                          <a:solidFill>
-                            <a:srgbClr val="FFFFFF"/>
-                          </a:solidFill>
-                          <a:latin typeface="Calibri"/>
-                        </a:rPr>
-                        <a:t>09.27</a:t>
                       </a:r>
                     </a:p>
                   </a:txBody>
@@ -7094,6 +7070,271 @@
                           </a:solidFill>
                           <a:latin typeface="Calibri"/>
                         </a:rPr>
+                        <a:t>ППК Тюмень</a:t>
+                      </a:r>
+                    </a:p>
+                  </a:txBody>
+                  <a:tcPr anchor="ctr" marL="25400" marR="25400" marT="12700" marB="12700">
+                    <a:solidFill>
+                      <a:srgbClr val="FFD2D8"/>
+                    </a:solidFill>
+                    <a:lnL w="6350" cap="flat" cmpd="sng" algn="ctr">
+                      <a:solidFill>
+                        <a:srgbClr val="E8C4C8"/>
+                      </a:solidFill>
+                    </a:lnL>
+                    <a:lnR w="6350" cap="flat" cmpd="sng" algn="ctr">
+                      <a:solidFill>
+                        <a:srgbClr val="E8C4C8"/>
+                      </a:solidFill>
+                    </a:lnR>
+                    <a:lnT w="6350" cap="flat" cmpd="sng" algn="ctr">
+                      <a:solidFill>
+                        <a:srgbClr val="E8C4C8"/>
+                      </a:solidFill>
+                    </a:lnT>
+                    <a:lnB w="6350" cap="flat" cmpd="sng" algn="ctr">
+                      <a:solidFill>
+                        <a:srgbClr val="E8C4C8"/>
+                      </a:solidFill>
+                    </a:lnB>
+                  </a:tcPr>
+                </a:tc>
+                <a:tc>
+                  <a:txBody>
+                    <a:bodyPr wrap="square"/>
+                    <a:lstStyle/>
+                    <a:p>
+                      <a:pPr algn="ctr">
+                        <a:lnSpc>
+                          <a:spcPct val="100000"/>
+                        </a:lnSpc>
+                        <a:spcBef>
+                          <a:spcPts val="0"/>
+                        </a:spcBef>
+                        <a:spcAft>
+                          <a:spcPts val="0"/>
+                        </a:spcAft>
+                      </a:pPr>
+                      <a:r>
+                        <a:rPr sz="500" b="0">
+                          <a:solidFill>
+                            <a:srgbClr val="962837"/>
+                          </a:solidFill>
+                          <a:latin typeface="Calibri"/>
+                        </a:rPr>
+                        <a:t>ППК Москва МСП</a:t>
+                      </a:r>
+                    </a:p>
+                  </a:txBody>
+                  <a:tcPr anchor="ctr" marL="25400" marR="25400" marT="12700" marB="12700">
+                    <a:solidFill>
+                      <a:srgbClr val="FFD2D8"/>
+                    </a:solidFill>
+                    <a:lnL w="6350" cap="flat" cmpd="sng" algn="ctr">
+                      <a:solidFill>
+                        <a:srgbClr val="E8C4C8"/>
+                      </a:solidFill>
+                    </a:lnL>
+                    <a:lnR w="6350" cap="flat" cmpd="sng" algn="ctr">
+                      <a:solidFill>
+                        <a:srgbClr val="E8C4C8"/>
+                      </a:solidFill>
+                    </a:lnR>
+                    <a:lnT w="6350" cap="flat" cmpd="sng" algn="ctr">
+                      <a:solidFill>
+                        <a:srgbClr val="E8C4C8"/>
+                      </a:solidFill>
+                    </a:lnT>
+                    <a:lnB w="6350" cap="flat" cmpd="sng" algn="ctr">
+                      <a:solidFill>
+                        <a:srgbClr val="E8C4C8"/>
+                      </a:solidFill>
+                    </a:lnB>
+                  </a:tcPr>
+                </a:tc>
+                <a:tc>
+                  <a:txBody>
+                    <a:bodyPr wrap="square"/>
+                    <a:lstStyle/>
+                    <a:p>
+                      <a:pPr algn="l">
+                        <a:lnSpc>
+                          <a:spcPct val="100000"/>
+                        </a:lnSpc>
+                        <a:spcBef>
+                          <a:spcPts val="0"/>
+                        </a:spcBef>
+                        <a:spcAft>
+                          <a:spcPts val="0"/>
+                        </a:spcAft>
+                      </a:pPr>
+                      <a:r>
+                        <a:rPr sz="500" b="0">
+                          <a:solidFill>
+                            <a:srgbClr val="323232"/>
+                          </a:solidFill>
+                          <a:latin typeface="Calibri"/>
+                        </a:rPr>
+                        <a:t/>
+                      </a:r>
+                    </a:p>
+                  </a:txBody>
+                  <a:tcPr anchor="ctr" marL="25400" marR="25400" marT="12700" marB="12700">
+                    <a:solidFill>
+                      <a:srgbClr val="FFFFFF"/>
+                    </a:solidFill>
+                    <a:lnL w="6350" cap="flat" cmpd="sng" algn="ctr">
+                      <a:solidFill>
+                        <a:srgbClr val="E8C4C8"/>
+                      </a:solidFill>
+                    </a:lnL>
+                    <a:lnR w="6350" cap="flat" cmpd="sng" algn="ctr">
+                      <a:solidFill>
+                        <a:srgbClr val="E8C4C8"/>
+                      </a:solidFill>
+                    </a:lnR>
+                    <a:lnT w="6350" cap="flat" cmpd="sng" algn="ctr">
+                      <a:solidFill>
+                        <a:srgbClr val="E8C4C8"/>
+                      </a:solidFill>
+                    </a:lnT>
+                    <a:lnB w="6350" cap="flat" cmpd="sng" algn="ctr">
+                      <a:solidFill>
+                        <a:srgbClr val="E8C4C8"/>
+                      </a:solidFill>
+                    </a:lnB>
+                  </a:tcPr>
+                </a:tc>
+                <a:tc>
+                  <a:txBody>
+                    <a:bodyPr wrap="square"/>
+                    <a:lstStyle/>
+                    <a:p>
+                      <a:pPr algn="ctr">
+                        <a:lnSpc>
+                          <a:spcPct val="100000"/>
+                        </a:lnSpc>
+                        <a:spcBef>
+                          <a:spcPts val="0"/>
+                        </a:spcBef>
+                        <a:spcAft>
+                          <a:spcPts val="0"/>
+                        </a:spcAft>
+                      </a:pPr>
+                      <a:r>
+                        <a:rPr sz="500" b="0">
+                          <a:solidFill>
+                            <a:srgbClr val="962837"/>
+                          </a:solidFill>
+                          <a:latin typeface="Calibri"/>
+                        </a:rPr>
+                        <a:t>КЦ</a:t>
+                      </a:r>
+                    </a:p>
+                  </a:txBody>
+                  <a:tcPr anchor="ctr" marL="25400" marR="25400" marT="12700" marB="12700">
+                    <a:solidFill>
+                      <a:srgbClr val="FFD2D8"/>
+                    </a:solidFill>
+                    <a:lnL w="6350" cap="flat" cmpd="sng" algn="ctr">
+                      <a:solidFill>
+                        <a:srgbClr val="E8C4C8"/>
+                      </a:solidFill>
+                    </a:lnL>
+                    <a:lnR w="6350" cap="flat" cmpd="sng" algn="ctr">
+                      <a:solidFill>
+                        <a:srgbClr val="E8C4C8"/>
+                      </a:solidFill>
+                    </a:lnR>
+                    <a:lnT w="6350" cap="flat" cmpd="sng" algn="ctr">
+                      <a:solidFill>
+                        <a:srgbClr val="E8C4C8"/>
+                      </a:solidFill>
+                    </a:lnT>
+                    <a:lnB w="6350" cap="flat" cmpd="sng" algn="ctr">
+                      <a:solidFill>
+                        <a:srgbClr val="E8C4C8"/>
+                      </a:solidFill>
+                    </a:lnB>
+                  </a:tcPr>
+                </a:tc>
+                <a:tc>
+                  <a:txBody>
+                    <a:bodyPr wrap="square"/>
+                    <a:lstStyle/>
+                    <a:p>
+                      <a:pPr algn="l">
+                        <a:lnSpc>
+                          <a:spcPct val="100000"/>
+                        </a:lnSpc>
+                        <a:spcBef>
+                          <a:spcPts val="0"/>
+                        </a:spcBef>
+                        <a:spcAft>
+                          <a:spcPts val="0"/>
+                        </a:spcAft>
+                      </a:pPr>
+                      <a:r>
+                        <a:rPr sz="500" b="0">
+                          <a:solidFill>
+                            <a:srgbClr val="323232"/>
+                          </a:solidFill>
+                          <a:latin typeface="Calibri"/>
+                        </a:rPr>
+                        <a:t/>
+                      </a:r>
+                    </a:p>
+                  </a:txBody>
+                  <a:tcPr anchor="ctr" marL="25400" marR="25400" marT="12700" marB="12700">
+                    <a:solidFill>
+                      <a:srgbClr val="FFFFFF"/>
+                    </a:solidFill>
+                    <a:lnL w="6350" cap="flat" cmpd="sng" algn="ctr">
+                      <a:solidFill>
+                        <a:srgbClr val="E8C4C8"/>
+                      </a:solidFill>
+                    </a:lnL>
+                    <a:lnR w="6350" cap="flat" cmpd="sng" algn="ctr">
+                      <a:solidFill>
+                        <a:srgbClr val="E8C4C8"/>
+                      </a:solidFill>
+                    </a:lnR>
+                    <a:lnT w="6350" cap="flat" cmpd="sng" algn="ctr">
+                      <a:solidFill>
+                        <a:srgbClr val="E8C4C8"/>
+                      </a:solidFill>
+                    </a:lnT>
+                    <a:lnB w="6350" cap="flat" cmpd="sng" algn="ctr">
+                      <a:solidFill>
+                        <a:srgbClr val="E8C4C8"/>
+                      </a:solidFill>
+                    </a:lnB>
+                  </a:tcPr>
+                </a:tc>
+                <a:tc>
+                  <a:txBody>
+                    <a:bodyPr wrap="square"/>
+                    <a:lstStyle/>
+                    <a:p>
+                      <a:pPr algn="ctr">
+                        <a:lnSpc>
+                          <a:spcPct val="100000"/>
+                        </a:lnSpc>
+                        <a:spcBef>
+                          <a:spcPts val="0"/>
+                        </a:spcBef>
+                        <a:spcAft>
+                          <a:spcPts val="0"/>
+                        </a:spcAft>
+                      </a:pPr>
+                      <a:r>
+                        <a:rPr sz="500" b="0">
+                          <a:solidFill>
+                            <a:srgbClr val="962837"/>
+                          </a:solidFill>
+                          <a:latin typeface="Calibri"/>
+                        </a:rPr>
                         <a:t>Честный знак</a:t>
                       </a:r>
                     </a:p>
@@ -7101,271 +7342,6 @@
                   <a:tcPr anchor="ctr" marL="25400" marR="25400" marT="12700" marB="12700">
                     <a:solidFill>
                       <a:srgbClr val="FFD2D8"/>
-                    </a:solidFill>
-                    <a:lnL w="6350" cap="flat" cmpd="sng" algn="ctr">
-                      <a:solidFill>
-                        <a:srgbClr val="E8C4C8"/>
-                      </a:solidFill>
-                    </a:lnL>
-                    <a:lnR w="6350" cap="flat" cmpd="sng" algn="ctr">
-                      <a:solidFill>
-                        <a:srgbClr val="E8C4C8"/>
-                      </a:solidFill>
-                    </a:lnR>
-                    <a:lnT w="6350" cap="flat" cmpd="sng" algn="ctr">
-                      <a:solidFill>
-                        <a:srgbClr val="E8C4C8"/>
-                      </a:solidFill>
-                    </a:lnT>
-                    <a:lnB w="6350" cap="flat" cmpd="sng" algn="ctr">
-                      <a:solidFill>
-                        <a:srgbClr val="E8C4C8"/>
-                      </a:solidFill>
-                    </a:lnB>
-                  </a:tcPr>
-                </a:tc>
-                <a:tc>
-                  <a:txBody>
-                    <a:bodyPr wrap="square"/>
-                    <a:lstStyle/>
-                    <a:p>
-                      <a:pPr algn="ctr">
-                        <a:lnSpc>
-                          <a:spcPct val="100000"/>
-                        </a:lnSpc>
-                        <a:spcBef>
-                          <a:spcPts val="0"/>
-                        </a:spcBef>
-                        <a:spcAft>
-                          <a:spcPts val="0"/>
-                        </a:spcAft>
-                      </a:pPr>
-                      <a:r>
-                        <a:rPr sz="500" b="0">
-                          <a:solidFill>
-                            <a:srgbClr val="962837"/>
-                          </a:solidFill>
-                          <a:latin typeface="Calibri"/>
-                        </a:rPr>
-                        <a:t>ППК Тюмень</a:t>
-                      </a:r>
-                    </a:p>
-                  </a:txBody>
-                  <a:tcPr anchor="ctr" marL="25400" marR="25400" marT="12700" marB="12700">
-                    <a:solidFill>
-                      <a:srgbClr val="FFD2D8"/>
-                    </a:solidFill>
-                    <a:lnL w="6350" cap="flat" cmpd="sng" algn="ctr">
-                      <a:solidFill>
-                        <a:srgbClr val="E8C4C8"/>
-                      </a:solidFill>
-                    </a:lnL>
-                    <a:lnR w="6350" cap="flat" cmpd="sng" algn="ctr">
-                      <a:solidFill>
-                        <a:srgbClr val="E8C4C8"/>
-                      </a:solidFill>
-                    </a:lnR>
-                    <a:lnT w="6350" cap="flat" cmpd="sng" algn="ctr">
-                      <a:solidFill>
-                        <a:srgbClr val="E8C4C8"/>
-                      </a:solidFill>
-                    </a:lnT>
-                    <a:lnB w="6350" cap="flat" cmpd="sng" algn="ctr">
-                      <a:solidFill>
-                        <a:srgbClr val="E8C4C8"/>
-                      </a:solidFill>
-                    </a:lnB>
-                  </a:tcPr>
-                </a:tc>
-                <a:tc>
-                  <a:txBody>
-                    <a:bodyPr wrap="square"/>
-                    <a:lstStyle/>
-                    <a:p>
-                      <a:pPr algn="ctr">
-                        <a:lnSpc>
-                          <a:spcPct val="100000"/>
-                        </a:lnSpc>
-                        <a:spcBef>
-                          <a:spcPts val="0"/>
-                        </a:spcBef>
-                        <a:spcAft>
-                          <a:spcPts val="0"/>
-                        </a:spcAft>
-                      </a:pPr>
-                      <a:r>
-                        <a:rPr sz="500" b="0">
-                          <a:solidFill>
-                            <a:srgbClr val="962837"/>
-                          </a:solidFill>
-                          <a:latin typeface="Calibri"/>
-                        </a:rPr>
-                        <a:t>ППК Москва МСП</a:t>
-                      </a:r>
-                    </a:p>
-                  </a:txBody>
-                  <a:tcPr anchor="ctr" marL="25400" marR="25400" marT="12700" marB="12700">
-                    <a:solidFill>
-                      <a:srgbClr val="FFD2D8"/>
-                    </a:solidFill>
-                    <a:lnL w="6350" cap="flat" cmpd="sng" algn="ctr">
-                      <a:solidFill>
-                        <a:srgbClr val="E8C4C8"/>
-                      </a:solidFill>
-                    </a:lnL>
-                    <a:lnR w="6350" cap="flat" cmpd="sng" algn="ctr">
-                      <a:solidFill>
-                        <a:srgbClr val="E8C4C8"/>
-                      </a:solidFill>
-                    </a:lnR>
-                    <a:lnT w="6350" cap="flat" cmpd="sng" algn="ctr">
-                      <a:solidFill>
-                        <a:srgbClr val="E8C4C8"/>
-                      </a:solidFill>
-                    </a:lnT>
-                    <a:lnB w="6350" cap="flat" cmpd="sng" algn="ctr">
-                      <a:solidFill>
-                        <a:srgbClr val="E8C4C8"/>
-                      </a:solidFill>
-                    </a:lnB>
-                  </a:tcPr>
-                </a:tc>
-                <a:tc>
-                  <a:txBody>
-                    <a:bodyPr wrap="square"/>
-                    <a:lstStyle/>
-                    <a:p>
-                      <a:pPr algn="l">
-                        <a:lnSpc>
-                          <a:spcPct val="100000"/>
-                        </a:lnSpc>
-                        <a:spcBef>
-                          <a:spcPts val="0"/>
-                        </a:spcBef>
-                        <a:spcAft>
-                          <a:spcPts val="0"/>
-                        </a:spcAft>
-                      </a:pPr>
-                      <a:r>
-                        <a:rPr sz="500" b="0">
-                          <a:solidFill>
-                            <a:srgbClr val="323232"/>
-                          </a:solidFill>
-                          <a:latin typeface="Calibri"/>
-                        </a:rPr>
-                        <a:t/>
-                      </a:r>
-                    </a:p>
-                  </a:txBody>
-                  <a:tcPr anchor="ctr" marL="25400" marR="25400" marT="12700" marB="12700">
-                    <a:solidFill>
-                      <a:srgbClr val="FFFFFF"/>
-                    </a:solidFill>
-                    <a:lnL w="6350" cap="flat" cmpd="sng" algn="ctr">
-                      <a:solidFill>
-                        <a:srgbClr val="E8C4C8"/>
-                      </a:solidFill>
-                    </a:lnL>
-                    <a:lnR w="6350" cap="flat" cmpd="sng" algn="ctr">
-                      <a:solidFill>
-                        <a:srgbClr val="E8C4C8"/>
-                      </a:solidFill>
-                    </a:lnR>
-                    <a:lnT w="6350" cap="flat" cmpd="sng" algn="ctr">
-                      <a:solidFill>
-                        <a:srgbClr val="E8C4C8"/>
-                      </a:solidFill>
-                    </a:lnT>
-                    <a:lnB w="6350" cap="flat" cmpd="sng" algn="ctr">
-                      <a:solidFill>
-                        <a:srgbClr val="E8C4C8"/>
-                      </a:solidFill>
-                    </a:lnB>
-                  </a:tcPr>
-                </a:tc>
-                <a:tc>
-                  <a:txBody>
-                    <a:bodyPr wrap="square"/>
-                    <a:lstStyle/>
-                    <a:p>
-                      <a:pPr algn="ctr">
-                        <a:lnSpc>
-                          <a:spcPct val="100000"/>
-                        </a:lnSpc>
-                        <a:spcBef>
-                          <a:spcPts val="0"/>
-                        </a:spcBef>
-                        <a:spcAft>
-                          <a:spcPts val="0"/>
-                        </a:spcAft>
-                      </a:pPr>
-                      <a:r>
-                        <a:rPr sz="500" b="0">
-                          <a:solidFill>
-                            <a:srgbClr val="962837"/>
-                          </a:solidFill>
-                          <a:latin typeface="Calibri"/>
-                        </a:rPr>
-                        <a:t>КЦ</a:t>
-                      </a:r>
-                    </a:p>
-                  </a:txBody>
-                  <a:tcPr anchor="ctr" marL="25400" marR="25400" marT="12700" marB="12700">
-                    <a:solidFill>
-                      <a:srgbClr val="FFD2D8"/>
-                    </a:solidFill>
-                    <a:lnL w="6350" cap="flat" cmpd="sng" algn="ctr">
-                      <a:solidFill>
-                        <a:srgbClr val="E8C4C8"/>
-                      </a:solidFill>
-                    </a:lnL>
-                    <a:lnR w="6350" cap="flat" cmpd="sng" algn="ctr">
-                      <a:solidFill>
-                        <a:srgbClr val="E8C4C8"/>
-                      </a:solidFill>
-                    </a:lnR>
-                    <a:lnT w="6350" cap="flat" cmpd="sng" algn="ctr">
-                      <a:solidFill>
-                        <a:srgbClr val="E8C4C8"/>
-                      </a:solidFill>
-                    </a:lnT>
-                    <a:lnB w="6350" cap="flat" cmpd="sng" algn="ctr">
-                      <a:solidFill>
-                        <a:srgbClr val="E8C4C8"/>
-                      </a:solidFill>
-                    </a:lnB>
-                  </a:tcPr>
-                </a:tc>
-                <a:tc>
-                  <a:txBody>
-                    <a:bodyPr wrap="square"/>
-                    <a:lstStyle/>
-                    <a:p>
-                      <a:pPr algn="l">
-                        <a:lnSpc>
-                          <a:spcPct val="100000"/>
-                        </a:lnSpc>
-                        <a:spcBef>
-                          <a:spcPts val="0"/>
-                        </a:spcBef>
-                        <a:spcAft>
-                          <a:spcPts val="0"/>
-                        </a:spcAft>
-                      </a:pPr>
-                      <a:r>
-                        <a:rPr sz="500" b="0">
-                          <a:solidFill>
-                            <a:srgbClr val="323232"/>
-                          </a:solidFill>
-                          <a:latin typeface="Calibri"/>
-                        </a:rPr>
-                        <a:t/>
-                      </a:r>
-                    </a:p>
-                  </a:txBody>
-                  <a:tcPr anchor="ctr" marL="25400" marR="25400" marT="12700" marB="12700">
-                    <a:solidFill>
-                      <a:srgbClr val="FFFFFF"/>
                     </a:solidFill>
                     <a:lnL w="6350" cap="flat" cmpd="sng" algn="ctr">
                       <a:solidFill>
@@ -9785,6 +9761,165 @@
                     <a:bodyPr wrap="square"/>
                     <a:lstStyle/>
                     <a:p>
+                      <a:pPr algn="l">
+                        <a:lnSpc>
+                          <a:spcPct val="100000"/>
+                        </a:lnSpc>
+                        <a:spcBef>
+                          <a:spcPts val="0"/>
+                        </a:spcBef>
+                        <a:spcAft>
+                          <a:spcPts val="0"/>
+                        </a:spcAft>
+                      </a:pPr>
+                      <a:r>
+                        <a:rPr sz="500" b="0">
+                          <a:solidFill>
+                            <a:srgbClr val="323232"/>
+                          </a:solidFill>
+                          <a:latin typeface="Calibri"/>
+                        </a:rPr>
+                        <a:t/>
+                      </a:r>
+                    </a:p>
+                  </a:txBody>
+                  <a:tcPr anchor="ctr" marL="25400" marR="25400" marT="12700" marB="12700">
+                    <a:solidFill>
+                      <a:srgbClr val="FCF8F9"/>
+                    </a:solidFill>
+                    <a:lnL w="6350" cap="flat" cmpd="sng" algn="ctr">
+                      <a:solidFill>
+                        <a:srgbClr val="E8C4C8"/>
+                      </a:solidFill>
+                    </a:lnL>
+                    <a:lnR w="6350" cap="flat" cmpd="sng" algn="ctr">
+                      <a:solidFill>
+                        <a:srgbClr val="E8C4C8"/>
+                      </a:solidFill>
+                    </a:lnR>
+                    <a:lnT w="6350" cap="flat" cmpd="sng" algn="ctr">
+                      <a:solidFill>
+                        <a:srgbClr val="E8C4C8"/>
+                      </a:solidFill>
+                    </a:lnT>
+                    <a:lnB w="6350" cap="flat" cmpd="sng" algn="ctr">
+                      <a:solidFill>
+                        <a:srgbClr val="E8C4C8"/>
+                      </a:solidFill>
+                    </a:lnB>
+                  </a:tcPr>
+                </a:tc>
+                <a:tc>
+                  <a:txBody>
+                    <a:bodyPr wrap="square"/>
+                    <a:lstStyle/>
+                    <a:p>
+                      <a:pPr algn="l">
+                        <a:lnSpc>
+                          <a:spcPct val="100000"/>
+                        </a:lnSpc>
+                        <a:spcBef>
+                          <a:spcPts val="0"/>
+                        </a:spcBef>
+                        <a:spcAft>
+                          <a:spcPts val="0"/>
+                        </a:spcAft>
+                      </a:pPr>
+                      <a:r>
+                        <a:rPr sz="500" b="0">
+                          <a:solidFill>
+                            <a:srgbClr val="323232"/>
+                          </a:solidFill>
+                          <a:latin typeface="Calibri"/>
+                        </a:rPr>
+                        <a:t/>
+                      </a:r>
+                    </a:p>
+                  </a:txBody>
+                  <a:tcPr anchor="ctr" marL="25400" marR="25400" marT="12700" marB="12700">
+                    <a:solidFill>
+                      <a:srgbClr val="FCF8F9"/>
+                    </a:solidFill>
+                    <a:lnL w="6350" cap="flat" cmpd="sng" algn="ctr">
+                      <a:solidFill>
+                        <a:srgbClr val="E8C4C8"/>
+                      </a:solidFill>
+                    </a:lnL>
+                    <a:lnR w="6350" cap="flat" cmpd="sng" algn="ctr">
+                      <a:solidFill>
+                        <a:srgbClr val="E8C4C8"/>
+                      </a:solidFill>
+                    </a:lnR>
+                    <a:lnT w="6350" cap="flat" cmpd="sng" algn="ctr">
+                      <a:solidFill>
+                        <a:srgbClr val="E8C4C8"/>
+                      </a:solidFill>
+                    </a:lnT>
+                    <a:lnB w="6350" cap="flat" cmpd="sng" algn="ctr">
+                      <a:solidFill>
+                        <a:srgbClr val="E8C4C8"/>
+                      </a:solidFill>
+                    </a:lnB>
+                  </a:tcPr>
+                </a:tc>
+                <a:tc>
+                  <a:txBody>
+                    <a:bodyPr wrap="square"/>
+                    <a:lstStyle/>
+                    <a:p>
+                      <a:pPr algn="l">
+                        <a:lnSpc>
+                          <a:spcPct val="100000"/>
+                        </a:lnSpc>
+                        <a:spcBef>
+                          <a:spcPts val="0"/>
+                        </a:spcBef>
+                        <a:spcAft>
+                          <a:spcPts val="0"/>
+                        </a:spcAft>
+                      </a:pPr>
+                      <a:r>
+                        <a:rPr sz="500" b="0">
+                          <a:solidFill>
+                            <a:srgbClr val="323232"/>
+                          </a:solidFill>
+                          <a:latin typeface="Calibri"/>
+                        </a:rPr>
+                        <a:t/>
+                      </a:r>
+                    </a:p>
+                  </a:txBody>
+                  <a:tcPr anchor="ctr" marL="25400" marR="25400" marT="12700" marB="12700">
+                    <a:solidFill>
+                      <a:srgbClr val="FCF8F9"/>
+                    </a:solidFill>
+                    <a:lnL w="6350" cap="flat" cmpd="sng" algn="ctr">
+                      <a:solidFill>
+                        <a:srgbClr val="E8C4C8"/>
+                      </a:solidFill>
+                    </a:lnL>
+                    <a:lnR w="6350" cap="flat" cmpd="sng" algn="ctr">
+                      <a:solidFill>
+                        <a:srgbClr val="E8C4C8"/>
+                      </a:solidFill>
+                    </a:lnR>
+                    <a:lnT w="6350" cap="flat" cmpd="sng" algn="ctr">
+                      <a:solidFill>
+                        <a:srgbClr val="E8C4C8"/>
+                      </a:solidFill>
+                    </a:lnT>
+                    <a:lnB w="6350" cap="flat" cmpd="sng" algn="ctr">
+                      <a:solidFill>
+                        <a:srgbClr val="E8C4C8"/>
+                      </a:solidFill>
+                    </a:lnB>
+                  </a:tcPr>
+                </a:tc>
+                <a:tc>
+                  <a:txBody>
+                    <a:bodyPr wrap="square"/>
+                    <a:lstStyle/>
+                    <a:p>
                       <a:pPr algn="ctr">
                         <a:lnSpc>
                           <a:spcPct val="100000"/>
@@ -9803,6 +9938,112 @@
                           </a:solidFill>
                           <a:latin typeface="Calibri"/>
                         </a:rPr>
+                        <a:t>КЦ</a:t>
+                      </a:r>
+                    </a:p>
+                  </a:txBody>
+                  <a:tcPr anchor="ctr" marL="25400" marR="25400" marT="12700" marB="12700">
+                    <a:solidFill>
+                      <a:srgbClr val="FFD2D8"/>
+                    </a:solidFill>
+                    <a:lnL w="6350" cap="flat" cmpd="sng" algn="ctr">
+                      <a:solidFill>
+                        <a:srgbClr val="E8C4C8"/>
+                      </a:solidFill>
+                    </a:lnL>
+                    <a:lnR w="6350" cap="flat" cmpd="sng" algn="ctr">
+                      <a:solidFill>
+                        <a:srgbClr val="E8C4C8"/>
+                      </a:solidFill>
+                    </a:lnR>
+                    <a:lnT w="6350" cap="flat" cmpd="sng" algn="ctr">
+                      <a:solidFill>
+                        <a:srgbClr val="E8C4C8"/>
+                      </a:solidFill>
+                    </a:lnT>
+                    <a:lnB w="6350" cap="flat" cmpd="sng" algn="ctr">
+                      <a:solidFill>
+                        <a:srgbClr val="E8C4C8"/>
+                      </a:solidFill>
+                    </a:lnB>
+                  </a:tcPr>
+                </a:tc>
+                <a:tc>
+                  <a:txBody>
+                    <a:bodyPr wrap="square"/>
+                    <a:lstStyle/>
+                    <a:p>
+                      <a:pPr algn="l">
+                        <a:lnSpc>
+                          <a:spcPct val="100000"/>
+                        </a:lnSpc>
+                        <a:spcBef>
+                          <a:spcPts val="0"/>
+                        </a:spcBef>
+                        <a:spcAft>
+                          <a:spcPts val="0"/>
+                        </a:spcAft>
+                      </a:pPr>
+                      <a:r>
+                        <a:rPr sz="500" b="0">
+                          <a:solidFill>
+                            <a:srgbClr val="323232"/>
+                          </a:solidFill>
+                          <a:latin typeface="Calibri"/>
+                        </a:rPr>
+                        <a:t/>
+                      </a:r>
+                    </a:p>
+                  </a:txBody>
+                  <a:tcPr anchor="ctr" marL="25400" marR="25400" marT="12700" marB="12700">
+                    <a:solidFill>
+                      <a:srgbClr val="FCF8F9"/>
+                    </a:solidFill>
+                    <a:lnL w="6350" cap="flat" cmpd="sng" algn="ctr">
+                      <a:solidFill>
+                        <a:srgbClr val="E8C4C8"/>
+                      </a:solidFill>
+                    </a:lnL>
+                    <a:lnR w="6350" cap="flat" cmpd="sng" algn="ctr">
+                      <a:solidFill>
+                        <a:srgbClr val="E8C4C8"/>
+                      </a:solidFill>
+                    </a:lnR>
+                    <a:lnT w="6350" cap="flat" cmpd="sng" algn="ctr">
+                      <a:solidFill>
+                        <a:srgbClr val="E8C4C8"/>
+                      </a:solidFill>
+                    </a:lnT>
+                    <a:lnB w="6350" cap="flat" cmpd="sng" algn="ctr">
+                      <a:solidFill>
+                        <a:srgbClr val="E8C4C8"/>
+                      </a:solidFill>
+                    </a:lnB>
+                  </a:tcPr>
+                </a:tc>
+                <a:tc>
+                  <a:txBody>
+                    <a:bodyPr wrap="square"/>
+                    <a:lstStyle/>
+                    <a:p>
+                      <a:pPr algn="ctr">
+                        <a:lnSpc>
+                          <a:spcPct val="100000"/>
+                        </a:lnSpc>
+                        <a:spcBef>
+                          <a:spcPts val="0"/>
+                        </a:spcBef>
+                        <a:spcAft>
+                          <a:spcPts val="0"/>
+                        </a:spcAft>
+                      </a:pPr>
+                      <a:r>
+                        <a:rPr sz="500" b="0">
+                          <a:solidFill>
+                            <a:srgbClr val="962837"/>
+                          </a:solidFill>
+                          <a:latin typeface="Calibri"/>
+                        </a:rPr>
                         <a:t>Честный знак</a:t>
                       </a:r>
                     </a:p>
@@ -9810,271 +10051,6 @@
                   <a:tcPr anchor="ctr" marL="25400" marR="25400" marT="12700" marB="12700">
                     <a:solidFill>
                       <a:srgbClr val="FFD2D8"/>
-                    </a:solidFill>
-                    <a:lnL w="6350" cap="flat" cmpd="sng" algn="ctr">
-                      <a:solidFill>
-                        <a:srgbClr val="E8C4C8"/>
-                      </a:solidFill>
-                    </a:lnL>
-                    <a:lnR w="6350" cap="flat" cmpd="sng" algn="ctr">
-                      <a:solidFill>
-                        <a:srgbClr val="E8C4C8"/>
-                      </a:solidFill>
-                    </a:lnR>
-                    <a:lnT w="6350" cap="flat" cmpd="sng" algn="ctr">
-                      <a:solidFill>
-                        <a:srgbClr val="E8C4C8"/>
-                      </a:solidFill>
-                    </a:lnT>
-                    <a:lnB w="6350" cap="flat" cmpd="sng" algn="ctr">
-                      <a:solidFill>
-                        <a:srgbClr val="E8C4C8"/>
-                      </a:solidFill>
-                    </a:lnB>
-                  </a:tcPr>
-                </a:tc>
-                <a:tc>
-                  <a:txBody>
-                    <a:bodyPr wrap="square"/>
-                    <a:lstStyle/>
-                    <a:p>
-                      <a:pPr algn="l">
-                        <a:lnSpc>
-                          <a:spcPct val="100000"/>
-                        </a:lnSpc>
-                        <a:spcBef>
-                          <a:spcPts val="0"/>
-                        </a:spcBef>
-                        <a:spcAft>
-                          <a:spcPts val="0"/>
-                        </a:spcAft>
-                      </a:pPr>
-                      <a:r>
-                        <a:rPr sz="500" b="0">
-                          <a:solidFill>
-                            <a:srgbClr val="323232"/>
-                          </a:solidFill>
-                          <a:latin typeface="Calibri"/>
-                        </a:rPr>
-                        <a:t/>
-                      </a:r>
-                    </a:p>
-                  </a:txBody>
-                  <a:tcPr anchor="ctr" marL="25400" marR="25400" marT="12700" marB="12700">
-                    <a:solidFill>
-                      <a:srgbClr val="FCF8F9"/>
-                    </a:solidFill>
-                    <a:lnL w="6350" cap="flat" cmpd="sng" algn="ctr">
-                      <a:solidFill>
-                        <a:srgbClr val="E8C4C8"/>
-                      </a:solidFill>
-                    </a:lnL>
-                    <a:lnR w="6350" cap="flat" cmpd="sng" algn="ctr">
-                      <a:solidFill>
-                        <a:srgbClr val="E8C4C8"/>
-                      </a:solidFill>
-                    </a:lnR>
-                    <a:lnT w="6350" cap="flat" cmpd="sng" algn="ctr">
-                      <a:solidFill>
-                        <a:srgbClr val="E8C4C8"/>
-                      </a:solidFill>
-                    </a:lnT>
-                    <a:lnB w="6350" cap="flat" cmpd="sng" algn="ctr">
-                      <a:solidFill>
-                        <a:srgbClr val="E8C4C8"/>
-                      </a:solidFill>
-                    </a:lnB>
-                  </a:tcPr>
-                </a:tc>
-                <a:tc>
-                  <a:txBody>
-                    <a:bodyPr wrap="square"/>
-                    <a:lstStyle/>
-                    <a:p>
-                      <a:pPr algn="l">
-                        <a:lnSpc>
-                          <a:spcPct val="100000"/>
-                        </a:lnSpc>
-                        <a:spcBef>
-                          <a:spcPts val="0"/>
-                        </a:spcBef>
-                        <a:spcAft>
-                          <a:spcPts val="0"/>
-                        </a:spcAft>
-                      </a:pPr>
-                      <a:r>
-                        <a:rPr sz="500" b="0">
-                          <a:solidFill>
-                            <a:srgbClr val="323232"/>
-                          </a:solidFill>
-                          <a:latin typeface="Calibri"/>
-                        </a:rPr>
-                        <a:t/>
-                      </a:r>
-                    </a:p>
-                  </a:txBody>
-                  <a:tcPr anchor="ctr" marL="25400" marR="25400" marT="12700" marB="12700">
-                    <a:solidFill>
-                      <a:srgbClr val="FCF8F9"/>
-                    </a:solidFill>
-                    <a:lnL w="6350" cap="flat" cmpd="sng" algn="ctr">
-                      <a:solidFill>
-                        <a:srgbClr val="E8C4C8"/>
-                      </a:solidFill>
-                    </a:lnL>
-                    <a:lnR w="6350" cap="flat" cmpd="sng" algn="ctr">
-                      <a:solidFill>
-                        <a:srgbClr val="E8C4C8"/>
-                      </a:solidFill>
-                    </a:lnR>
-                    <a:lnT w="6350" cap="flat" cmpd="sng" algn="ctr">
-                      <a:solidFill>
-                        <a:srgbClr val="E8C4C8"/>
-                      </a:solidFill>
-                    </a:lnT>
-                    <a:lnB w="6350" cap="flat" cmpd="sng" algn="ctr">
-                      <a:solidFill>
-                        <a:srgbClr val="E8C4C8"/>
-                      </a:solidFill>
-                    </a:lnB>
-                  </a:tcPr>
-                </a:tc>
-                <a:tc>
-                  <a:txBody>
-                    <a:bodyPr wrap="square"/>
-                    <a:lstStyle/>
-                    <a:p>
-                      <a:pPr algn="l">
-                        <a:lnSpc>
-                          <a:spcPct val="100000"/>
-                        </a:lnSpc>
-                        <a:spcBef>
-                          <a:spcPts val="0"/>
-                        </a:spcBef>
-                        <a:spcAft>
-                          <a:spcPts val="0"/>
-                        </a:spcAft>
-                      </a:pPr>
-                      <a:r>
-                        <a:rPr sz="500" b="0">
-                          <a:solidFill>
-                            <a:srgbClr val="323232"/>
-                          </a:solidFill>
-                          <a:latin typeface="Calibri"/>
-                        </a:rPr>
-                        <a:t/>
-                      </a:r>
-                    </a:p>
-                  </a:txBody>
-                  <a:tcPr anchor="ctr" marL="25400" marR="25400" marT="12700" marB="12700">
-                    <a:solidFill>
-                      <a:srgbClr val="FCF8F9"/>
-                    </a:solidFill>
-                    <a:lnL w="6350" cap="flat" cmpd="sng" algn="ctr">
-                      <a:solidFill>
-                        <a:srgbClr val="E8C4C8"/>
-                      </a:solidFill>
-                    </a:lnL>
-                    <a:lnR w="6350" cap="flat" cmpd="sng" algn="ctr">
-                      <a:solidFill>
-                        <a:srgbClr val="E8C4C8"/>
-                      </a:solidFill>
-                    </a:lnR>
-                    <a:lnT w="6350" cap="flat" cmpd="sng" algn="ctr">
-                      <a:solidFill>
-                        <a:srgbClr val="E8C4C8"/>
-                      </a:solidFill>
-                    </a:lnT>
-                    <a:lnB w="6350" cap="flat" cmpd="sng" algn="ctr">
-                      <a:solidFill>
-                        <a:srgbClr val="E8C4C8"/>
-                      </a:solidFill>
-                    </a:lnB>
-                  </a:tcPr>
-                </a:tc>
-                <a:tc>
-                  <a:txBody>
-                    <a:bodyPr wrap="square"/>
-                    <a:lstStyle/>
-                    <a:p>
-                      <a:pPr algn="ctr">
-                        <a:lnSpc>
-                          <a:spcPct val="100000"/>
-                        </a:lnSpc>
-                        <a:spcBef>
-                          <a:spcPts val="0"/>
-                        </a:spcBef>
-                        <a:spcAft>
-                          <a:spcPts val="0"/>
-                        </a:spcAft>
-                      </a:pPr>
-                      <a:r>
-                        <a:rPr sz="500" b="0">
-                          <a:solidFill>
-                            <a:srgbClr val="962837"/>
-                          </a:solidFill>
-                          <a:latin typeface="Calibri"/>
-                        </a:rPr>
-                        <a:t>КЦ</a:t>
-                      </a:r>
-                    </a:p>
-                  </a:txBody>
-                  <a:tcPr anchor="ctr" marL="25400" marR="25400" marT="12700" marB="12700">
-                    <a:solidFill>
-                      <a:srgbClr val="FFD2D8"/>
-                    </a:solidFill>
-                    <a:lnL w="6350" cap="flat" cmpd="sng" algn="ctr">
-                      <a:solidFill>
-                        <a:srgbClr val="E8C4C8"/>
-                      </a:solidFill>
-                    </a:lnL>
-                    <a:lnR w="6350" cap="flat" cmpd="sng" algn="ctr">
-                      <a:solidFill>
-                        <a:srgbClr val="E8C4C8"/>
-                      </a:solidFill>
-                    </a:lnR>
-                    <a:lnT w="6350" cap="flat" cmpd="sng" algn="ctr">
-                      <a:solidFill>
-                        <a:srgbClr val="E8C4C8"/>
-                      </a:solidFill>
-                    </a:lnT>
-                    <a:lnB w="6350" cap="flat" cmpd="sng" algn="ctr">
-                      <a:solidFill>
-                        <a:srgbClr val="E8C4C8"/>
-                      </a:solidFill>
-                    </a:lnB>
-                  </a:tcPr>
-                </a:tc>
-                <a:tc>
-                  <a:txBody>
-                    <a:bodyPr wrap="square"/>
-                    <a:lstStyle/>
-                    <a:p>
-                      <a:pPr algn="l">
-                        <a:lnSpc>
-                          <a:spcPct val="100000"/>
-                        </a:lnSpc>
-                        <a:spcBef>
-                          <a:spcPts val="0"/>
-                        </a:spcBef>
-                        <a:spcAft>
-                          <a:spcPts val="0"/>
-                        </a:spcAft>
-                      </a:pPr>
-                      <a:r>
-                        <a:rPr sz="500" b="0">
-                          <a:solidFill>
-                            <a:srgbClr val="323232"/>
-                          </a:solidFill>
-                          <a:latin typeface="Calibri"/>
-                        </a:rPr>
-                        <a:t/>
-                      </a:r>
-                    </a:p>
-                  </a:txBody>
-                  <a:tcPr anchor="ctr" marL="25400" marR="25400" marT="12700" marB="12700">
-                    <a:solidFill>
-                      <a:srgbClr val="FCF8F9"/>
                     </a:solidFill>
                     <a:lnL w="6350" cap="flat" cmpd="sng" algn="ctr">
                       <a:solidFill>
@@ -11609,59 +11585,6 @@
                           </a:solidFill>
                           <a:latin typeface="Calibri"/>
                         </a:rPr>
-                        <a:t>Честный знак</a:t>
-                      </a:r>
-                    </a:p>
-                  </a:txBody>
-                  <a:tcPr anchor="ctr" marL="25400" marR="25400" marT="12700" marB="12700">
-                    <a:solidFill>
-                      <a:srgbClr val="FFD2D8"/>
-                    </a:solidFill>
-                    <a:lnL w="6350" cap="flat" cmpd="sng" algn="ctr">
-                      <a:solidFill>
-                        <a:srgbClr val="E8C4C8"/>
-                      </a:solidFill>
-                    </a:lnL>
-                    <a:lnR w="6350" cap="flat" cmpd="sng" algn="ctr">
-                      <a:solidFill>
-                        <a:srgbClr val="E8C4C8"/>
-                      </a:solidFill>
-                    </a:lnR>
-                    <a:lnT w="6350" cap="flat" cmpd="sng" algn="ctr">
-                      <a:solidFill>
-                        <a:srgbClr val="E8C4C8"/>
-                      </a:solidFill>
-                    </a:lnT>
-                    <a:lnB w="6350" cap="flat" cmpd="sng" algn="ctr">
-                      <a:solidFill>
-                        <a:srgbClr val="E8C4C8"/>
-                      </a:solidFill>
-                    </a:lnB>
-                  </a:tcPr>
-                </a:tc>
-                <a:tc>
-                  <a:txBody>
-                    <a:bodyPr wrap="square"/>
-                    <a:lstStyle/>
-                    <a:p>
-                      <a:pPr algn="ctr">
-                        <a:lnSpc>
-                          <a:spcPct val="100000"/>
-                        </a:lnSpc>
-                        <a:spcBef>
-                          <a:spcPts val="0"/>
-                        </a:spcBef>
-                        <a:spcAft>
-                          <a:spcPts val="0"/>
-                        </a:spcAft>
-                      </a:pPr>
-                      <a:r>
-                        <a:rPr sz="500" b="0">
-                          <a:solidFill>
-                            <a:srgbClr val="962837"/>
-                          </a:solidFill>
-                          <a:latin typeface="Calibri"/>
-                        </a:rPr>
                         <a:t>ЦИ Липецк</a:t>
                       </a:r>
                     </a:p>
@@ -11906,6 +11829,59 @@
                     </a:lnB>
                   </a:tcPr>
                 </a:tc>
+                <a:tc>
+                  <a:txBody>
+                    <a:bodyPr wrap="square"/>
+                    <a:lstStyle/>
+                    <a:p>
+                      <a:pPr algn="ctr">
+                        <a:lnSpc>
+                          <a:spcPct val="100000"/>
+                        </a:lnSpc>
+                        <a:spcBef>
+                          <a:spcPts val="0"/>
+                        </a:spcBef>
+                        <a:spcAft>
+                          <a:spcPts val="0"/>
+                        </a:spcAft>
+                      </a:pPr>
+                      <a:r>
+                        <a:rPr sz="500" b="0">
+                          <a:solidFill>
+                            <a:srgbClr val="962837"/>
+                          </a:solidFill>
+                          <a:latin typeface="Calibri"/>
+                        </a:rPr>
+                        <a:t>Честный знак</a:t>
+                      </a:r>
+                    </a:p>
+                  </a:txBody>
+                  <a:tcPr anchor="ctr" marL="25400" marR="25400" marT="12700" marB="12700">
+                    <a:solidFill>
+                      <a:srgbClr val="FFD2D8"/>
+                    </a:solidFill>
+                    <a:lnL w="6350" cap="flat" cmpd="sng" algn="ctr">
+                      <a:solidFill>
+                        <a:srgbClr val="E8C4C8"/>
+                      </a:solidFill>
+                    </a:lnL>
+                    <a:lnR w="6350" cap="flat" cmpd="sng" algn="ctr">
+                      <a:solidFill>
+                        <a:srgbClr val="E8C4C8"/>
+                      </a:solidFill>
+                    </a:lnR>
+                    <a:lnT w="6350" cap="flat" cmpd="sng" algn="ctr">
+                      <a:solidFill>
+                        <a:srgbClr val="E8C4C8"/>
+                      </a:solidFill>
+                    </a:lnT>
+                    <a:lnB w="6350" cap="flat" cmpd="sng" algn="ctr">
+                      <a:solidFill>
+                        <a:srgbClr val="E8C4C8"/>
+                      </a:solidFill>
+                    </a:lnB>
+                  </a:tcPr>
+                </a:tc>
               </a:tr>
               <a:tr h="182880">
                 <a:tc>
@@ -12497,6 +12473,112 @@
                     <a:bodyPr wrap="square"/>
                     <a:lstStyle/>
                     <a:p>
+                      <a:pPr algn="ctr">
+                        <a:lnSpc>
+                          <a:spcPct val="100000"/>
+                        </a:lnSpc>
+                        <a:spcBef>
+                          <a:spcPts val="0"/>
+                        </a:spcBef>
+                        <a:spcAft>
+                          <a:spcPts val="0"/>
+                        </a:spcAft>
+                      </a:pPr>
+                      <a:r>
+                        <a:rPr sz="500" b="0">
+                          <a:solidFill>
+                            <a:srgbClr val="962837"/>
+                          </a:solidFill>
+                          <a:latin typeface="Calibri"/>
+                        </a:rPr>
+                        <a:t>ОП Тюмень</a:t>
+                      </a:r>
+                    </a:p>
+                  </a:txBody>
+                  <a:tcPr anchor="ctr" marL="25400" marR="25400" marT="12700" marB="12700">
+                    <a:solidFill>
+                      <a:srgbClr val="FFD2D8"/>
+                    </a:solidFill>
+                    <a:lnL w="6350" cap="flat" cmpd="sng" algn="ctr">
+                      <a:solidFill>
+                        <a:srgbClr val="E8C4C8"/>
+                      </a:solidFill>
+                    </a:lnL>
+                    <a:lnR w="6350" cap="flat" cmpd="sng" algn="ctr">
+                      <a:solidFill>
+                        <a:srgbClr val="E8C4C8"/>
+                      </a:solidFill>
+                    </a:lnR>
+                    <a:lnT w="6350" cap="flat" cmpd="sng" algn="ctr">
+                      <a:solidFill>
+                        <a:srgbClr val="E8C4C8"/>
+                      </a:solidFill>
+                    </a:lnT>
+                    <a:lnB w="6350" cap="flat" cmpd="sng" algn="ctr">
+                      <a:solidFill>
+                        <a:srgbClr val="E8C4C8"/>
+                      </a:solidFill>
+                    </a:lnB>
+                  </a:tcPr>
+                </a:tc>
+                <a:tc>
+                  <a:txBody>
+                    <a:bodyPr wrap="square"/>
+                    <a:lstStyle/>
+                    <a:p>
+                      <a:pPr algn="ctr">
+                        <a:lnSpc>
+                          <a:spcPct val="100000"/>
+                        </a:lnSpc>
+                        <a:spcBef>
+                          <a:spcPts val="0"/>
+                        </a:spcBef>
+                        <a:spcAft>
+                          <a:spcPts val="0"/>
+                        </a:spcAft>
+                      </a:pPr>
+                      <a:r>
+                        <a:rPr sz="500" b="0">
+                          <a:solidFill>
+                            <a:srgbClr val="962837"/>
+                          </a:solidFill>
+                          <a:latin typeface="Calibri"/>
+                        </a:rPr>
+                        <a:t>ОП Москва МСП</a:t>
+                      </a:r>
+                    </a:p>
+                  </a:txBody>
+                  <a:tcPr anchor="ctr" marL="25400" marR="25400" marT="12700" marB="12700">
+                    <a:solidFill>
+                      <a:srgbClr val="FFD2D8"/>
+                    </a:solidFill>
+                    <a:lnL w="6350" cap="flat" cmpd="sng" algn="ctr">
+                      <a:solidFill>
+                        <a:srgbClr val="E8C4C8"/>
+                      </a:solidFill>
+                    </a:lnL>
+                    <a:lnR w="6350" cap="flat" cmpd="sng" algn="ctr">
+                      <a:solidFill>
+                        <a:srgbClr val="E8C4C8"/>
+                      </a:solidFill>
+                    </a:lnR>
+                    <a:lnT w="6350" cap="flat" cmpd="sng" algn="ctr">
+                      <a:solidFill>
+                        <a:srgbClr val="E8C4C8"/>
+                      </a:solidFill>
+                    </a:lnT>
+                    <a:lnB w="6350" cap="flat" cmpd="sng" algn="ctr">
+                      <a:solidFill>
+                        <a:srgbClr val="E8C4C8"/>
+                      </a:solidFill>
+                    </a:lnB>
+                  </a:tcPr>
+                </a:tc>
+                <a:tc>
+                  <a:txBody>
+                    <a:bodyPr wrap="square"/>
+                    <a:lstStyle/>
+                    <a:p>
                       <a:pPr algn="l">
                         <a:lnSpc>
                           <a:spcPct val="100000"/>
@@ -12568,7 +12650,7 @@
                           </a:solidFill>
                           <a:latin typeface="Calibri"/>
                         </a:rPr>
-                        <a:t>ОП Тюмень</a:t>
+                        <a:t>КЦ</a:t>
                       </a:r>
                     </a:p>
                   </a:txBody>
@@ -12603,59 +12685,6 @@
                     <a:bodyPr wrap="square"/>
                     <a:lstStyle/>
                     <a:p>
-                      <a:pPr algn="ctr">
-                        <a:lnSpc>
-                          <a:spcPct val="100000"/>
-                        </a:lnSpc>
-                        <a:spcBef>
-                          <a:spcPts val="0"/>
-                        </a:spcBef>
-                        <a:spcAft>
-                          <a:spcPts val="0"/>
-                        </a:spcAft>
-                      </a:pPr>
-                      <a:r>
-                        <a:rPr sz="500" b="0">
-                          <a:solidFill>
-                            <a:srgbClr val="962837"/>
-                          </a:solidFill>
-                          <a:latin typeface="Calibri"/>
-                        </a:rPr>
-                        <a:t>ОП Москва МСП</a:t>
-                      </a:r>
-                    </a:p>
-                  </a:txBody>
-                  <a:tcPr anchor="ctr" marL="25400" marR="25400" marT="12700" marB="12700">
-                    <a:solidFill>
-                      <a:srgbClr val="FFD2D8"/>
-                    </a:solidFill>
-                    <a:lnL w="6350" cap="flat" cmpd="sng" algn="ctr">
-                      <a:solidFill>
-                        <a:srgbClr val="E8C4C8"/>
-                      </a:solidFill>
-                    </a:lnL>
-                    <a:lnR w="6350" cap="flat" cmpd="sng" algn="ctr">
-                      <a:solidFill>
-                        <a:srgbClr val="E8C4C8"/>
-                      </a:solidFill>
-                    </a:lnR>
-                    <a:lnT w="6350" cap="flat" cmpd="sng" algn="ctr">
-                      <a:solidFill>
-                        <a:srgbClr val="E8C4C8"/>
-                      </a:solidFill>
-                    </a:lnT>
-                    <a:lnB w="6350" cap="flat" cmpd="sng" algn="ctr">
-                      <a:solidFill>
-                        <a:srgbClr val="E8C4C8"/>
-                      </a:solidFill>
-                    </a:lnB>
-                  </a:tcPr>
-                </a:tc>
-                <a:tc>
-                  <a:txBody>
-                    <a:bodyPr wrap="square"/>
-                    <a:lstStyle/>
-                    <a:p>
                       <a:pPr algn="l">
                         <a:lnSpc>
                           <a:spcPct val="100000"/>
@@ -12681,59 +12710,6 @@
                   <a:tcPr anchor="ctr" marL="25400" marR="25400" marT="12700" marB="12700">
                     <a:solidFill>
                       <a:srgbClr val="FFFFFF"/>
-                    </a:solidFill>
-                    <a:lnL w="6350" cap="flat" cmpd="sng" algn="ctr">
-                      <a:solidFill>
-                        <a:srgbClr val="E8C4C8"/>
-                      </a:solidFill>
-                    </a:lnL>
-                    <a:lnR w="6350" cap="flat" cmpd="sng" algn="ctr">
-                      <a:solidFill>
-                        <a:srgbClr val="E8C4C8"/>
-                      </a:solidFill>
-                    </a:lnR>
-                    <a:lnT w="6350" cap="flat" cmpd="sng" algn="ctr">
-                      <a:solidFill>
-                        <a:srgbClr val="E8C4C8"/>
-                      </a:solidFill>
-                    </a:lnT>
-                    <a:lnB w="6350" cap="flat" cmpd="sng" algn="ctr">
-                      <a:solidFill>
-                        <a:srgbClr val="E8C4C8"/>
-                      </a:solidFill>
-                    </a:lnB>
-                  </a:tcPr>
-                </a:tc>
-                <a:tc>
-                  <a:txBody>
-                    <a:bodyPr wrap="square"/>
-                    <a:lstStyle/>
-                    <a:p>
-                      <a:pPr algn="ctr">
-                        <a:lnSpc>
-                          <a:spcPct val="100000"/>
-                        </a:lnSpc>
-                        <a:spcBef>
-                          <a:spcPts val="0"/>
-                        </a:spcBef>
-                        <a:spcAft>
-                          <a:spcPts val="0"/>
-                        </a:spcAft>
-                      </a:pPr>
-                      <a:r>
-                        <a:rPr sz="500" b="0">
-                          <a:solidFill>
-                            <a:srgbClr val="962837"/>
-                          </a:solidFill>
-                          <a:latin typeface="Calibri"/>
-                        </a:rPr>
-                        <a:t>КЦ</a:t>
-                      </a:r>
-                    </a:p>
-                  </a:txBody>
-                  <a:tcPr anchor="ctr" marL="25400" marR="25400" marT="12700" marB="12700">
-                    <a:solidFill>
-                      <a:srgbClr val="FFD2D8"/>
                     </a:solidFill>
                     <a:lnL w="6350" cap="flat" cmpd="sng" algn="ctr">
                       <a:solidFill>
@@ -13401,6 +13377,112 @@
                     <a:bodyPr wrap="square"/>
                     <a:lstStyle/>
                     <a:p>
+                      <a:pPr algn="ctr">
+                        <a:lnSpc>
+                          <a:spcPct val="100000"/>
+                        </a:lnSpc>
+                        <a:spcBef>
+                          <a:spcPts val="0"/>
+                        </a:spcBef>
+                        <a:spcAft>
+                          <a:spcPts val="0"/>
+                        </a:spcAft>
+                      </a:pPr>
+                      <a:r>
+                        <a:rPr sz="500" b="0">
+                          <a:solidFill>
+                            <a:srgbClr val="962837"/>
+                          </a:solidFill>
+                          <a:latin typeface="Calibri"/>
+                        </a:rPr>
+                        <a:t>БЦ Тюмень</a:t>
+                      </a:r>
+                    </a:p>
+                  </a:txBody>
+                  <a:tcPr anchor="ctr" marL="25400" marR="25400" marT="12700" marB="12700">
+                    <a:solidFill>
+                      <a:srgbClr val="FFD2D8"/>
+                    </a:solidFill>
+                    <a:lnL w="6350" cap="flat" cmpd="sng" algn="ctr">
+                      <a:solidFill>
+                        <a:srgbClr val="E8C4C8"/>
+                      </a:solidFill>
+                    </a:lnL>
+                    <a:lnR w="6350" cap="flat" cmpd="sng" algn="ctr">
+                      <a:solidFill>
+                        <a:srgbClr val="E8C4C8"/>
+                      </a:solidFill>
+                    </a:lnR>
+                    <a:lnT w="6350" cap="flat" cmpd="sng" algn="ctr">
+                      <a:solidFill>
+                        <a:srgbClr val="E8C4C8"/>
+                      </a:solidFill>
+                    </a:lnT>
+                    <a:lnB w="6350" cap="flat" cmpd="sng" algn="ctr">
+                      <a:solidFill>
+                        <a:srgbClr val="E8C4C8"/>
+                      </a:solidFill>
+                    </a:lnB>
+                  </a:tcPr>
+                </a:tc>
+                <a:tc>
+                  <a:txBody>
+                    <a:bodyPr wrap="square"/>
+                    <a:lstStyle/>
+                    <a:p>
+                      <a:pPr algn="ctr">
+                        <a:lnSpc>
+                          <a:spcPct val="100000"/>
+                        </a:lnSpc>
+                        <a:spcBef>
+                          <a:spcPts val="0"/>
+                        </a:spcBef>
+                        <a:spcAft>
+                          <a:spcPts val="0"/>
+                        </a:spcAft>
+                      </a:pPr>
+                      <a:r>
+                        <a:rPr sz="500" b="0">
+                          <a:solidFill>
+                            <a:srgbClr val="962837"/>
+                          </a:solidFill>
+                          <a:latin typeface="Calibri"/>
+                        </a:rPr>
+                        <a:t>БЦ Москва МСП</a:t>
+                      </a:r>
+                    </a:p>
+                  </a:txBody>
+                  <a:tcPr anchor="ctr" marL="25400" marR="25400" marT="12700" marB="12700">
+                    <a:solidFill>
+                      <a:srgbClr val="FFD2D8"/>
+                    </a:solidFill>
+                    <a:lnL w="6350" cap="flat" cmpd="sng" algn="ctr">
+                      <a:solidFill>
+                        <a:srgbClr val="E8C4C8"/>
+                      </a:solidFill>
+                    </a:lnL>
+                    <a:lnR w="6350" cap="flat" cmpd="sng" algn="ctr">
+                      <a:solidFill>
+                        <a:srgbClr val="E8C4C8"/>
+                      </a:solidFill>
+                    </a:lnR>
+                    <a:lnT w="6350" cap="flat" cmpd="sng" algn="ctr">
+                      <a:solidFill>
+                        <a:srgbClr val="E8C4C8"/>
+                      </a:solidFill>
+                    </a:lnT>
+                    <a:lnB w="6350" cap="flat" cmpd="sng" algn="ctr">
+                      <a:solidFill>
+                        <a:srgbClr val="E8C4C8"/>
+                      </a:solidFill>
+                    </a:lnB>
+                  </a:tcPr>
+                </a:tc>
+                <a:tc>
+                  <a:txBody>
+                    <a:bodyPr wrap="square"/>
+                    <a:lstStyle/>
+                    <a:p>
                       <a:pPr algn="l">
                         <a:lnSpc>
                           <a:spcPct val="100000"/>
@@ -13426,112 +13508,6 @@
                   <a:tcPr anchor="ctr" marL="25400" marR="25400" marT="12700" marB="12700">
                     <a:solidFill>
                       <a:srgbClr val="FCF8F9"/>
-                    </a:solidFill>
-                    <a:lnL w="6350" cap="flat" cmpd="sng" algn="ctr">
-                      <a:solidFill>
-                        <a:srgbClr val="E8C4C8"/>
-                      </a:solidFill>
-                    </a:lnL>
-                    <a:lnR w="6350" cap="flat" cmpd="sng" algn="ctr">
-                      <a:solidFill>
-                        <a:srgbClr val="E8C4C8"/>
-                      </a:solidFill>
-                    </a:lnR>
-                    <a:lnT w="6350" cap="flat" cmpd="sng" algn="ctr">
-                      <a:solidFill>
-                        <a:srgbClr val="E8C4C8"/>
-                      </a:solidFill>
-                    </a:lnT>
-                    <a:lnB w="6350" cap="flat" cmpd="sng" algn="ctr">
-                      <a:solidFill>
-                        <a:srgbClr val="E8C4C8"/>
-                      </a:solidFill>
-                    </a:lnB>
-                  </a:tcPr>
-                </a:tc>
-                <a:tc>
-                  <a:txBody>
-                    <a:bodyPr wrap="square"/>
-                    <a:lstStyle/>
-                    <a:p>
-                      <a:pPr algn="ctr">
-                        <a:lnSpc>
-                          <a:spcPct val="100000"/>
-                        </a:lnSpc>
-                        <a:spcBef>
-                          <a:spcPts val="0"/>
-                        </a:spcBef>
-                        <a:spcAft>
-                          <a:spcPts val="0"/>
-                        </a:spcAft>
-                      </a:pPr>
-                      <a:r>
-                        <a:rPr sz="500" b="0">
-                          <a:solidFill>
-                            <a:srgbClr val="962837"/>
-                          </a:solidFill>
-                          <a:latin typeface="Calibri"/>
-                        </a:rPr>
-                        <a:t>БЦ Тюмень</a:t>
-                      </a:r>
-                    </a:p>
-                  </a:txBody>
-                  <a:tcPr anchor="ctr" marL="25400" marR="25400" marT="12700" marB="12700">
-                    <a:solidFill>
-                      <a:srgbClr val="FFD2D8"/>
-                    </a:solidFill>
-                    <a:lnL w="6350" cap="flat" cmpd="sng" algn="ctr">
-                      <a:solidFill>
-                        <a:srgbClr val="E8C4C8"/>
-                      </a:solidFill>
-                    </a:lnL>
-                    <a:lnR w="6350" cap="flat" cmpd="sng" algn="ctr">
-                      <a:solidFill>
-                        <a:srgbClr val="E8C4C8"/>
-                      </a:solidFill>
-                    </a:lnR>
-                    <a:lnT w="6350" cap="flat" cmpd="sng" algn="ctr">
-                      <a:solidFill>
-                        <a:srgbClr val="E8C4C8"/>
-                      </a:solidFill>
-                    </a:lnT>
-                    <a:lnB w="6350" cap="flat" cmpd="sng" algn="ctr">
-                      <a:solidFill>
-                        <a:srgbClr val="E8C4C8"/>
-                      </a:solidFill>
-                    </a:lnB>
-                  </a:tcPr>
-                </a:tc>
-                <a:tc>
-                  <a:txBody>
-                    <a:bodyPr wrap="square"/>
-                    <a:lstStyle/>
-                    <a:p>
-                      <a:pPr algn="ctr">
-                        <a:lnSpc>
-                          <a:spcPct val="100000"/>
-                        </a:lnSpc>
-                        <a:spcBef>
-                          <a:spcPts val="0"/>
-                        </a:spcBef>
-                        <a:spcAft>
-                          <a:spcPts val="0"/>
-                        </a:spcAft>
-                      </a:pPr>
-                      <a:r>
-                        <a:rPr sz="500" b="0">
-                          <a:solidFill>
-                            <a:srgbClr val="962837"/>
-                          </a:solidFill>
-                          <a:latin typeface="Calibri"/>
-                        </a:rPr>
-                        <a:t>БЦ Москва МСП</a:t>
-                      </a:r>
-                    </a:p>
-                  </a:txBody>
-                  <a:tcPr anchor="ctr" marL="25400" marR="25400" marT="12700" marB="12700">
-                    <a:solidFill>
-                      <a:srgbClr val="FFD2D8"/>
                     </a:solidFill>
                     <a:lnL w="6350" cap="flat" cmpd="sng" algn="ctr">
                       <a:solidFill>
@@ -14305,6 +14281,112 @@
                     <a:bodyPr wrap="square"/>
                     <a:lstStyle/>
                     <a:p>
+                      <a:pPr algn="ctr">
+                        <a:lnSpc>
+                          <a:spcPct val="100000"/>
+                        </a:lnSpc>
+                        <a:spcBef>
+                          <a:spcPts val="0"/>
+                        </a:spcBef>
+                        <a:spcAft>
+                          <a:spcPts val="0"/>
+                        </a:spcAft>
+                      </a:pPr>
+                      <a:r>
+                        <a:rPr sz="500" b="0">
+                          <a:solidFill>
+                            <a:srgbClr val="962837"/>
+                          </a:solidFill>
+                          <a:latin typeface="Calibri"/>
+                        </a:rPr>
+                        <a:t>РС Тюмень</a:t>
+                      </a:r>
+                    </a:p>
+                  </a:txBody>
+                  <a:tcPr anchor="ctr" marL="25400" marR="25400" marT="12700" marB="12700">
+                    <a:solidFill>
+                      <a:srgbClr val="FFD2D8"/>
+                    </a:solidFill>
+                    <a:lnL w="6350" cap="flat" cmpd="sng" algn="ctr">
+                      <a:solidFill>
+                        <a:srgbClr val="E8C4C8"/>
+                      </a:solidFill>
+                    </a:lnL>
+                    <a:lnR w="6350" cap="flat" cmpd="sng" algn="ctr">
+                      <a:solidFill>
+                        <a:srgbClr val="E8C4C8"/>
+                      </a:solidFill>
+                    </a:lnR>
+                    <a:lnT w="6350" cap="flat" cmpd="sng" algn="ctr">
+                      <a:solidFill>
+                        <a:srgbClr val="E8C4C8"/>
+                      </a:solidFill>
+                    </a:lnT>
+                    <a:lnB w="6350" cap="flat" cmpd="sng" algn="ctr">
+                      <a:solidFill>
+                        <a:srgbClr val="E8C4C8"/>
+                      </a:solidFill>
+                    </a:lnB>
+                  </a:tcPr>
+                </a:tc>
+                <a:tc>
+                  <a:txBody>
+                    <a:bodyPr wrap="square"/>
+                    <a:lstStyle/>
+                    <a:p>
+                      <a:pPr algn="ctr">
+                        <a:lnSpc>
+                          <a:spcPct val="100000"/>
+                        </a:lnSpc>
+                        <a:spcBef>
+                          <a:spcPts val="0"/>
+                        </a:spcBef>
+                        <a:spcAft>
+                          <a:spcPts val="0"/>
+                        </a:spcAft>
+                      </a:pPr>
+                      <a:r>
+                        <a:rPr sz="500" b="0">
+                          <a:solidFill>
+                            <a:srgbClr val="962837"/>
+                          </a:solidFill>
+                          <a:latin typeface="Calibri"/>
+                        </a:rPr>
+                        <a:t>РС Липецк</a:t>
+                      </a:r>
+                    </a:p>
+                  </a:txBody>
+                  <a:tcPr anchor="ctr" marL="25400" marR="25400" marT="12700" marB="12700">
+                    <a:solidFill>
+                      <a:srgbClr val="FFD2D8"/>
+                    </a:solidFill>
+                    <a:lnL w="6350" cap="flat" cmpd="sng" algn="ctr">
+                      <a:solidFill>
+                        <a:srgbClr val="E8C4C8"/>
+                      </a:solidFill>
+                    </a:lnL>
+                    <a:lnR w="6350" cap="flat" cmpd="sng" algn="ctr">
+                      <a:solidFill>
+                        <a:srgbClr val="E8C4C8"/>
+                      </a:solidFill>
+                    </a:lnR>
+                    <a:lnT w="6350" cap="flat" cmpd="sng" algn="ctr">
+                      <a:solidFill>
+                        <a:srgbClr val="E8C4C8"/>
+                      </a:solidFill>
+                    </a:lnT>
+                    <a:lnB w="6350" cap="flat" cmpd="sng" algn="ctr">
+                      <a:solidFill>
+                        <a:srgbClr val="E8C4C8"/>
+                      </a:solidFill>
+                    </a:lnB>
+                  </a:tcPr>
+                </a:tc>
+                <a:tc>
+                  <a:txBody>
+                    <a:bodyPr wrap="square"/>
+                    <a:lstStyle/>
+                    <a:p>
                       <a:pPr algn="l">
                         <a:lnSpc>
                           <a:spcPct val="100000"/>
@@ -14330,112 +14412,6 @@
                   <a:tcPr anchor="ctr" marL="25400" marR="25400" marT="12700" marB="12700">
                     <a:solidFill>
                       <a:srgbClr val="FFFFFF"/>
-                    </a:solidFill>
-                    <a:lnL w="6350" cap="flat" cmpd="sng" algn="ctr">
-                      <a:solidFill>
-                        <a:srgbClr val="E8C4C8"/>
-                      </a:solidFill>
-                    </a:lnL>
-                    <a:lnR w="6350" cap="flat" cmpd="sng" algn="ctr">
-                      <a:solidFill>
-                        <a:srgbClr val="E8C4C8"/>
-                      </a:solidFill>
-                    </a:lnR>
-                    <a:lnT w="6350" cap="flat" cmpd="sng" algn="ctr">
-                      <a:solidFill>
-                        <a:srgbClr val="E8C4C8"/>
-                      </a:solidFill>
-                    </a:lnT>
-                    <a:lnB w="6350" cap="flat" cmpd="sng" algn="ctr">
-                      <a:solidFill>
-                        <a:srgbClr val="E8C4C8"/>
-                      </a:solidFill>
-                    </a:lnB>
-                  </a:tcPr>
-                </a:tc>
-                <a:tc>
-                  <a:txBody>
-                    <a:bodyPr wrap="square"/>
-                    <a:lstStyle/>
-                    <a:p>
-                      <a:pPr algn="ctr">
-                        <a:lnSpc>
-                          <a:spcPct val="100000"/>
-                        </a:lnSpc>
-                        <a:spcBef>
-                          <a:spcPts val="0"/>
-                        </a:spcBef>
-                        <a:spcAft>
-                          <a:spcPts val="0"/>
-                        </a:spcAft>
-                      </a:pPr>
-                      <a:r>
-                        <a:rPr sz="500" b="0">
-                          <a:solidFill>
-                            <a:srgbClr val="962837"/>
-                          </a:solidFill>
-                          <a:latin typeface="Calibri"/>
-                        </a:rPr>
-                        <a:t>РС Тюмень</a:t>
-                      </a:r>
-                    </a:p>
-                  </a:txBody>
-                  <a:tcPr anchor="ctr" marL="25400" marR="25400" marT="12700" marB="12700">
-                    <a:solidFill>
-                      <a:srgbClr val="FFD2D8"/>
-                    </a:solidFill>
-                    <a:lnL w="6350" cap="flat" cmpd="sng" algn="ctr">
-                      <a:solidFill>
-                        <a:srgbClr val="E8C4C8"/>
-                      </a:solidFill>
-                    </a:lnL>
-                    <a:lnR w="6350" cap="flat" cmpd="sng" algn="ctr">
-                      <a:solidFill>
-                        <a:srgbClr val="E8C4C8"/>
-                      </a:solidFill>
-                    </a:lnR>
-                    <a:lnT w="6350" cap="flat" cmpd="sng" algn="ctr">
-                      <a:solidFill>
-                        <a:srgbClr val="E8C4C8"/>
-                      </a:solidFill>
-                    </a:lnT>
-                    <a:lnB w="6350" cap="flat" cmpd="sng" algn="ctr">
-                      <a:solidFill>
-                        <a:srgbClr val="E8C4C8"/>
-                      </a:solidFill>
-                    </a:lnB>
-                  </a:tcPr>
-                </a:tc>
-                <a:tc>
-                  <a:txBody>
-                    <a:bodyPr wrap="square"/>
-                    <a:lstStyle/>
-                    <a:p>
-                      <a:pPr algn="ctr">
-                        <a:lnSpc>
-                          <a:spcPct val="100000"/>
-                        </a:lnSpc>
-                        <a:spcBef>
-                          <a:spcPts val="0"/>
-                        </a:spcBef>
-                        <a:spcAft>
-                          <a:spcPts val="0"/>
-                        </a:spcAft>
-                      </a:pPr>
-                      <a:r>
-                        <a:rPr sz="500" b="0">
-                          <a:solidFill>
-                            <a:srgbClr val="962837"/>
-                          </a:solidFill>
-                          <a:latin typeface="Calibri"/>
-                        </a:rPr>
-                        <a:t>РС Липецк</a:t>
-                      </a:r>
-                    </a:p>
-                  </a:txBody>
-                  <a:tcPr anchor="ctr" marL="25400" marR="25400" marT="12700" marB="12700">
-                    <a:solidFill>
-                      <a:srgbClr val="FFD2D8"/>
                     </a:solidFill>
                     <a:lnL w="6350" cap="flat" cmpd="sng" algn="ctr">
                       <a:solidFill>
@@ -16270,6 +16246,59 @@
                     <a:bodyPr wrap="square"/>
                     <a:lstStyle/>
                     <a:p>
+                      <a:pPr algn="ctr">
+                        <a:lnSpc>
+                          <a:spcPct val="100000"/>
+                        </a:lnSpc>
+                        <a:spcBef>
+                          <a:spcPts val="0"/>
+                        </a:spcBef>
+                        <a:spcAft>
+                          <a:spcPts val="0"/>
+                        </a:spcAft>
+                      </a:pPr>
+                      <a:r>
+                        <a:rPr sz="500" b="0">
+                          <a:solidFill>
+                            <a:srgbClr val="962837"/>
+                          </a:solidFill>
+                          <a:latin typeface="Calibri"/>
+                        </a:rPr>
+                        <a:t>КЦ</a:t>
+                      </a:r>
+                    </a:p>
+                  </a:txBody>
+                  <a:tcPr anchor="ctr" marL="25400" marR="25400" marT="12700" marB="12700">
+                    <a:solidFill>
+                      <a:srgbClr val="FFD2D8"/>
+                    </a:solidFill>
+                    <a:lnL w="6350" cap="flat" cmpd="sng" algn="ctr">
+                      <a:solidFill>
+                        <a:srgbClr val="E8C4C8"/>
+                      </a:solidFill>
+                    </a:lnL>
+                    <a:lnR w="6350" cap="flat" cmpd="sng" algn="ctr">
+                      <a:solidFill>
+                        <a:srgbClr val="E8C4C8"/>
+                      </a:solidFill>
+                    </a:lnR>
+                    <a:lnT w="6350" cap="flat" cmpd="sng" algn="ctr">
+                      <a:solidFill>
+                        <a:srgbClr val="E8C4C8"/>
+                      </a:solidFill>
+                    </a:lnT>
+                    <a:lnB w="6350" cap="flat" cmpd="sng" algn="ctr">
+                      <a:solidFill>
+                        <a:srgbClr val="E8C4C8"/>
+                      </a:solidFill>
+                    </a:lnB>
+                  </a:tcPr>
+                </a:tc>
+                <a:tc>
+                  <a:txBody>
+                    <a:bodyPr wrap="square"/>
+                    <a:lstStyle/>
+                    <a:p>
                       <a:pPr algn="l">
                         <a:lnSpc>
                           <a:spcPct val="100000"/>
@@ -16295,59 +16324,6 @@
                   <a:tcPr anchor="ctr" marL="25400" marR="25400" marT="12700" marB="12700">
                     <a:solidFill>
                       <a:srgbClr val="FFFFFF"/>
-                    </a:solidFill>
-                    <a:lnL w="6350" cap="flat" cmpd="sng" algn="ctr">
-                      <a:solidFill>
-                        <a:srgbClr val="E8C4C8"/>
-                      </a:solidFill>
-                    </a:lnL>
-                    <a:lnR w="6350" cap="flat" cmpd="sng" algn="ctr">
-                      <a:solidFill>
-                        <a:srgbClr val="E8C4C8"/>
-                      </a:solidFill>
-                    </a:lnR>
-                    <a:lnT w="6350" cap="flat" cmpd="sng" algn="ctr">
-                      <a:solidFill>
-                        <a:srgbClr val="E8C4C8"/>
-                      </a:solidFill>
-                    </a:lnT>
-                    <a:lnB w="6350" cap="flat" cmpd="sng" algn="ctr">
-                      <a:solidFill>
-                        <a:srgbClr val="E8C4C8"/>
-                      </a:solidFill>
-                    </a:lnB>
-                  </a:tcPr>
-                </a:tc>
-                <a:tc>
-                  <a:txBody>
-                    <a:bodyPr wrap="square"/>
-                    <a:lstStyle/>
-                    <a:p>
-                      <a:pPr algn="ctr">
-                        <a:lnSpc>
-                          <a:spcPct val="100000"/>
-                        </a:lnSpc>
-                        <a:spcBef>
-                          <a:spcPts val="0"/>
-                        </a:spcBef>
-                        <a:spcAft>
-                          <a:spcPts val="0"/>
-                        </a:spcAft>
-                      </a:pPr>
-                      <a:r>
-                        <a:rPr sz="500" b="0">
-                          <a:solidFill>
-                            <a:srgbClr val="962837"/>
-                          </a:solidFill>
-                          <a:latin typeface="Calibri"/>
-                        </a:rPr>
-                        <a:t>КЦ</a:t>
-                      </a:r>
-                    </a:p>
-                  </a:txBody>
-                  <a:tcPr anchor="ctr" marL="25400" marR="25400" marT="12700" marB="12700">
-                    <a:solidFill>
-                      <a:srgbClr val="FFD2D8"/>
                     </a:solidFill>
                     <a:lnL w="6350" cap="flat" cmpd="sng" algn="ctr">
                       <a:solidFill>
@@ -22406,59 +22382,6 @@
                   <a:tcPr anchor="ctr" marL="25400" marR="25400" marT="12700" marB="12700">
                     <a:solidFill>
                       <a:srgbClr val="FFD2D8"/>
-                    </a:solidFill>
-                    <a:lnL w="6350" cap="flat" cmpd="sng" algn="ctr">
-                      <a:solidFill>
-                        <a:srgbClr val="E8C4C8"/>
-                      </a:solidFill>
-                    </a:lnL>
-                    <a:lnR w="6350" cap="flat" cmpd="sng" algn="ctr">
-                      <a:solidFill>
-                        <a:srgbClr val="E8C4C8"/>
-                      </a:solidFill>
-                    </a:lnR>
-                    <a:lnT w="6350" cap="flat" cmpd="sng" algn="ctr">
-                      <a:solidFill>
-                        <a:srgbClr val="E8C4C8"/>
-                      </a:solidFill>
-                    </a:lnT>
-                    <a:lnB w="6350" cap="flat" cmpd="sng" algn="ctr">
-                      <a:solidFill>
-                        <a:srgbClr val="E8C4C8"/>
-                      </a:solidFill>
-                    </a:lnB>
-                  </a:tcPr>
-                </a:tc>
-                <a:tc>
-                  <a:txBody>
-                    <a:bodyPr wrap="square"/>
-                    <a:lstStyle/>
-                    <a:p>
-                      <a:pPr algn="l">
-                        <a:lnSpc>
-                          <a:spcPct val="100000"/>
-                        </a:lnSpc>
-                        <a:spcBef>
-                          <a:spcPts val="0"/>
-                        </a:spcBef>
-                        <a:spcAft>
-                          <a:spcPts val="0"/>
-                        </a:spcAft>
-                      </a:pPr>
-                      <a:r>
-                        <a:rPr sz="500" b="0">
-                          <a:solidFill>
-                            <a:srgbClr val="323232"/>
-                          </a:solidFill>
-                          <a:latin typeface="Calibri"/>
-                        </a:rPr>
-                        <a:t/>
-                      </a:r>
-                    </a:p>
-                  </a:txBody>
-                  <a:tcPr anchor="ctr" marL="25400" marR="25400" marT="12700" marB="12700">
-                    <a:solidFill>
-                      <a:srgbClr val="FCF8F9"/>
                     </a:solidFill>
                     <a:lnL w="6350" cap="flat" cmpd="sng" algn="ctr">
                       <a:solidFill>
@@ -22751,6 +22674,59 @@
                     </a:lnB>
                   </a:tcPr>
                 </a:tc>
+                <a:tc>
+                  <a:txBody>
+                    <a:bodyPr wrap="square"/>
+                    <a:lstStyle/>
+                    <a:p>
+                      <a:pPr algn="l">
+                        <a:lnSpc>
+                          <a:spcPct val="100000"/>
+                        </a:lnSpc>
+                        <a:spcBef>
+                          <a:spcPts val="0"/>
+                        </a:spcBef>
+                        <a:spcAft>
+                          <a:spcPts val="0"/>
+                        </a:spcAft>
+                      </a:pPr>
+                      <a:r>
+                        <a:rPr sz="500" b="0">
+                          <a:solidFill>
+                            <a:srgbClr val="323232"/>
+                          </a:solidFill>
+                          <a:latin typeface="Calibri"/>
+                        </a:rPr>
+                        <a:t/>
+                      </a:r>
+                    </a:p>
+                  </a:txBody>
+                  <a:tcPr anchor="ctr" marL="25400" marR="25400" marT="12700" marB="12700">
+                    <a:solidFill>
+                      <a:srgbClr val="FCF8F9"/>
+                    </a:solidFill>
+                    <a:lnL w="6350" cap="flat" cmpd="sng" algn="ctr">
+                      <a:solidFill>
+                        <a:srgbClr val="E8C4C8"/>
+                      </a:solidFill>
+                    </a:lnL>
+                    <a:lnR w="6350" cap="flat" cmpd="sng" algn="ctr">
+                      <a:solidFill>
+                        <a:srgbClr val="E8C4C8"/>
+                      </a:solidFill>
+                    </a:lnR>
+                    <a:lnT w="6350" cap="flat" cmpd="sng" algn="ctr">
+                      <a:solidFill>
+                        <a:srgbClr val="E8C4C8"/>
+                      </a:solidFill>
+                    </a:lnT>
+                    <a:lnB w="6350" cap="flat" cmpd="sng" algn="ctr">
+                      <a:solidFill>
+                        <a:srgbClr val="E8C4C8"/>
+                      </a:solidFill>
+                    </a:lnB>
+                  </a:tcPr>
+                </a:tc>
               </a:tr>
               <a:tr h="256032">
                 <a:tc>
@@ -25359,6 +25335,59 @@
                     <a:bodyPr wrap="square"/>
                     <a:lstStyle/>
                     <a:p>
+                      <a:pPr algn="ctr">
+                        <a:lnSpc>
+                          <a:spcPct val="100000"/>
+                        </a:lnSpc>
+                        <a:spcBef>
+                          <a:spcPts val="0"/>
+                        </a:spcBef>
+                        <a:spcAft>
+                          <a:spcPts val="0"/>
+                        </a:spcAft>
+                      </a:pPr>
+                      <a:r>
+                        <a:rPr sz="500" b="0">
+                          <a:solidFill>
+                            <a:srgbClr val="962837"/>
+                          </a:solidFill>
+                          <a:latin typeface="Calibri"/>
+                        </a:rPr>
+                        <a:t>КЦ</a:t>
+                      </a:r>
+                    </a:p>
+                  </a:txBody>
+                  <a:tcPr anchor="ctr" marL="25400" marR="25400" marT="12700" marB="12700">
+                    <a:solidFill>
+                      <a:srgbClr val="FFD2D8"/>
+                    </a:solidFill>
+                    <a:lnL w="6350" cap="flat" cmpd="sng" algn="ctr">
+                      <a:solidFill>
+                        <a:srgbClr val="E8C4C8"/>
+                      </a:solidFill>
+                    </a:lnL>
+                    <a:lnR w="6350" cap="flat" cmpd="sng" algn="ctr">
+                      <a:solidFill>
+                        <a:srgbClr val="E8C4C8"/>
+                      </a:solidFill>
+                    </a:lnR>
+                    <a:lnT w="6350" cap="flat" cmpd="sng" algn="ctr">
+                      <a:solidFill>
+                        <a:srgbClr val="E8C4C8"/>
+                      </a:solidFill>
+                    </a:lnT>
+                    <a:lnB w="6350" cap="flat" cmpd="sng" algn="ctr">
+                      <a:solidFill>
+                        <a:srgbClr val="E8C4C8"/>
+                      </a:solidFill>
+                    </a:lnB>
+                  </a:tcPr>
+                </a:tc>
+                <a:tc>
+                  <a:txBody>
+                    <a:bodyPr wrap="square"/>
+                    <a:lstStyle/>
+                    <a:p>
                       <a:pPr algn="l">
                         <a:lnSpc>
                           <a:spcPct val="100000"/>
@@ -25384,59 +25413,6 @@
                   <a:tcPr anchor="ctr" marL="25400" marR="25400" marT="12700" marB="12700">
                     <a:solidFill>
                       <a:srgbClr val="FFFFFF"/>
-                    </a:solidFill>
-                    <a:lnL w="6350" cap="flat" cmpd="sng" algn="ctr">
-                      <a:solidFill>
-                        <a:srgbClr val="E8C4C8"/>
-                      </a:solidFill>
-                    </a:lnL>
-                    <a:lnR w="6350" cap="flat" cmpd="sng" algn="ctr">
-                      <a:solidFill>
-                        <a:srgbClr val="E8C4C8"/>
-                      </a:solidFill>
-                    </a:lnR>
-                    <a:lnT w="6350" cap="flat" cmpd="sng" algn="ctr">
-                      <a:solidFill>
-                        <a:srgbClr val="E8C4C8"/>
-                      </a:solidFill>
-                    </a:lnT>
-                    <a:lnB w="6350" cap="flat" cmpd="sng" algn="ctr">
-                      <a:solidFill>
-                        <a:srgbClr val="E8C4C8"/>
-                      </a:solidFill>
-                    </a:lnB>
-                  </a:tcPr>
-                </a:tc>
-                <a:tc>
-                  <a:txBody>
-                    <a:bodyPr wrap="square"/>
-                    <a:lstStyle/>
-                    <a:p>
-                      <a:pPr algn="ctr">
-                        <a:lnSpc>
-                          <a:spcPct val="100000"/>
-                        </a:lnSpc>
-                        <a:spcBef>
-                          <a:spcPts val="0"/>
-                        </a:spcBef>
-                        <a:spcAft>
-                          <a:spcPts val="0"/>
-                        </a:spcAft>
-                      </a:pPr>
-                      <a:r>
-                        <a:rPr sz="500" b="0">
-                          <a:solidFill>
-                            <a:srgbClr val="962837"/>
-                          </a:solidFill>
-                          <a:latin typeface="Calibri"/>
-                        </a:rPr>
-                        <a:t>КЦ</a:t>
-                      </a:r>
-                    </a:p>
-                  </a:txBody>
-                  <a:tcPr anchor="ctr" marL="25400" marR="25400" marT="12700" marB="12700">
-                    <a:solidFill>
-                      <a:srgbClr val="FFD2D8"/>
                     </a:solidFill>
                     <a:lnL w="6350" cap="flat" cmpd="sng" algn="ctr">
                       <a:solidFill>
@@ -26787,7 +26763,7 @@
                     </a:lnB>
                   </a:tcPr>
                 </a:tc>
-                <a:tc gridSpan="3">
+                <a:tc gridSpan="8">
                   <a:txBody>
                     <a:bodyPr wrap="square"/>
                     <a:lstStyle/>
@@ -26898,6 +26874,151 @@
                     </a:lnB>
                   </a:tcPr>
                 </a:tc>
+                <a:tc hMerge="1">
+                  <a:txBody>
+                    <a:bodyPr/>
+                    <a:lstStyle/>
+                    <a:p/>
+                  </a:txBody>
+                  <a:tcPr>
+                    <a:lnL w="6350" cap="flat" cmpd="sng" algn="ctr">
+                      <a:solidFill>
+                        <a:srgbClr val="E8C4C8"/>
+                      </a:solidFill>
+                    </a:lnL>
+                    <a:lnR w="6350" cap="flat" cmpd="sng" algn="ctr">
+                      <a:solidFill>
+                        <a:srgbClr val="E8C4C8"/>
+                      </a:solidFill>
+                    </a:lnR>
+                    <a:lnT w="6350" cap="flat" cmpd="sng" algn="ctr">
+                      <a:solidFill>
+                        <a:srgbClr val="E8C4C8"/>
+                      </a:solidFill>
+                    </a:lnT>
+                    <a:lnB w="6350" cap="flat" cmpd="sng" algn="ctr">
+                      <a:solidFill>
+                        <a:srgbClr val="E8C4C8"/>
+                      </a:solidFill>
+                    </a:lnB>
+                  </a:tcPr>
+                </a:tc>
+                <a:tc hMerge="1">
+                  <a:txBody>
+                    <a:bodyPr/>
+                    <a:lstStyle/>
+                    <a:p/>
+                  </a:txBody>
+                  <a:tcPr>
+                    <a:lnL w="6350" cap="flat" cmpd="sng" algn="ctr">
+                      <a:solidFill>
+                        <a:srgbClr val="E8C4C8"/>
+                      </a:solidFill>
+                    </a:lnL>
+                    <a:lnR w="6350" cap="flat" cmpd="sng" algn="ctr">
+                      <a:solidFill>
+                        <a:srgbClr val="E8C4C8"/>
+                      </a:solidFill>
+                    </a:lnR>
+                    <a:lnT w="6350" cap="flat" cmpd="sng" algn="ctr">
+                      <a:solidFill>
+                        <a:srgbClr val="E8C4C8"/>
+                      </a:solidFill>
+                    </a:lnT>
+                    <a:lnB w="6350" cap="flat" cmpd="sng" algn="ctr">
+                      <a:solidFill>
+                        <a:srgbClr val="E8C4C8"/>
+                      </a:solidFill>
+                    </a:lnB>
+                  </a:tcPr>
+                </a:tc>
+                <a:tc hMerge="1">
+                  <a:txBody>
+                    <a:bodyPr/>
+                    <a:lstStyle/>
+                    <a:p/>
+                  </a:txBody>
+                  <a:tcPr>
+                    <a:lnL w="6350" cap="flat" cmpd="sng" algn="ctr">
+                      <a:solidFill>
+                        <a:srgbClr val="E8C4C8"/>
+                      </a:solidFill>
+                    </a:lnL>
+                    <a:lnR w="6350" cap="flat" cmpd="sng" algn="ctr">
+                      <a:solidFill>
+                        <a:srgbClr val="E8C4C8"/>
+                      </a:solidFill>
+                    </a:lnR>
+                    <a:lnT w="6350" cap="flat" cmpd="sng" algn="ctr">
+                      <a:solidFill>
+                        <a:srgbClr val="E8C4C8"/>
+                      </a:solidFill>
+                    </a:lnT>
+                    <a:lnB w="6350" cap="flat" cmpd="sng" algn="ctr">
+                      <a:solidFill>
+                        <a:srgbClr val="E8C4C8"/>
+                      </a:solidFill>
+                    </a:lnB>
+                  </a:tcPr>
+                </a:tc>
+                <a:tc hMerge="1">
+                  <a:txBody>
+                    <a:bodyPr/>
+                    <a:lstStyle/>
+                    <a:p/>
+                  </a:txBody>
+                  <a:tcPr>
+                    <a:lnL w="6350" cap="flat" cmpd="sng" algn="ctr">
+                      <a:solidFill>
+                        <a:srgbClr val="E8C4C8"/>
+                      </a:solidFill>
+                    </a:lnL>
+                    <a:lnR w="6350" cap="flat" cmpd="sng" algn="ctr">
+                      <a:solidFill>
+                        <a:srgbClr val="E8C4C8"/>
+                      </a:solidFill>
+                    </a:lnR>
+                    <a:lnT w="6350" cap="flat" cmpd="sng" algn="ctr">
+                      <a:solidFill>
+                        <a:srgbClr val="E8C4C8"/>
+                      </a:solidFill>
+                    </a:lnT>
+                    <a:lnB w="6350" cap="flat" cmpd="sng" algn="ctr">
+                      <a:solidFill>
+                        <a:srgbClr val="E8C4C8"/>
+                      </a:solidFill>
+                    </a:lnB>
+                  </a:tcPr>
+                </a:tc>
+                <a:tc hMerge="1">
+                  <a:txBody>
+                    <a:bodyPr/>
+                    <a:lstStyle/>
+                    <a:p/>
+                  </a:txBody>
+                  <a:tcPr>
+                    <a:lnL w="6350" cap="flat" cmpd="sng" algn="ctr">
+                      <a:solidFill>
+                        <a:srgbClr val="E8C4C8"/>
+                      </a:solidFill>
+                    </a:lnL>
+                    <a:lnR w="6350" cap="flat" cmpd="sng" algn="ctr">
+                      <a:solidFill>
+                        <a:srgbClr val="E8C4C8"/>
+                      </a:solidFill>
+                    </a:lnR>
+                    <a:lnT w="6350" cap="flat" cmpd="sng" algn="ctr">
+                      <a:solidFill>
+                        <a:srgbClr val="E8C4C8"/>
+                      </a:solidFill>
+                    </a:lnT>
+                    <a:lnB w="6350" cap="flat" cmpd="sng" algn="ctr">
+                      <a:solidFill>
+                        <a:srgbClr val="E8C4C8"/>
+                      </a:solidFill>
+                    </a:lnB>
+                  </a:tcPr>
+                </a:tc>
                 <a:tc>
                   <a:txBody>
                     <a:bodyPr wrap="square"/>
@@ -26929,175 +27050,6 @@
                     <a:solidFill>
                       <a:srgbClr val="570C17"/>
                     </a:solidFill>
-                    <a:lnL w="6350" cap="flat" cmpd="sng" algn="ctr">
-                      <a:solidFill>
-                        <a:srgbClr val="E8C4C8"/>
-                      </a:solidFill>
-                    </a:lnL>
-                    <a:lnR w="6350" cap="flat" cmpd="sng" algn="ctr">
-                      <a:solidFill>
-                        <a:srgbClr val="E8C4C8"/>
-                      </a:solidFill>
-                    </a:lnR>
-                    <a:lnT w="6350" cap="flat" cmpd="sng" algn="ctr">
-                      <a:solidFill>
-                        <a:srgbClr val="E8C4C8"/>
-                      </a:solidFill>
-                    </a:lnT>
-                    <a:lnB w="6350" cap="flat" cmpd="sng" algn="ctr">
-                      <a:solidFill>
-                        <a:srgbClr val="E8C4C8"/>
-                      </a:solidFill>
-                    </a:lnB>
-                  </a:tcPr>
-                </a:tc>
-                <a:tc gridSpan="5">
-                  <a:txBody>
-                    <a:bodyPr wrap="square"/>
-                    <a:lstStyle/>
-                    <a:p>
-                      <a:pPr algn="ctr">
-                        <a:lnSpc>
-                          <a:spcPct val="100000"/>
-                        </a:lnSpc>
-                        <a:spcBef>
-                          <a:spcPts val="0"/>
-                        </a:spcBef>
-                        <a:spcAft>
-                          <a:spcPts val="0"/>
-                        </a:spcAft>
-                      </a:pPr>
-                      <a:r>
-                        <a:rPr sz="700" b="1">
-                          <a:solidFill>
-                            <a:srgbClr val="FFFFFF"/>
-                          </a:solidFill>
-                          <a:latin typeface="Calibri"/>
-                        </a:rPr>
-                        <a:t>2027</a:t>
-                      </a:r>
-                    </a:p>
-                  </a:txBody>
-                  <a:tcPr anchor="ctr" marL="25400" marR="25400" marT="12700" marB="12700">
-                    <a:solidFill>
-                      <a:srgbClr val="570C17"/>
-                    </a:solidFill>
-                    <a:lnL w="6350" cap="flat" cmpd="sng" algn="ctr">
-                      <a:solidFill>
-                        <a:srgbClr val="E8C4C8"/>
-                      </a:solidFill>
-                    </a:lnL>
-                    <a:lnR w="6350" cap="flat" cmpd="sng" algn="ctr">
-                      <a:solidFill>
-                        <a:srgbClr val="E8C4C8"/>
-                      </a:solidFill>
-                    </a:lnR>
-                    <a:lnT w="6350" cap="flat" cmpd="sng" algn="ctr">
-                      <a:solidFill>
-                        <a:srgbClr val="E8C4C8"/>
-                      </a:solidFill>
-                    </a:lnT>
-                    <a:lnB w="6350" cap="flat" cmpd="sng" algn="ctr">
-                      <a:solidFill>
-                        <a:srgbClr val="E8C4C8"/>
-                      </a:solidFill>
-                    </a:lnB>
-                  </a:tcPr>
-                </a:tc>
-                <a:tc hMerge="1">
-                  <a:txBody>
-                    <a:bodyPr/>
-                    <a:lstStyle/>
-                    <a:p/>
-                  </a:txBody>
-                  <a:tcPr>
-                    <a:lnL w="6350" cap="flat" cmpd="sng" algn="ctr">
-                      <a:solidFill>
-                        <a:srgbClr val="E8C4C8"/>
-                      </a:solidFill>
-                    </a:lnL>
-                    <a:lnR w="6350" cap="flat" cmpd="sng" algn="ctr">
-                      <a:solidFill>
-                        <a:srgbClr val="E8C4C8"/>
-                      </a:solidFill>
-                    </a:lnR>
-                    <a:lnT w="6350" cap="flat" cmpd="sng" algn="ctr">
-                      <a:solidFill>
-                        <a:srgbClr val="E8C4C8"/>
-                      </a:solidFill>
-                    </a:lnT>
-                    <a:lnB w="6350" cap="flat" cmpd="sng" algn="ctr">
-                      <a:solidFill>
-                        <a:srgbClr val="E8C4C8"/>
-                      </a:solidFill>
-                    </a:lnB>
-                  </a:tcPr>
-                </a:tc>
-                <a:tc hMerge="1">
-                  <a:txBody>
-                    <a:bodyPr/>
-                    <a:lstStyle/>
-                    <a:p/>
-                  </a:txBody>
-                  <a:tcPr>
-                    <a:lnL w="6350" cap="flat" cmpd="sng" algn="ctr">
-                      <a:solidFill>
-                        <a:srgbClr val="E8C4C8"/>
-                      </a:solidFill>
-                    </a:lnL>
-                    <a:lnR w="6350" cap="flat" cmpd="sng" algn="ctr">
-                      <a:solidFill>
-                        <a:srgbClr val="E8C4C8"/>
-                      </a:solidFill>
-                    </a:lnR>
-                    <a:lnT w="6350" cap="flat" cmpd="sng" algn="ctr">
-                      <a:solidFill>
-                        <a:srgbClr val="E8C4C8"/>
-                      </a:solidFill>
-                    </a:lnT>
-                    <a:lnB w="6350" cap="flat" cmpd="sng" algn="ctr">
-                      <a:solidFill>
-                        <a:srgbClr val="E8C4C8"/>
-                      </a:solidFill>
-                    </a:lnB>
-                  </a:tcPr>
-                </a:tc>
-                <a:tc hMerge="1">
-                  <a:txBody>
-                    <a:bodyPr/>
-                    <a:lstStyle/>
-                    <a:p/>
-                  </a:txBody>
-                  <a:tcPr>
-                    <a:lnL w="6350" cap="flat" cmpd="sng" algn="ctr">
-                      <a:solidFill>
-                        <a:srgbClr val="E8C4C8"/>
-                      </a:solidFill>
-                    </a:lnL>
-                    <a:lnR w="6350" cap="flat" cmpd="sng" algn="ctr">
-                      <a:solidFill>
-                        <a:srgbClr val="E8C4C8"/>
-                      </a:solidFill>
-                    </a:lnR>
-                    <a:lnT w="6350" cap="flat" cmpd="sng" algn="ctr">
-                      <a:solidFill>
-                        <a:srgbClr val="E8C4C8"/>
-                      </a:solidFill>
-                    </a:lnT>
-                    <a:lnB w="6350" cap="flat" cmpd="sng" algn="ctr">
-                      <a:solidFill>
-                        <a:srgbClr val="E8C4C8"/>
-                      </a:solidFill>
-                    </a:lnB>
-                  </a:tcPr>
-                </a:tc>
-                <a:tc hMerge="1">
-                  <a:txBody>
-                    <a:bodyPr/>
-                    <a:lstStyle/>
-                    <a:p/>
-                  </a:txBody>
-                  <a:tcPr>
                     <a:lnL w="6350" cap="flat" cmpd="sng" algn="ctr">
                       <a:solidFill>
                         <a:srgbClr val="E8C4C8"/>
@@ -27680,272 +27632,272 @@
                           </a:solidFill>
                           <a:latin typeface="Calibri"/>
                         </a:rPr>
+                        <a:t>05.27</a:t>
+                      </a:r>
+                    </a:p>
+                  </a:txBody>
+                  <a:tcPr anchor="ctr" marL="25400" marR="25400" marT="12700" marB="12700">
+                    <a:solidFill>
+                      <a:srgbClr val="570C17"/>
+                    </a:solidFill>
+                    <a:lnL w="6350" cap="flat" cmpd="sng" algn="ctr">
+                      <a:solidFill>
+                        <a:srgbClr val="E8C4C8"/>
+                      </a:solidFill>
+                    </a:lnL>
+                    <a:lnR w="6350" cap="flat" cmpd="sng" algn="ctr">
+                      <a:solidFill>
+                        <a:srgbClr val="E8C4C8"/>
+                      </a:solidFill>
+                    </a:lnR>
+                    <a:lnT w="6350" cap="flat" cmpd="sng" algn="ctr">
+                      <a:solidFill>
+                        <a:srgbClr val="E8C4C8"/>
+                      </a:solidFill>
+                    </a:lnT>
+                    <a:lnB w="6350" cap="flat" cmpd="sng" algn="ctr">
+                      <a:solidFill>
+                        <a:srgbClr val="E8C4C8"/>
+                      </a:solidFill>
+                    </a:lnB>
+                  </a:tcPr>
+                </a:tc>
+                <a:tc>
+                  <a:txBody>
+                    <a:bodyPr wrap="square"/>
+                    <a:lstStyle/>
+                    <a:p>
+                      <a:pPr algn="ctr">
+                        <a:lnSpc>
+                          <a:spcPct val="100000"/>
+                        </a:lnSpc>
+                        <a:spcBef>
+                          <a:spcPts val="0"/>
+                        </a:spcBef>
+                        <a:spcAft>
+                          <a:spcPts val="0"/>
+                        </a:spcAft>
+                      </a:pPr>
+                      <a:r>
+                        <a:rPr sz="600" b="1">
+                          <a:solidFill>
+                            <a:srgbClr val="FFFFFF"/>
+                          </a:solidFill>
+                          <a:latin typeface="Calibri"/>
+                        </a:rPr>
+                        <a:t>06.27</a:t>
+                      </a:r>
+                    </a:p>
+                  </a:txBody>
+                  <a:tcPr anchor="ctr" marL="25400" marR="25400" marT="12700" marB="12700">
+                    <a:solidFill>
+                      <a:srgbClr val="570C17"/>
+                    </a:solidFill>
+                    <a:lnL w="6350" cap="flat" cmpd="sng" algn="ctr">
+                      <a:solidFill>
+                        <a:srgbClr val="E8C4C8"/>
+                      </a:solidFill>
+                    </a:lnL>
+                    <a:lnR w="6350" cap="flat" cmpd="sng" algn="ctr">
+                      <a:solidFill>
+                        <a:srgbClr val="E8C4C8"/>
+                      </a:solidFill>
+                    </a:lnR>
+                    <a:lnT w="6350" cap="flat" cmpd="sng" algn="ctr">
+                      <a:solidFill>
+                        <a:srgbClr val="E8C4C8"/>
+                      </a:solidFill>
+                    </a:lnT>
+                    <a:lnB w="6350" cap="flat" cmpd="sng" algn="ctr">
+                      <a:solidFill>
+                        <a:srgbClr val="E8C4C8"/>
+                      </a:solidFill>
+                    </a:lnB>
+                  </a:tcPr>
+                </a:tc>
+                <a:tc>
+                  <a:txBody>
+                    <a:bodyPr wrap="square"/>
+                    <a:lstStyle/>
+                    <a:p>
+                      <a:pPr algn="ctr">
+                        <a:lnSpc>
+                          <a:spcPct val="100000"/>
+                        </a:lnSpc>
+                        <a:spcBef>
+                          <a:spcPts val="0"/>
+                        </a:spcBef>
+                        <a:spcAft>
+                          <a:spcPts val="0"/>
+                        </a:spcAft>
+                      </a:pPr>
+                      <a:r>
+                        <a:rPr sz="600" b="1">
+                          <a:solidFill>
+                            <a:srgbClr val="FFFFFF"/>
+                          </a:solidFill>
+                          <a:latin typeface="Calibri"/>
+                        </a:rPr>
+                        <a:t>07.27</a:t>
+                      </a:r>
+                    </a:p>
+                  </a:txBody>
+                  <a:tcPr anchor="ctr" marL="25400" marR="25400" marT="12700" marB="12700">
+                    <a:solidFill>
+                      <a:srgbClr val="570C17"/>
+                    </a:solidFill>
+                    <a:lnL w="6350" cap="flat" cmpd="sng" algn="ctr">
+                      <a:solidFill>
+                        <a:srgbClr val="E8C4C8"/>
+                      </a:solidFill>
+                    </a:lnL>
+                    <a:lnR w="6350" cap="flat" cmpd="sng" algn="ctr">
+                      <a:solidFill>
+                        <a:srgbClr val="E8C4C8"/>
+                      </a:solidFill>
+                    </a:lnR>
+                    <a:lnT w="6350" cap="flat" cmpd="sng" algn="ctr">
+                      <a:solidFill>
+                        <a:srgbClr val="E8C4C8"/>
+                      </a:solidFill>
+                    </a:lnT>
+                    <a:lnB w="6350" cap="flat" cmpd="sng" algn="ctr">
+                      <a:solidFill>
+                        <a:srgbClr val="E8C4C8"/>
+                      </a:solidFill>
+                    </a:lnB>
+                  </a:tcPr>
+                </a:tc>
+                <a:tc>
+                  <a:txBody>
+                    <a:bodyPr wrap="square"/>
+                    <a:lstStyle/>
+                    <a:p>
+                      <a:pPr algn="ctr">
+                        <a:lnSpc>
+                          <a:spcPct val="100000"/>
+                        </a:lnSpc>
+                        <a:spcBef>
+                          <a:spcPts val="0"/>
+                        </a:spcBef>
+                        <a:spcAft>
+                          <a:spcPts val="0"/>
+                        </a:spcAft>
+                      </a:pPr>
+                      <a:r>
+                        <a:rPr sz="600" b="1">
+                          <a:solidFill>
+                            <a:srgbClr val="FFFFFF"/>
+                          </a:solidFill>
+                          <a:latin typeface="Calibri"/>
+                        </a:rPr>
+                        <a:t>08.27</a:t>
+                      </a:r>
+                    </a:p>
+                  </a:txBody>
+                  <a:tcPr anchor="ctr" marL="25400" marR="25400" marT="12700" marB="12700">
+                    <a:solidFill>
+                      <a:srgbClr val="570C17"/>
+                    </a:solidFill>
+                    <a:lnL w="6350" cap="flat" cmpd="sng" algn="ctr">
+                      <a:solidFill>
+                        <a:srgbClr val="E8C4C8"/>
+                      </a:solidFill>
+                    </a:lnL>
+                    <a:lnR w="6350" cap="flat" cmpd="sng" algn="ctr">
+                      <a:solidFill>
+                        <a:srgbClr val="E8C4C8"/>
+                      </a:solidFill>
+                    </a:lnR>
+                    <a:lnT w="6350" cap="flat" cmpd="sng" algn="ctr">
+                      <a:solidFill>
+                        <a:srgbClr val="E8C4C8"/>
+                      </a:solidFill>
+                    </a:lnT>
+                    <a:lnB w="6350" cap="flat" cmpd="sng" algn="ctr">
+                      <a:solidFill>
+                        <a:srgbClr val="E8C4C8"/>
+                      </a:solidFill>
+                    </a:lnB>
+                  </a:tcPr>
+                </a:tc>
+                <a:tc>
+                  <a:txBody>
+                    <a:bodyPr wrap="square"/>
+                    <a:lstStyle/>
+                    <a:p>
+                      <a:pPr algn="ctr">
+                        <a:lnSpc>
+                          <a:spcPct val="100000"/>
+                        </a:lnSpc>
+                        <a:spcBef>
+                          <a:spcPts val="0"/>
+                        </a:spcBef>
+                        <a:spcAft>
+                          <a:spcPts val="0"/>
+                        </a:spcAft>
+                      </a:pPr>
+                      <a:r>
+                        <a:rPr sz="600" b="1">
+                          <a:solidFill>
+                            <a:srgbClr val="FFFFFF"/>
+                          </a:solidFill>
+                          <a:latin typeface="Calibri"/>
+                        </a:rPr>
+                        <a:t>09.27</a:t>
+                      </a:r>
+                    </a:p>
+                  </a:txBody>
+                  <a:tcPr anchor="ctr" marL="25400" marR="25400" marT="12700" marB="12700">
+                    <a:solidFill>
+                      <a:srgbClr val="570C17"/>
+                    </a:solidFill>
+                    <a:lnL w="6350" cap="flat" cmpd="sng" algn="ctr">
+                      <a:solidFill>
+                        <a:srgbClr val="E8C4C8"/>
+                      </a:solidFill>
+                    </a:lnL>
+                    <a:lnR w="6350" cap="flat" cmpd="sng" algn="ctr">
+                      <a:solidFill>
+                        <a:srgbClr val="E8C4C8"/>
+                      </a:solidFill>
+                    </a:lnR>
+                    <a:lnT w="6350" cap="flat" cmpd="sng" algn="ctr">
+                      <a:solidFill>
+                        <a:srgbClr val="E8C4C8"/>
+                      </a:solidFill>
+                    </a:lnT>
+                    <a:lnB w="6350" cap="flat" cmpd="sng" algn="ctr">
+                      <a:solidFill>
+                        <a:srgbClr val="E8C4C8"/>
+                      </a:solidFill>
+                    </a:lnB>
+                  </a:tcPr>
+                </a:tc>
+                <a:tc>
+                  <a:txBody>
+                    <a:bodyPr wrap="square"/>
+                    <a:lstStyle/>
+                    <a:p>
+                      <a:pPr algn="ctr">
+                        <a:lnSpc>
+                          <a:spcPct val="100000"/>
+                        </a:lnSpc>
+                        <a:spcBef>
+                          <a:spcPts val="0"/>
+                        </a:spcBef>
+                        <a:spcAft>
+                          <a:spcPts val="0"/>
+                        </a:spcAft>
+                      </a:pPr>
+                      <a:r>
+                        <a:rPr sz="600" b="1">
+                          <a:solidFill>
+                            <a:srgbClr val="FFFFFF"/>
+                          </a:solidFill>
+                          <a:latin typeface="Calibri"/>
+                        </a:rPr>
                         <a:t>04.28</a:t>
-                      </a:r>
-                    </a:p>
-                  </a:txBody>
-                  <a:tcPr anchor="ctr" marL="25400" marR="25400" marT="12700" marB="12700">
-                    <a:solidFill>
-                      <a:srgbClr val="570C17"/>
-                    </a:solidFill>
-                    <a:lnL w="6350" cap="flat" cmpd="sng" algn="ctr">
-                      <a:solidFill>
-                        <a:srgbClr val="E8C4C8"/>
-                      </a:solidFill>
-                    </a:lnL>
-                    <a:lnR w="6350" cap="flat" cmpd="sng" algn="ctr">
-                      <a:solidFill>
-                        <a:srgbClr val="E8C4C8"/>
-                      </a:solidFill>
-                    </a:lnR>
-                    <a:lnT w="6350" cap="flat" cmpd="sng" algn="ctr">
-                      <a:solidFill>
-                        <a:srgbClr val="E8C4C8"/>
-                      </a:solidFill>
-                    </a:lnT>
-                    <a:lnB w="6350" cap="flat" cmpd="sng" algn="ctr">
-                      <a:solidFill>
-                        <a:srgbClr val="E8C4C8"/>
-                      </a:solidFill>
-                    </a:lnB>
-                  </a:tcPr>
-                </a:tc>
-                <a:tc>
-                  <a:txBody>
-                    <a:bodyPr wrap="square"/>
-                    <a:lstStyle/>
-                    <a:p>
-                      <a:pPr algn="ctr">
-                        <a:lnSpc>
-                          <a:spcPct val="100000"/>
-                        </a:lnSpc>
-                        <a:spcBef>
-                          <a:spcPts val="0"/>
-                        </a:spcBef>
-                        <a:spcAft>
-                          <a:spcPts val="0"/>
-                        </a:spcAft>
-                      </a:pPr>
-                      <a:r>
-                        <a:rPr sz="600" b="1">
-                          <a:solidFill>
-                            <a:srgbClr val="FFFFFF"/>
-                          </a:solidFill>
-                          <a:latin typeface="Calibri"/>
-                        </a:rPr>
-                        <a:t>05.27</a:t>
-                      </a:r>
-                    </a:p>
-                  </a:txBody>
-                  <a:tcPr anchor="ctr" marL="25400" marR="25400" marT="12700" marB="12700">
-                    <a:solidFill>
-                      <a:srgbClr val="570C17"/>
-                    </a:solidFill>
-                    <a:lnL w="6350" cap="flat" cmpd="sng" algn="ctr">
-                      <a:solidFill>
-                        <a:srgbClr val="E8C4C8"/>
-                      </a:solidFill>
-                    </a:lnL>
-                    <a:lnR w="6350" cap="flat" cmpd="sng" algn="ctr">
-                      <a:solidFill>
-                        <a:srgbClr val="E8C4C8"/>
-                      </a:solidFill>
-                    </a:lnR>
-                    <a:lnT w="6350" cap="flat" cmpd="sng" algn="ctr">
-                      <a:solidFill>
-                        <a:srgbClr val="E8C4C8"/>
-                      </a:solidFill>
-                    </a:lnT>
-                    <a:lnB w="6350" cap="flat" cmpd="sng" algn="ctr">
-                      <a:solidFill>
-                        <a:srgbClr val="E8C4C8"/>
-                      </a:solidFill>
-                    </a:lnB>
-                  </a:tcPr>
-                </a:tc>
-                <a:tc>
-                  <a:txBody>
-                    <a:bodyPr wrap="square"/>
-                    <a:lstStyle/>
-                    <a:p>
-                      <a:pPr algn="ctr">
-                        <a:lnSpc>
-                          <a:spcPct val="100000"/>
-                        </a:lnSpc>
-                        <a:spcBef>
-                          <a:spcPts val="0"/>
-                        </a:spcBef>
-                        <a:spcAft>
-                          <a:spcPts val="0"/>
-                        </a:spcAft>
-                      </a:pPr>
-                      <a:r>
-                        <a:rPr sz="600" b="1">
-                          <a:solidFill>
-                            <a:srgbClr val="FFFFFF"/>
-                          </a:solidFill>
-                          <a:latin typeface="Calibri"/>
-                        </a:rPr>
-                        <a:t>06.27</a:t>
-                      </a:r>
-                    </a:p>
-                  </a:txBody>
-                  <a:tcPr anchor="ctr" marL="25400" marR="25400" marT="12700" marB="12700">
-                    <a:solidFill>
-                      <a:srgbClr val="570C17"/>
-                    </a:solidFill>
-                    <a:lnL w="6350" cap="flat" cmpd="sng" algn="ctr">
-                      <a:solidFill>
-                        <a:srgbClr val="E8C4C8"/>
-                      </a:solidFill>
-                    </a:lnL>
-                    <a:lnR w="6350" cap="flat" cmpd="sng" algn="ctr">
-                      <a:solidFill>
-                        <a:srgbClr val="E8C4C8"/>
-                      </a:solidFill>
-                    </a:lnR>
-                    <a:lnT w="6350" cap="flat" cmpd="sng" algn="ctr">
-                      <a:solidFill>
-                        <a:srgbClr val="E8C4C8"/>
-                      </a:solidFill>
-                    </a:lnT>
-                    <a:lnB w="6350" cap="flat" cmpd="sng" algn="ctr">
-                      <a:solidFill>
-                        <a:srgbClr val="E8C4C8"/>
-                      </a:solidFill>
-                    </a:lnB>
-                  </a:tcPr>
-                </a:tc>
-                <a:tc>
-                  <a:txBody>
-                    <a:bodyPr wrap="square"/>
-                    <a:lstStyle/>
-                    <a:p>
-                      <a:pPr algn="ctr">
-                        <a:lnSpc>
-                          <a:spcPct val="100000"/>
-                        </a:lnSpc>
-                        <a:spcBef>
-                          <a:spcPts val="0"/>
-                        </a:spcBef>
-                        <a:spcAft>
-                          <a:spcPts val="0"/>
-                        </a:spcAft>
-                      </a:pPr>
-                      <a:r>
-                        <a:rPr sz="600" b="1">
-                          <a:solidFill>
-                            <a:srgbClr val="FFFFFF"/>
-                          </a:solidFill>
-                          <a:latin typeface="Calibri"/>
-                        </a:rPr>
-                        <a:t>07.27</a:t>
-                      </a:r>
-                    </a:p>
-                  </a:txBody>
-                  <a:tcPr anchor="ctr" marL="25400" marR="25400" marT="12700" marB="12700">
-                    <a:solidFill>
-                      <a:srgbClr val="570C17"/>
-                    </a:solidFill>
-                    <a:lnL w="6350" cap="flat" cmpd="sng" algn="ctr">
-                      <a:solidFill>
-                        <a:srgbClr val="E8C4C8"/>
-                      </a:solidFill>
-                    </a:lnL>
-                    <a:lnR w="6350" cap="flat" cmpd="sng" algn="ctr">
-                      <a:solidFill>
-                        <a:srgbClr val="E8C4C8"/>
-                      </a:solidFill>
-                    </a:lnR>
-                    <a:lnT w="6350" cap="flat" cmpd="sng" algn="ctr">
-                      <a:solidFill>
-                        <a:srgbClr val="E8C4C8"/>
-                      </a:solidFill>
-                    </a:lnT>
-                    <a:lnB w="6350" cap="flat" cmpd="sng" algn="ctr">
-                      <a:solidFill>
-                        <a:srgbClr val="E8C4C8"/>
-                      </a:solidFill>
-                    </a:lnB>
-                  </a:tcPr>
-                </a:tc>
-                <a:tc>
-                  <a:txBody>
-                    <a:bodyPr wrap="square"/>
-                    <a:lstStyle/>
-                    <a:p>
-                      <a:pPr algn="ctr">
-                        <a:lnSpc>
-                          <a:spcPct val="100000"/>
-                        </a:lnSpc>
-                        <a:spcBef>
-                          <a:spcPts val="0"/>
-                        </a:spcBef>
-                        <a:spcAft>
-                          <a:spcPts val="0"/>
-                        </a:spcAft>
-                      </a:pPr>
-                      <a:r>
-                        <a:rPr sz="600" b="1">
-                          <a:solidFill>
-                            <a:srgbClr val="FFFFFF"/>
-                          </a:solidFill>
-                          <a:latin typeface="Calibri"/>
-                        </a:rPr>
-                        <a:t>08.27</a:t>
-                      </a:r>
-                    </a:p>
-                  </a:txBody>
-                  <a:tcPr anchor="ctr" marL="25400" marR="25400" marT="12700" marB="12700">
-                    <a:solidFill>
-                      <a:srgbClr val="570C17"/>
-                    </a:solidFill>
-                    <a:lnL w="6350" cap="flat" cmpd="sng" algn="ctr">
-                      <a:solidFill>
-                        <a:srgbClr val="E8C4C8"/>
-                      </a:solidFill>
-                    </a:lnL>
-                    <a:lnR w="6350" cap="flat" cmpd="sng" algn="ctr">
-                      <a:solidFill>
-                        <a:srgbClr val="E8C4C8"/>
-                      </a:solidFill>
-                    </a:lnR>
-                    <a:lnT w="6350" cap="flat" cmpd="sng" algn="ctr">
-                      <a:solidFill>
-                        <a:srgbClr val="E8C4C8"/>
-                      </a:solidFill>
-                    </a:lnT>
-                    <a:lnB w="6350" cap="flat" cmpd="sng" algn="ctr">
-                      <a:solidFill>
-                        <a:srgbClr val="E8C4C8"/>
-                      </a:solidFill>
-                    </a:lnB>
-                  </a:tcPr>
-                </a:tc>
-                <a:tc>
-                  <a:txBody>
-                    <a:bodyPr wrap="square"/>
-                    <a:lstStyle/>
-                    <a:p>
-                      <a:pPr algn="ctr">
-                        <a:lnSpc>
-                          <a:spcPct val="100000"/>
-                        </a:lnSpc>
-                        <a:spcBef>
-                          <a:spcPts val="0"/>
-                        </a:spcBef>
-                        <a:spcAft>
-                          <a:spcPts val="0"/>
-                        </a:spcAft>
-                      </a:pPr>
-                      <a:r>
-                        <a:rPr sz="600" b="1">
-                          <a:solidFill>
-                            <a:srgbClr val="FFFFFF"/>
-                          </a:solidFill>
-                          <a:latin typeface="Calibri"/>
-                        </a:rPr>
-                        <a:t>09.27</a:t>
                       </a:r>
                     </a:p>
                   </a:txBody>
@@ -31433,6 +31385,59 @@
                     <a:bodyPr wrap="square"/>
                     <a:lstStyle/>
                     <a:p>
+                      <a:pPr algn="ctr">
+                        <a:lnSpc>
+                          <a:spcPct val="100000"/>
+                        </a:lnSpc>
+                        <a:spcBef>
+                          <a:spcPts val="0"/>
+                        </a:spcBef>
+                        <a:spcAft>
+                          <a:spcPts val="0"/>
+                        </a:spcAft>
+                      </a:pPr>
+                      <a:r>
+                        <a:rPr sz="500" b="0">
+                          <a:solidFill>
+                            <a:srgbClr val="962837"/>
+                          </a:solidFill>
+                          <a:latin typeface="Calibri"/>
+                        </a:rPr>
+                        <a:t>КЦ</a:t>
+                      </a:r>
+                    </a:p>
+                  </a:txBody>
+                  <a:tcPr anchor="ctr" marL="25400" marR="25400" marT="12700" marB="12700">
+                    <a:solidFill>
+                      <a:srgbClr val="FFD2D8"/>
+                    </a:solidFill>
+                    <a:lnL w="6350" cap="flat" cmpd="sng" algn="ctr">
+                      <a:solidFill>
+                        <a:srgbClr val="E8C4C8"/>
+                      </a:solidFill>
+                    </a:lnL>
+                    <a:lnR w="6350" cap="flat" cmpd="sng" algn="ctr">
+                      <a:solidFill>
+                        <a:srgbClr val="E8C4C8"/>
+                      </a:solidFill>
+                    </a:lnR>
+                    <a:lnT w="6350" cap="flat" cmpd="sng" algn="ctr">
+                      <a:solidFill>
+                        <a:srgbClr val="E8C4C8"/>
+                      </a:solidFill>
+                    </a:lnT>
+                    <a:lnB w="6350" cap="flat" cmpd="sng" algn="ctr">
+                      <a:solidFill>
+                        <a:srgbClr val="E8C4C8"/>
+                      </a:solidFill>
+                    </a:lnB>
+                  </a:tcPr>
+                </a:tc>
+                <a:tc>
+                  <a:txBody>
+                    <a:bodyPr wrap="square"/>
+                    <a:lstStyle/>
+                    <a:p>
                       <a:pPr algn="l">
                         <a:lnSpc>
                           <a:spcPct val="100000"/>
@@ -31458,59 +31463,6 @@
                   <a:tcPr anchor="ctr" marL="25400" marR="25400" marT="12700" marB="12700">
                     <a:solidFill>
                       <a:srgbClr val="FCF8F9"/>
-                    </a:solidFill>
-                    <a:lnL w="6350" cap="flat" cmpd="sng" algn="ctr">
-                      <a:solidFill>
-                        <a:srgbClr val="E8C4C8"/>
-                      </a:solidFill>
-                    </a:lnL>
-                    <a:lnR w="6350" cap="flat" cmpd="sng" algn="ctr">
-                      <a:solidFill>
-                        <a:srgbClr val="E8C4C8"/>
-                      </a:solidFill>
-                    </a:lnR>
-                    <a:lnT w="6350" cap="flat" cmpd="sng" algn="ctr">
-                      <a:solidFill>
-                        <a:srgbClr val="E8C4C8"/>
-                      </a:solidFill>
-                    </a:lnT>
-                    <a:lnB w="6350" cap="flat" cmpd="sng" algn="ctr">
-                      <a:solidFill>
-                        <a:srgbClr val="E8C4C8"/>
-                      </a:solidFill>
-                    </a:lnB>
-                  </a:tcPr>
-                </a:tc>
-                <a:tc>
-                  <a:txBody>
-                    <a:bodyPr wrap="square"/>
-                    <a:lstStyle/>
-                    <a:p>
-                      <a:pPr algn="ctr">
-                        <a:lnSpc>
-                          <a:spcPct val="100000"/>
-                        </a:lnSpc>
-                        <a:spcBef>
-                          <a:spcPts val="0"/>
-                        </a:spcBef>
-                        <a:spcAft>
-                          <a:spcPts val="0"/>
-                        </a:spcAft>
-                      </a:pPr>
-                      <a:r>
-                        <a:rPr sz="500" b="0">
-                          <a:solidFill>
-                            <a:srgbClr val="962837"/>
-                          </a:solidFill>
-                          <a:latin typeface="Calibri"/>
-                        </a:rPr>
-                        <a:t>КЦ</a:t>
-                      </a:r>
-                    </a:p>
-                  </a:txBody>
-                  <a:tcPr anchor="ctr" marL="25400" marR="25400" marT="12700" marB="12700">
-                    <a:solidFill>
-                      <a:srgbClr val="FFD2D8"/>
                     </a:solidFill>
                     <a:lnL w="6350" cap="flat" cmpd="sng" algn="ctr">
                       <a:solidFill>

</xml_diff>

<commit_message>
Sort and trim RTR launch schedule timeline columns (#13)
* Sort RTR launch schedule timeline columns by date ascending

Move Apr 2028 column after Sep 2027 so year/month headers are in
chronological order instead of 2028 appearing between 2027 months.

Co-authored-by: Artem Kostin <kostin.artem@gmail.com>

* Remove timeline columns before Jul 2026 from launch schedule CSV

Drop May and Jun 2026 columns (and their spacer) so the schedule
starts from July 2026.

Co-authored-by: Artem Kostin <kostin.artem@gmail.com>

* Regenerate RTR launch schedule presentation

Update График_запуска_RTR.pptx after sorting timeline columns and
removing months before Jul 2026.

Co-authored-by: Artem Kostin <kostin.artem@gmail.com>

---------

Co-authored-by: Cursor Agent <cursoragent@cursor.com>
</commit_message>
<xml_diff>
--- a/График_запуска_RTR.pptx
+++ b/График_запуска_RTR.pptx
@@ -3490,7 +3490,7 @@
                     </a:lnB>
                   </a:tcPr>
                 </a:tc>
-                <a:tc gridSpan="3">
+                <a:tc gridSpan="8">
                   <a:txBody>
                     <a:bodyPr wrap="square"/>
                     <a:lstStyle/>
@@ -3601,6 +3601,151 @@
                     </a:lnB>
                   </a:tcPr>
                 </a:tc>
+                <a:tc hMerge="1">
+                  <a:txBody>
+                    <a:bodyPr/>
+                    <a:lstStyle/>
+                    <a:p/>
+                  </a:txBody>
+                  <a:tcPr>
+                    <a:lnL w="6350" cap="flat" cmpd="sng" algn="ctr">
+                      <a:solidFill>
+                        <a:srgbClr val="E8C4C8"/>
+                      </a:solidFill>
+                    </a:lnL>
+                    <a:lnR w="6350" cap="flat" cmpd="sng" algn="ctr">
+                      <a:solidFill>
+                        <a:srgbClr val="E8C4C8"/>
+                      </a:solidFill>
+                    </a:lnR>
+                    <a:lnT w="6350" cap="flat" cmpd="sng" algn="ctr">
+                      <a:solidFill>
+                        <a:srgbClr val="E8C4C8"/>
+                      </a:solidFill>
+                    </a:lnT>
+                    <a:lnB w="6350" cap="flat" cmpd="sng" algn="ctr">
+                      <a:solidFill>
+                        <a:srgbClr val="E8C4C8"/>
+                      </a:solidFill>
+                    </a:lnB>
+                  </a:tcPr>
+                </a:tc>
+                <a:tc hMerge="1">
+                  <a:txBody>
+                    <a:bodyPr/>
+                    <a:lstStyle/>
+                    <a:p/>
+                  </a:txBody>
+                  <a:tcPr>
+                    <a:lnL w="6350" cap="flat" cmpd="sng" algn="ctr">
+                      <a:solidFill>
+                        <a:srgbClr val="E8C4C8"/>
+                      </a:solidFill>
+                    </a:lnL>
+                    <a:lnR w="6350" cap="flat" cmpd="sng" algn="ctr">
+                      <a:solidFill>
+                        <a:srgbClr val="E8C4C8"/>
+                      </a:solidFill>
+                    </a:lnR>
+                    <a:lnT w="6350" cap="flat" cmpd="sng" algn="ctr">
+                      <a:solidFill>
+                        <a:srgbClr val="E8C4C8"/>
+                      </a:solidFill>
+                    </a:lnT>
+                    <a:lnB w="6350" cap="flat" cmpd="sng" algn="ctr">
+                      <a:solidFill>
+                        <a:srgbClr val="E8C4C8"/>
+                      </a:solidFill>
+                    </a:lnB>
+                  </a:tcPr>
+                </a:tc>
+                <a:tc hMerge="1">
+                  <a:txBody>
+                    <a:bodyPr/>
+                    <a:lstStyle/>
+                    <a:p/>
+                  </a:txBody>
+                  <a:tcPr>
+                    <a:lnL w="6350" cap="flat" cmpd="sng" algn="ctr">
+                      <a:solidFill>
+                        <a:srgbClr val="E8C4C8"/>
+                      </a:solidFill>
+                    </a:lnL>
+                    <a:lnR w="6350" cap="flat" cmpd="sng" algn="ctr">
+                      <a:solidFill>
+                        <a:srgbClr val="E8C4C8"/>
+                      </a:solidFill>
+                    </a:lnR>
+                    <a:lnT w="6350" cap="flat" cmpd="sng" algn="ctr">
+                      <a:solidFill>
+                        <a:srgbClr val="E8C4C8"/>
+                      </a:solidFill>
+                    </a:lnT>
+                    <a:lnB w="6350" cap="flat" cmpd="sng" algn="ctr">
+                      <a:solidFill>
+                        <a:srgbClr val="E8C4C8"/>
+                      </a:solidFill>
+                    </a:lnB>
+                  </a:tcPr>
+                </a:tc>
+                <a:tc hMerge="1">
+                  <a:txBody>
+                    <a:bodyPr/>
+                    <a:lstStyle/>
+                    <a:p/>
+                  </a:txBody>
+                  <a:tcPr>
+                    <a:lnL w="6350" cap="flat" cmpd="sng" algn="ctr">
+                      <a:solidFill>
+                        <a:srgbClr val="E8C4C8"/>
+                      </a:solidFill>
+                    </a:lnL>
+                    <a:lnR w="6350" cap="flat" cmpd="sng" algn="ctr">
+                      <a:solidFill>
+                        <a:srgbClr val="E8C4C8"/>
+                      </a:solidFill>
+                    </a:lnR>
+                    <a:lnT w="6350" cap="flat" cmpd="sng" algn="ctr">
+                      <a:solidFill>
+                        <a:srgbClr val="E8C4C8"/>
+                      </a:solidFill>
+                    </a:lnT>
+                    <a:lnB w="6350" cap="flat" cmpd="sng" algn="ctr">
+                      <a:solidFill>
+                        <a:srgbClr val="E8C4C8"/>
+                      </a:solidFill>
+                    </a:lnB>
+                  </a:tcPr>
+                </a:tc>
+                <a:tc hMerge="1">
+                  <a:txBody>
+                    <a:bodyPr/>
+                    <a:lstStyle/>
+                    <a:p/>
+                  </a:txBody>
+                  <a:tcPr>
+                    <a:lnL w="6350" cap="flat" cmpd="sng" algn="ctr">
+                      <a:solidFill>
+                        <a:srgbClr val="E8C4C8"/>
+                      </a:solidFill>
+                    </a:lnL>
+                    <a:lnR w="6350" cap="flat" cmpd="sng" algn="ctr">
+                      <a:solidFill>
+                        <a:srgbClr val="E8C4C8"/>
+                      </a:solidFill>
+                    </a:lnR>
+                    <a:lnT w="6350" cap="flat" cmpd="sng" algn="ctr">
+                      <a:solidFill>
+                        <a:srgbClr val="E8C4C8"/>
+                      </a:solidFill>
+                    </a:lnT>
+                    <a:lnB w="6350" cap="flat" cmpd="sng" algn="ctr">
+                      <a:solidFill>
+                        <a:srgbClr val="E8C4C8"/>
+                      </a:solidFill>
+                    </a:lnB>
+                  </a:tcPr>
+                </a:tc>
                 <a:tc>
                   <a:txBody>
                     <a:bodyPr wrap="square"/>
@@ -3632,175 +3777,6 @@
                     <a:solidFill>
                       <a:srgbClr val="570C17"/>
                     </a:solidFill>
-                    <a:lnL w="6350" cap="flat" cmpd="sng" algn="ctr">
-                      <a:solidFill>
-                        <a:srgbClr val="E8C4C8"/>
-                      </a:solidFill>
-                    </a:lnL>
-                    <a:lnR w="6350" cap="flat" cmpd="sng" algn="ctr">
-                      <a:solidFill>
-                        <a:srgbClr val="E8C4C8"/>
-                      </a:solidFill>
-                    </a:lnR>
-                    <a:lnT w="6350" cap="flat" cmpd="sng" algn="ctr">
-                      <a:solidFill>
-                        <a:srgbClr val="E8C4C8"/>
-                      </a:solidFill>
-                    </a:lnT>
-                    <a:lnB w="6350" cap="flat" cmpd="sng" algn="ctr">
-                      <a:solidFill>
-                        <a:srgbClr val="E8C4C8"/>
-                      </a:solidFill>
-                    </a:lnB>
-                  </a:tcPr>
-                </a:tc>
-                <a:tc gridSpan="5">
-                  <a:txBody>
-                    <a:bodyPr wrap="square"/>
-                    <a:lstStyle/>
-                    <a:p>
-                      <a:pPr algn="ctr">
-                        <a:lnSpc>
-                          <a:spcPct val="100000"/>
-                        </a:lnSpc>
-                        <a:spcBef>
-                          <a:spcPts val="0"/>
-                        </a:spcBef>
-                        <a:spcAft>
-                          <a:spcPts val="0"/>
-                        </a:spcAft>
-                      </a:pPr>
-                      <a:r>
-                        <a:rPr sz="700" b="1">
-                          <a:solidFill>
-                            <a:srgbClr val="FFFFFF"/>
-                          </a:solidFill>
-                          <a:latin typeface="Calibri"/>
-                        </a:rPr>
-                        <a:t>2027</a:t>
-                      </a:r>
-                    </a:p>
-                  </a:txBody>
-                  <a:tcPr anchor="ctr" marL="25400" marR="25400" marT="12700" marB="12700">
-                    <a:solidFill>
-                      <a:srgbClr val="570C17"/>
-                    </a:solidFill>
-                    <a:lnL w="6350" cap="flat" cmpd="sng" algn="ctr">
-                      <a:solidFill>
-                        <a:srgbClr val="E8C4C8"/>
-                      </a:solidFill>
-                    </a:lnL>
-                    <a:lnR w="6350" cap="flat" cmpd="sng" algn="ctr">
-                      <a:solidFill>
-                        <a:srgbClr val="E8C4C8"/>
-                      </a:solidFill>
-                    </a:lnR>
-                    <a:lnT w="6350" cap="flat" cmpd="sng" algn="ctr">
-                      <a:solidFill>
-                        <a:srgbClr val="E8C4C8"/>
-                      </a:solidFill>
-                    </a:lnT>
-                    <a:lnB w="6350" cap="flat" cmpd="sng" algn="ctr">
-                      <a:solidFill>
-                        <a:srgbClr val="E8C4C8"/>
-                      </a:solidFill>
-                    </a:lnB>
-                  </a:tcPr>
-                </a:tc>
-                <a:tc hMerge="1">
-                  <a:txBody>
-                    <a:bodyPr/>
-                    <a:lstStyle/>
-                    <a:p/>
-                  </a:txBody>
-                  <a:tcPr>
-                    <a:lnL w="6350" cap="flat" cmpd="sng" algn="ctr">
-                      <a:solidFill>
-                        <a:srgbClr val="E8C4C8"/>
-                      </a:solidFill>
-                    </a:lnL>
-                    <a:lnR w="6350" cap="flat" cmpd="sng" algn="ctr">
-                      <a:solidFill>
-                        <a:srgbClr val="E8C4C8"/>
-                      </a:solidFill>
-                    </a:lnR>
-                    <a:lnT w="6350" cap="flat" cmpd="sng" algn="ctr">
-                      <a:solidFill>
-                        <a:srgbClr val="E8C4C8"/>
-                      </a:solidFill>
-                    </a:lnT>
-                    <a:lnB w="6350" cap="flat" cmpd="sng" algn="ctr">
-                      <a:solidFill>
-                        <a:srgbClr val="E8C4C8"/>
-                      </a:solidFill>
-                    </a:lnB>
-                  </a:tcPr>
-                </a:tc>
-                <a:tc hMerge="1">
-                  <a:txBody>
-                    <a:bodyPr/>
-                    <a:lstStyle/>
-                    <a:p/>
-                  </a:txBody>
-                  <a:tcPr>
-                    <a:lnL w="6350" cap="flat" cmpd="sng" algn="ctr">
-                      <a:solidFill>
-                        <a:srgbClr val="E8C4C8"/>
-                      </a:solidFill>
-                    </a:lnL>
-                    <a:lnR w="6350" cap="flat" cmpd="sng" algn="ctr">
-                      <a:solidFill>
-                        <a:srgbClr val="E8C4C8"/>
-                      </a:solidFill>
-                    </a:lnR>
-                    <a:lnT w="6350" cap="flat" cmpd="sng" algn="ctr">
-                      <a:solidFill>
-                        <a:srgbClr val="E8C4C8"/>
-                      </a:solidFill>
-                    </a:lnT>
-                    <a:lnB w="6350" cap="flat" cmpd="sng" algn="ctr">
-                      <a:solidFill>
-                        <a:srgbClr val="E8C4C8"/>
-                      </a:solidFill>
-                    </a:lnB>
-                  </a:tcPr>
-                </a:tc>
-                <a:tc hMerge="1">
-                  <a:txBody>
-                    <a:bodyPr/>
-                    <a:lstStyle/>
-                    <a:p/>
-                  </a:txBody>
-                  <a:tcPr>
-                    <a:lnL w="6350" cap="flat" cmpd="sng" algn="ctr">
-                      <a:solidFill>
-                        <a:srgbClr val="E8C4C8"/>
-                      </a:solidFill>
-                    </a:lnL>
-                    <a:lnR w="6350" cap="flat" cmpd="sng" algn="ctr">
-                      <a:solidFill>
-                        <a:srgbClr val="E8C4C8"/>
-                      </a:solidFill>
-                    </a:lnR>
-                    <a:lnT w="6350" cap="flat" cmpd="sng" algn="ctr">
-                      <a:solidFill>
-                        <a:srgbClr val="E8C4C8"/>
-                      </a:solidFill>
-                    </a:lnT>
-                    <a:lnB w="6350" cap="flat" cmpd="sng" algn="ctr">
-                      <a:solidFill>
-                        <a:srgbClr val="E8C4C8"/>
-                      </a:solidFill>
-                    </a:lnB>
-                  </a:tcPr>
-                </a:tc>
-                <a:tc hMerge="1">
-                  <a:txBody>
-                    <a:bodyPr/>
-                    <a:lstStyle/>
-                    <a:p/>
-                  </a:txBody>
-                  <a:tcPr>
                     <a:lnL w="6350" cap="flat" cmpd="sng" algn="ctr">
                       <a:solidFill>
                         <a:srgbClr val="E8C4C8"/>
@@ -4383,272 +4359,272 @@
                           </a:solidFill>
                           <a:latin typeface="Calibri"/>
                         </a:rPr>
+                        <a:t>05.27</a:t>
+                      </a:r>
+                    </a:p>
+                  </a:txBody>
+                  <a:tcPr anchor="ctr" marL="25400" marR="25400" marT="12700" marB="12700">
+                    <a:solidFill>
+                      <a:srgbClr val="570C17"/>
+                    </a:solidFill>
+                    <a:lnL w="6350" cap="flat" cmpd="sng" algn="ctr">
+                      <a:solidFill>
+                        <a:srgbClr val="E8C4C8"/>
+                      </a:solidFill>
+                    </a:lnL>
+                    <a:lnR w="6350" cap="flat" cmpd="sng" algn="ctr">
+                      <a:solidFill>
+                        <a:srgbClr val="E8C4C8"/>
+                      </a:solidFill>
+                    </a:lnR>
+                    <a:lnT w="6350" cap="flat" cmpd="sng" algn="ctr">
+                      <a:solidFill>
+                        <a:srgbClr val="E8C4C8"/>
+                      </a:solidFill>
+                    </a:lnT>
+                    <a:lnB w="6350" cap="flat" cmpd="sng" algn="ctr">
+                      <a:solidFill>
+                        <a:srgbClr val="E8C4C8"/>
+                      </a:solidFill>
+                    </a:lnB>
+                  </a:tcPr>
+                </a:tc>
+                <a:tc>
+                  <a:txBody>
+                    <a:bodyPr wrap="square"/>
+                    <a:lstStyle/>
+                    <a:p>
+                      <a:pPr algn="ctr">
+                        <a:lnSpc>
+                          <a:spcPct val="100000"/>
+                        </a:lnSpc>
+                        <a:spcBef>
+                          <a:spcPts val="0"/>
+                        </a:spcBef>
+                        <a:spcAft>
+                          <a:spcPts val="0"/>
+                        </a:spcAft>
+                      </a:pPr>
+                      <a:r>
+                        <a:rPr sz="600" b="1">
+                          <a:solidFill>
+                            <a:srgbClr val="FFFFFF"/>
+                          </a:solidFill>
+                          <a:latin typeface="Calibri"/>
+                        </a:rPr>
+                        <a:t>06.27</a:t>
+                      </a:r>
+                    </a:p>
+                  </a:txBody>
+                  <a:tcPr anchor="ctr" marL="25400" marR="25400" marT="12700" marB="12700">
+                    <a:solidFill>
+                      <a:srgbClr val="570C17"/>
+                    </a:solidFill>
+                    <a:lnL w="6350" cap="flat" cmpd="sng" algn="ctr">
+                      <a:solidFill>
+                        <a:srgbClr val="E8C4C8"/>
+                      </a:solidFill>
+                    </a:lnL>
+                    <a:lnR w="6350" cap="flat" cmpd="sng" algn="ctr">
+                      <a:solidFill>
+                        <a:srgbClr val="E8C4C8"/>
+                      </a:solidFill>
+                    </a:lnR>
+                    <a:lnT w="6350" cap="flat" cmpd="sng" algn="ctr">
+                      <a:solidFill>
+                        <a:srgbClr val="E8C4C8"/>
+                      </a:solidFill>
+                    </a:lnT>
+                    <a:lnB w="6350" cap="flat" cmpd="sng" algn="ctr">
+                      <a:solidFill>
+                        <a:srgbClr val="E8C4C8"/>
+                      </a:solidFill>
+                    </a:lnB>
+                  </a:tcPr>
+                </a:tc>
+                <a:tc>
+                  <a:txBody>
+                    <a:bodyPr wrap="square"/>
+                    <a:lstStyle/>
+                    <a:p>
+                      <a:pPr algn="ctr">
+                        <a:lnSpc>
+                          <a:spcPct val="100000"/>
+                        </a:lnSpc>
+                        <a:spcBef>
+                          <a:spcPts val="0"/>
+                        </a:spcBef>
+                        <a:spcAft>
+                          <a:spcPts val="0"/>
+                        </a:spcAft>
+                      </a:pPr>
+                      <a:r>
+                        <a:rPr sz="600" b="1">
+                          <a:solidFill>
+                            <a:srgbClr val="FFFFFF"/>
+                          </a:solidFill>
+                          <a:latin typeface="Calibri"/>
+                        </a:rPr>
+                        <a:t>07.27</a:t>
+                      </a:r>
+                    </a:p>
+                  </a:txBody>
+                  <a:tcPr anchor="ctr" marL="25400" marR="25400" marT="12700" marB="12700">
+                    <a:solidFill>
+                      <a:srgbClr val="570C17"/>
+                    </a:solidFill>
+                    <a:lnL w="6350" cap="flat" cmpd="sng" algn="ctr">
+                      <a:solidFill>
+                        <a:srgbClr val="E8C4C8"/>
+                      </a:solidFill>
+                    </a:lnL>
+                    <a:lnR w="6350" cap="flat" cmpd="sng" algn="ctr">
+                      <a:solidFill>
+                        <a:srgbClr val="E8C4C8"/>
+                      </a:solidFill>
+                    </a:lnR>
+                    <a:lnT w="6350" cap="flat" cmpd="sng" algn="ctr">
+                      <a:solidFill>
+                        <a:srgbClr val="E8C4C8"/>
+                      </a:solidFill>
+                    </a:lnT>
+                    <a:lnB w="6350" cap="flat" cmpd="sng" algn="ctr">
+                      <a:solidFill>
+                        <a:srgbClr val="E8C4C8"/>
+                      </a:solidFill>
+                    </a:lnB>
+                  </a:tcPr>
+                </a:tc>
+                <a:tc>
+                  <a:txBody>
+                    <a:bodyPr wrap="square"/>
+                    <a:lstStyle/>
+                    <a:p>
+                      <a:pPr algn="ctr">
+                        <a:lnSpc>
+                          <a:spcPct val="100000"/>
+                        </a:lnSpc>
+                        <a:spcBef>
+                          <a:spcPts val="0"/>
+                        </a:spcBef>
+                        <a:spcAft>
+                          <a:spcPts val="0"/>
+                        </a:spcAft>
+                      </a:pPr>
+                      <a:r>
+                        <a:rPr sz="600" b="1">
+                          <a:solidFill>
+                            <a:srgbClr val="FFFFFF"/>
+                          </a:solidFill>
+                          <a:latin typeface="Calibri"/>
+                        </a:rPr>
+                        <a:t>08.27</a:t>
+                      </a:r>
+                    </a:p>
+                  </a:txBody>
+                  <a:tcPr anchor="ctr" marL="25400" marR="25400" marT="12700" marB="12700">
+                    <a:solidFill>
+                      <a:srgbClr val="570C17"/>
+                    </a:solidFill>
+                    <a:lnL w="6350" cap="flat" cmpd="sng" algn="ctr">
+                      <a:solidFill>
+                        <a:srgbClr val="E8C4C8"/>
+                      </a:solidFill>
+                    </a:lnL>
+                    <a:lnR w="6350" cap="flat" cmpd="sng" algn="ctr">
+                      <a:solidFill>
+                        <a:srgbClr val="E8C4C8"/>
+                      </a:solidFill>
+                    </a:lnR>
+                    <a:lnT w="6350" cap="flat" cmpd="sng" algn="ctr">
+                      <a:solidFill>
+                        <a:srgbClr val="E8C4C8"/>
+                      </a:solidFill>
+                    </a:lnT>
+                    <a:lnB w="6350" cap="flat" cmpd="sng" algn="ctr">
+                      <a:solidFill>
+                        <a:srgbClr val="E8C4C8"/>
+                      </a:solidFill>
+                    </a:lnB>
+                  </a:tcPr>
+                </a:tc>
+                <a:tc>
+                  <a:txBody>
+                    <a:bodyPr wrap="square"/>
+                    <a:lstStyle/>
+                    <a:p>
+                      <a:pPr algn="ctr">
+                        <a:lnSpc>
+                          <a:spcPct val="100000"/>
+                        </a:lnSpc>
+                        <a:spcBef>
+                          <a:spcPts val="0"/>
+                        </a:spcBef>
+                        <a:spcAft>
+                          <a:spcPts val="0"/>
+                        </a:spcAft>
+                      </a:pPr>
+                      <a:r>
+                        <a:rPr sz="600" b="1">
+                          <a:solidFill>
+                            <a:srgbClr val="FFFFFF"/>
+                          </a:solidFill>
+                          <a:latin typeface="Calibri"/>
+                        </a:rPr>
+                        <a:t>09.27</a:t>
+                      </a:r>
+                    </a:p>
+                  </a:txBody>
+                  <a:tcPr anchor="ctr" marL="25400" marR="25400" marT="12700" marB="12700">
+                    <a:solidFill>
+                      <a:srgbClr val="570C17"/>
+                    </a:solidFill>
+                    <a:lnL w="6350" cap="flat" cmpd="sng" algn="ctr">
+                      <a:solidFill>
+                        <a:srgbClr val="E8C4C8"/>
+                      </a:solidFill>
+                    </a:lnL>
+                    <a:lnR w="6350" cap="flat" cmpd="sng" algn="ctr">
+                      <a:solidFill>
+                        <a:srgbClr val="E8C4C8"/>
+                      </a:solidFill>
+                    </a:lnR>
+                    <a:lnT w="6350" cap="flat" cmpd="sng" algn="ctr">
+                      <a:solidFill>
+                        <a:srgbClr val="E8C4C8"/>
+                      </a:solidFill>
+                    </a:lnT>
+                    <a:lnB w="6350" cap="flat" cmpd="sng" algn="ctr">
+                      <a:solidFill>
+                        <a:srgbClr val="E8C4C8"/>
+                      </a:solidFill>
+                    </a:lnB>
+                  </a:tcPr>
+                </a:tc>
+                <a:tc>
+                  <a:txBody>
+                    <a:bodyPr wrap="square"/>
+                    <a:lstStyle/>
+                    <a:p>
+                      <a:pPr algn="ctr">
+                        <a:lnSpc>
+                          <a:spcPct val="100000"/>
+                        </a:lnSpc>
+                        <a:spcBef>
+                          <a:spcPts val="0"/>
+                        </a:spcBef>
+                        <a:spcAft>
+                          <a:spcPts val="0"/>
+                        </a:spcAft>
+                      </a:pPr>
+                      <a:r>
+                        <a:rPr sz="600" b="1">
+                          <a:solidFill>
+                            <a:srgbClr val="FFFFFF"/>
+                          </a:solidFill>
+                          <a:latin typeface="Calibri"/>
+                        </a:rPr>
                         <a:t>04.28</a:t>
-                      </a:r>
-                    </a:p>
-                  </a:txBody>
-                  <a:tcPr anchor="ctr" marL="25400" marR="25400" marT="12700" marB="12700">
-                    <a:solidFill>
-                      <a:srgbClr val="570C17"/>
-                    </a:solidFill>
-                    <a:lnL w="6350" cap="flat" cmpd="sng" algn="ctr">
-                      <a:solidFill>
-                        <a:srgbClr val="E8C4C8"/>
-                      </a:solidFill>
-                    </a:lnL>
-                    <a:lnR w="6350" cap="flat" cmpd="sng" algn="ctr">
-                      <a:solidFill>
-                        <a:srgbClr val="E8C4C8"/>
-                      </a:solidFill>
-                    </a:lnR>
-                    <a:lnT w="6350" cap="flat" cmpd="sng" algn="ctr">
-                      <a:solidFill>
-                        <a:srgbClr val="E8C4C8"/>
-                      </a:solidFill>
-                    </a:lnT>
-                    <a:lnB w="6350" cap="flat" cmpd="sng" algn="ctr">
-                      <a:solidFill>
-                        <a:srgbClr val="E8C4C8"/>
-                      </a:solidFill>
-                    </a:lnB>
-                  </a:tcPr>
-                </a:tc>
-                <a:tc>
-                  <a:txBody>
-                    <a:bodyPr wrap="square"/>
-                    <a:lstStyle/>
-                    <a:p>
-                      <a:pPr algn="ctr">
-                        <a:lnSpc>
-                          <a:spcPct val="100000"/>
-                        </a:lnSpc>
-                        <a:spcBef>
-                          <a:spcPts val="0"/>
-                        </a:spcBef>
-                        <a:spcAft>
-                          <a:spcPts val="0"/>
-                        </a:spcAft>
-                      </a:pPr>
-                      <a:r>
-                        <a:rPr sz="600" b="1">
-                          <a:solidFill>
-                            <a:srgbClr val="FFFFFF"/>
-                          </a:solidFill>
-                          <a:latin typeface="Calibri"/>
-                        </a:rPr>
-                        <a:t>05.27</a:t>
-                      </a:r>
-                    </a:p>
-                  </a:txBody>
-                  <a:tcPr anchor="ctr" marL="25400" marR="25400" marT="12700" marB="12700">
-                    <a:solidFill>
-                      <a:srgbClr val="570C17"/>
-                    </a:solidFill>
-                    <a:lnL w="6350" cap="flat" cmpd="sng" algn="ctr">
-                      <a:solidFill>
-                        <a:srgbClr val="E8C4C8"/>
-                      </a:solidFill>
-                    </a:lnL>
-                    <a:lnR w="6350" cap="flat" cmpd="sng" algn="ctr">
-                      <a:solidFill>
-                        <a:srgbClr val="E8C4C8"/>
-                      </a:solidFill>
-                    </a:lnR>
-                    <a:lnT w="6350" cap="flat" cmpd="sng" algn="ctr">
-                      <a:solidFill>
-                        <a:srgbClr val="E8C4C8"/>
-                      </a:solidFill>
-                    </a:lnT>
-                    <a:lnB w="6350" cap="flat" cmpd="sng" algn="ctr">
-                      <a:solidFill>
-                        <a:srgbClr val="E8C4C8"/>
-                      </a:solidFill>
-                    </a:lnB>
-                  </a:tcPr>
-                </a:tc>
-                <a:tc>
-                  <a:txBody>
-                    <a:bodyPr wrap="square"/>
-                    <a:lstStyle/>
-                    <a:p>
-                      <a:pPr algn="ctr">
-                        <a:lnSpc>
-                          <a:spcPct val="100000"/>
-                        </a:lnSpc>
-                        <a:spcBef>
-                          <a:spcPts val="0"/>
-                        </a:spcBef>
-                        <a:spcAft>
-                          <a:spcPts val="0"/>
-                        </a:spcAft>
-                      </a:pPr>
-                      <a:r>
-                        <a:rPr sz="600" b="1">
-                          <a:solidFill>
-                            <a:srgbClr val="FFFFFF"/>
-                          </a:solidFill>
-                          <a:latin typeface="Calibri"/>
-                        </a:rPr>
-                        <a:t>06.27</a:t>
-                      </a:r>
-                    </a:p>
-                  </a:txBody>
-                  <a:tcPr anchor="ctr" marL="25400" marR="25400" marT="12700" marB="12700">
-                    <a:solidFill>
-                      <a:srgbClr val="570C17"/>
-                    </a:solidFill>
-                    <a:lnL w="6350" cap="flat" cmpd="sng" algn="ctr">
-                      <a:solidFill>
-                        <a:srgbClr val="E8C4C8"/>
-                      </a:solidFill>
-                    </a:lnL>
-                    <a:lnR w="6350" cap="flat" cmpd="sng" algn="ctr">
-                      <a:solidFill>
-                        <a:srgbClr val="E8C4C8"/>
-                      </a:solidFill>
-                    </a:lnR>
-                    <a:lnT w="6350" cap="flat" cmpd="sng" algn="ctr">
-                      <a:solidFill>
-                        <a:srgbClr val="E8C4C8"/>
-                      </a:solidFill>
-                    </a:lnT>
-                    <a:lnB w="6350" cap="flat" cmpd="sng" algn="ctr">
-                      <a:solidFill>
-                        <a:srgbClr val="E8C4C8"/>
-                      </a:solidFill>
-                    </a:lnB>
-                  </a:tcPr>
-                </a:tc>
-                <a:tc>
-                  <a:txBody>
-                    <a:bodyPr wrap="square"/>
-                    <a:lstStyle/>
-                    <a:p>
-                      <a:pPr algn="ctr">
-                        <a:lnSpc>
-                          <a:spcPct val="100000"/>
-                        </a:lnSpc>
-                        <a:spcBef>
-                          <a:spcPts val="0"/>
-                        </a:spcBef>
-                        <a:spcAft>
-                          <a:spcPts val="0"/>
-                        </a:spcAft>
-                      </a:pPr>
-                      <a:r>
-                        <a:rPr sz="600" b="1">
-                          <a:solidFill>
-                            <a:srgbClr val="FFFFFF"/>
-                          </a:solidFill>
-                          <a:latin typeface="Calibri"/>
-                        </a:rPr>
-                        <a:t>07.27</a:t>
-                      </a:r>
-                    </a:p>
-                  </a:txBody>
-                  <a:tcPr anchor="ctr" marL="25400" marR="25400" marT="12700" marB="12700">
-                    <a:solidFill>
-                      <a:srgbClr val="570C17"/>
-                    </a:solidFill>
-                    <a:lnL w="6350" cap="flat" cmpd="sng" algn="ctr">
-                      <a:solidFill>
-                        <a:srgbClr val="E8C4C8"/>
-                      </a:solidFill>
-                    </a:lnL>
-                    <a:lnR w="6350" cap="flat" cmpd="sng" algn="ctr">
-                      <a:solidFill>
-                        <a:srgbClr val="E8C4C8"/>
-                      </a:solidFill>
-                    </a:lnR>
-                    <a:lnT w="6350" cap="flat" cmpd="sng" algn="ctr">
-                      <a:solidFill>
-                        <a:srgbClr val="E8C4C8"/>
-                      </a:solidFill>
-                    </a:lnT>
-                    <a:lnB w="6350" cap="flat" cmpd="sng" algn="ctr">
-                      <a:solidFill>
-                        <a:srgbClr val="E8C4C8"/>
-                      </a:solidFill>
-                    </a:lnB>
-                  </a:tcPr>
-                </a:tc>
-                <a:tc>
-                  <a:txBody>
-                    <a:bodyPr wrap="square"/>
-                    <a:lstStyle/>
-                    <a:p>
-                      <a:pPr algn="ctr">
-                        <a:lnSpc>
-                          <a:spcPct val="100000"/>
-                        </a:lnSpc>
-                        <a:spcBef>
-                          <a:spcPts val="0"/>
-                        </a:spcBef>
-                        <a:spcAft>
-                          <a:spcPts val="0"/>
-                        </a:spcAft>
-                      </a:pPr>
-                      <a:r>
-                        <a:rPr sz="600" b="1">
-                          <a:solidFill>
-                            <a:srgbClr val="FFFFFF"/>
-                          </a:solidFill>
-                          <a:latin typeface="Calibri"/>
-                        </a:rPr>
-                        <a:t>08.27</a:t>
-                      </a:r>
-                    </a:p>
-                  </a:txBody>
-                  <a:tcPr anchor="ctr" marL="25400" marR="25400" marT="12700" marB="12700">
-                    <a:solidFill>
-                      <a:srgbClr val="570C17"/>
-                    </a:solidFill>
-                    <a:lnL w="6350" cap="flat" cmpd="sng" algn="ctr">
-                      <a:solidFill>
-                        <a:srgbClr val="E8C4C8"/>
-                      </a:solidFill>
-                    </a:lnL>
-                    <a:lnR w="6350" cap="flat" cmpd="sng" algn="ctr">
-                      <a:solidFill>
-                        <a:srgbClr val="E8C4C8"/>
-                      </a:solidFill>
-                    </a:lnR>
-                    <a:lnT w="6350" cap="flat" cmpd="sng" algn="ctr">
-                      <a:solidFill>
-                        <a:srgbClr val="E8C4C8"/>
-                      </a:solidFill>
-                    </a:lnT>
-                    <a:lnB w="6350" cap="flat" cmpd="sng" algn="ctr">
-                      <a:solidFill>
-                        <a:srgbClr val="E8C4C8"/>
-                      </a:solidFill>
-                    </a:lnB>
-                  </a:tcPr>
-                </a:tc>
-                <a:tc>
-                  <a:txBody>
-                    <a:bodyPr wrap="square"/>
-                    <a:lstStyle/>
-                    <a:p>
-                      <a:pPr algn="ctr">
-                        <a:lnSpc>
-                          <a:spcPct val="100000"/>
-                        </a:lnSpc>
-                        <a:spcBef>
-                          <a:spcPts val="0"/>
-                        </a:spcBef>
-                        <a:spcAft>
-                          <a:spcPts val="0"/>
-                        </a:spcAft>
-                      </a:pPr>
-                      <a:r>
-                        <a:rPr sz="600" b="1">
-                          <a:solidFill>
-                            <a:srgbClr val="FFFFFF"/>
-                          </a:solidFill>
-                          <a:latin typeface="Calibri"/>
-                        </a:rPr>
-                        <a:t>09.27</a:t>
                       </a:r>
                     </a:p>
                   </a:txBody>
@@ -7094,6 +7070,271 @@
                           </a:solidFill>
                           <a:latin typeface="Calibri"/>
                         </a:rPr>
+                        <a:t>ППК Тюмень</a:t>
+                      </a:r>
+                    </a:p>
+                  </a:txBody>
+                  <a:tcPr anchor="ctr" marL="25400" marR="25400" marT="12700" marB="12700">
+                    <a:solidFill>
+                      <a:srgbClr val="FFD2D8"/>
+                    </a:solidFill>
+                    <a:lnL w="6350" cap="flat" cmpd="sng" algn="ctr">
+                      <a:solidFill>
+                        <a:srgbClr val="E8C4C8"/>
+                      </a:solidFill>
+                    </a:lnL>
+                    <a:lnR w="6350" cap="flat" cmpd="sng" algn="ctr">
+                      <a:solidFill>
+                        <a:srgbClr val="E8C4C8"/>
+                      </a:solidFill>
+                    </a:lnR>
+                    <a:lnT w="6350" cap="flat" cmpd="sng" algn="ctr">
+                      <a:solidFill>
+                        <a:srgbClr val="E8C4C8"/>
+                      </a:solidFill>
+                    </a:lnT>
+                    <a:lnB w="6350" cap="flat" cmpd="sng" algn="ctr">
+                      <a:solidFill>
+                        <a:srgbClr val="E8C4C8"/>
+                      </a:solidFill>
+                    </a:lnB>
+                  </a:tcPr>
+                </a:tc>
+                <a:tc>
+                  <a:txBody>
+                    <a:bodyPr wrap="square"/>
+                    <a:lstStyle/>
+                    <a:p>
+                      <a:pPr algn="ctr">
+                        <a:lnSpc>
+                          <a:spcPct val="100000"/>
+                        </a:lnSpc>
+                        <a:spcBef>
+                          <a:spcPts val="0"/>
+                        </a:spcBef>
+                        <a:spcAft>
+                          <a:spcPts val="0"/>
+                        </a:spcAft>
+                      </a:pPr>
+                      <a:r>
+                        <a:rPr sz="500" b="0">
+                          <a:solidFill>
+                            <a:srgbClr val="962837"/>
+                          </a:solidFill>
+                          <a:latin typeface="Calibri"/>
+                        </a:rPr>
+                        <a:t>ППК Москва МСП</a:t>
+                      </a:r>
+                    </a:p>
+                  </a:txBody>
+                  <a:tcPr anchor="ctr" marL="25400" marR="25400" marT="12700" marB="12700">
+                    <a:solidFill>
+                      <a:srgbClr val="FFD2D8"/>
+                    </a:solidFill>
+                    <a:lnL w="6350" cap="flat" cmpd="sng" algn="ctr">
+                      <a:solidFill>
+                        <a:srgbClr val="E8C4C8"/>
+                      </a:solidFill>
+                    </a:lnL>
+                    <a:lnR w="6350" cap="flat" cmpd="sng" algn="ctr">
+                      <a:solidFill>
+                        <a:srgbClr val="E8C4C8"/>
+                      </a:solidFill>
+                    </a:lnR>
+                    <a:lnT w="6350" cap="flat" cmpd="sng" algn="ctr">
+                      <a:solidFill>
+                        <a:srgbClr val="E8C4C8"/>
+                      </a:solidFill>
+                    </a:lnT>
+                    <a:lnB w="6350" cap="flat" cmpd="sng" algn="ctr">
+                      <a:solidFill>
+                        <a:srgbClr val="E8C4C8"/>
+                      </a:solidFill>
+                    </a:lnB>
+                  </a:tcPr>
+                </a:tc>
+                <a:tc>
+                  <a:txBody>
+                    <a:bodyPr wrap="square"/>
+                    <a:lstStyle/>
+                    <a:p>
+                      <a:pPr algn="l">
+                        <a:lnSpc>
+                          <a:spcPct val="100000"/>
+                        </a:lnSpc>
+                        <a:spcBef>
+                          <a:spcPts val="0"/>
+                        </a:spcBef>
+                        <a:spcAft>
+                          <a:spcPts val="0"/>
+                        </a:spcAft>
+                      </a:pPr>
+                      <a:r>
+                        <a:rPr sz="500" b="0">
+                          <a:solidFill>
+                            <a:srgbClr val="323232"/>
+                          </a:solidFill>
+                          <a:latin typeface="Calibri"/>
+                        </a:rPr>
+                        <a:t/>
+                      </a:r>
+                    </a:p>
+                  </a:txBody>
+                  <a:tcPr anchor="ctr" marL="25400" marR="25400" marT="12700" marB="12700">
+                    <a:solidFill>
+                      <a:srgbClr val="FFFFFF"/>
+                    </a:solidFill>
+                    <a:lnL w="6350" cap="flat" cmpd="sng" algn="ctr">
+                      <a:solidFill>
+                        <a:srgbClr val="E8C4C8"/>
+                      </a:solidFill>
+                    </a:lnL>
+                    <a:lnR w="6350" cap="flat" cmpd="sng" algn="ctr">
+                      <a:solidFill>
+                        <a:srgbClr val="E8C4C8"/>
+                      </a:solidFill>
+                    </a:lnR>
+                    <a:lnT w="6350" cap="flat" cmpd="sng" algn="ctr">
+                      <a:solidFill>
+                        <a:srgbClr val="E8C4C8"/>
+                      </a:solidFill>
+                    </a:lnT>
+                    <a:lnB w="6350" cap="flat" cmpd="sng" algn="ctr">
+                      <a:solidFill>
+                        <a:srgbClr val="E8C4C8"/>
+                      </a:solidFill>
+                    </a:lnB>
+                  </a:tcPr>
+                </a:tc>
+                <a:tc>
+                  <a:txBody>
+                    <a:bodyPr wrap="square"/>
+                    <a:lstStyle/>
+                    <a:p>
+                      <a:pPr algn="ctr">
+                        <a:lnSpc>
+                          <a:spcPct val="100000"/>
+                        </a:lnSpc>
+                        <a:spcBef>
+                          <a:spcPts val="0"/>
+                        </a:spcBef>
+                        <a:spcAft>
+                          <a:spcPts val="0"/>
+                        </a:spcAft>
+                      </a:pPr>
+                      <a:r>
+                        <a:rPr sz="500" b="0">
+                          <a:solidFill>
+                            <a:srgbClr val="962837"/>
+                          </a:solidFill>
+                          <a:latin typeface="Calibri"/>
+                        </a:rPr>
+                        <a:t>КЦ</a:t>
+                      </a:r>
+                    </a:p>
+                  </a:txBody>
+                  <a:tcPr anchor="ctr" marL="25400" marR="25400" marT="12700" marB="12700">
+                    <a:solidFill>
+                      <a:srgbClr val="FFD2D8"/>
+                    </a:solidFill>
+                    <a:lnL w="6350" cap="flat" cmpd="sng" algn="ctr">
+                      <a:solidFill>
+                        <a:srgbClr val="E8C4C8"/>
+                      </a:solidFill>
+                    </a:lnL>
+                    <a:lnR w="6350" cap="flat" cmpd="sng" algn="ctr">
+                      <a:solidFill>
+                        <a:srgbClr val="E8C4C8"/>
+                      </a:solidFill>
+                    </a:lnR>
+                    <a:lnT w="6350" cap="flat" cmpd="sng" algn="ctr">
+                      <a:solidFill>
+                        <a:srgbClr val="E8C4C8"/>
+                      </a:solidFill>
+                    </a:lnT>
+                    <a:lnB w="6350" cap="flat" cmpd="sng" algn="ctr">
+                      <a:solidFill>
+                        <a:srgbClr val="E8C4C8"/>
+                      </a:solidFill>
+                    </a:lnB>
+                  </a:tcPr>
+                </a:tc>
+                <a:tc>
+                  <a:txBody>
+                    <a:bodyPr wrap="square"/>
+                    <a:lstStyle/>
+                    <a:p>
+                      <a:pPr algn="l">
+                        <a:lnSpc>
+                          <a:spcPct val="100000"/>
+                        </a:lnSpc>
+                        <a:spcBef>
+                          <a:spcPts val="0"/>
+                        </a:spcBef>
+                        <a:spcAft>
+                          <a:spcPts val="0"/>
+                        </a:spcAft>
+                      </a:pPr>
+                      <a:r>
+                        <a:rPr sz="500" b="0">
+                          <a:solidFill>
+                            <a:srgbClr val="323232"/>
+                          </a:solidFill>
+                          <a:latin typeface="Calibri"/>
+                        </a:rPr>
+                        <a:t/>
+                      </a:r>
+                    </a:p>
+                  </a:txBody>
+                  <a:tcPr anchor="ctr" marL="25400" marR="25400" marT="12700" marB="12700">
+                    <a:solidFill>
+                      <a:srgbClr val="FFFFFF"/>
+                    </a:solidFill>
+                    <a:lnL w="6350" cap="flat" cmpd="sng" algn="ctr">
+                      <a:solidFill>
+                        <a:srgbClr val="E8C4C8"/>
+                      </a:solidFill>
+                    </a:lnL>
+                    <a:lnR w="6350" cap="flat" cmpd="sng" algn="ctr">
+                      <a:solidFill>
+                        <a:srgbClr val="E8C4C8"/>
+                      </a:solidFill>
+                    </a:lnR>
+                    <a:lnT w="6350" cap="flat" cmpd="sng" algn="ctr">
+                      <a:solidFill>
+                        <a:srgbClr val="E8C4C8"/>
+                      </a:solidFill>
+                    </a:lnT>
+                    <a:lnB w="6350" cap="flat" cmpd="sng" algn="ctr">
+                      <a:solidFill>
+                        <a:srgbClr val="E8C4C8"/>
+                      </a:solidFill>
+                    </a:lnB>
+                  </a:tcPr>
+                </a:tc>
+                <a:tc>
+                  <a:txBody>
+                    <a:bodyPr wrap="square"/>
+                    <a:lstStyle/>
+                    <a:p>
+                      <a:pPr algn="ctr">
+                        <a:lnSpc>
+                          <a:spcPct val="100000"/>
+                        </a:lnSpc>
+                        <a:spcBef>
+                          <a:spcPts val="0"/>
+                        </a:spcBef>
+                        <a:spcAft>
+                          <a:spcPts val="0"/>
+                        </a:spcAft>
+                      </a:pPr>
+                      <a:r>
+                        <a:rPr sz="500" b="0">
+                          <a:solidFill>
+                            <a:srgbClr val="962837"/>
+                          </a:solidFill>
+                          <a:latin typeface="Calibri"/>
+                        </a:rPr>
                         <a:t>Честный знак</a:t>
                       </a:r>
                     </a:p>
@@ -7101,271 +7342,6 @@
                   <a:tcPr anchor="ctr" marL="25400" marR="25400" marT="12700" marB="12700">
                     <a:solidFill>
                       <a:srgbClr val="FFD2D8"/>
-                    </a:solidFill>
-                    <a:lnL w="6350" cap="flat" cmpd="sng" algn="ctr">
-                      <a:solidFill>
-                        <a:srgbClr val="E8C4C8"/>
-                      </a:solidFill>
-                    </a:lnL>
-                    <a:lnR w="6350" cap="flat" cmpd="sng" algn="ctr">
-                      <a:solidFill>
-                        <a:srgbClr val="E8C4C8"/>
-                      </a:solidFill>
-                    </a:lnR>
-                    <a:lnT w="6350" cap="flat" cmpd="sng" algn="ctr">
-                      <a:solidFill>
-                        <a:srgbClr val="E8C4C8"/>
-                      </a:solidFill>
-                    </a:lnT>
-                    <a:lnB w="6350" cap="flat" cmpd="sng" algn="ctr">
-                      <a:solidFill>
-                        <a:srgbClr val="E8C4C8"/>
-                      </a:solidFill>
-                    </a:lnB>
-                  </a:tcPr>
-                </a:tc>
-                <a:tc>
-                  <a:txBody>
-                    <a:bodyPr wrap="square"/>
-                    <a:lstStyle/>
-                    <a:p>
-                      <a:pPr algn="ctr">
-                        <a:lnSpc>
-                          <a:spcPct val="100000"/>
-                        </a:lnSpc>
-                        <a:spcBef>
-                          <a:spcPts val="0"/>
-                        </a:spcBef>
-                        <a:spcAft>
-                          <a:spcPts val="0"/>
-                        </a:spcAft>
-                      </a:pPr>
-                      <a:r>
-                        <a:rPr sz="500" b="0">
-                          <a:solidFill>
-                            <a:srgbClr val="962837"/>
-                          </a:solidFill>
-                          <a:latin typeface="Calibri"/>
-                        </a:rPr>
-                        <a:t>ППК Тюмень</a:t>
-                      </a:r>
-                    </a:p>
-                  </a:txBody>
-                  <a:tcPr anchor="ctr" marL="25400" marR="25400" marT="12700" marB="12700">
-                    <a:solidFill>
-                      <a:srgbClr val="FFD2D8"/>
-                    </a:solidFill>
-                    <a:lnL w="6350" cap="flat" cmpd="sng" algn="ctr">
-                      <a:solidFill>
-                        <a:srgbClr val="E8C4C8"/>
-                      </a:solidFill>
-                    </a:lnL>
-                    <a:lnR w="6350" cap="flat" cmpd="sng" algn="ctr">
-                      <a:solidFill>
-                        <a:srgbClr val="E8C4C8"/>
-                      </a:solidFill>
-                    </a:lnR>
-                    <a:lnT w="6350" cap="flat" cmpd="sng" algn="ctr">
-                      <a:solidFill>
-                        <a:srgbClr val="E8C4C8"/>
-                      </a:solidFill>
-                    </a:lnT>
-                    <a:lnB w="6350" cap="flat" cmpd="sng" algn="ctr">
-                      <a:solidFill>
-                        <a:srgbClr val="E8C4C8"/>
-                      </a:solidFill>
-                    </a:lnB>
-                  </a:tcPr>
-                </a:tc>
-                <a:tc>
-                  <a:txBody>
-                    <a:bodyPr wrap="square"/>
-                    <a:lstStyle/>
-                    <a:p>
-                      <a:pPr algn="ctr">
-                        <a:lnSpc>
-                          <a:spcPct val="100000"/>
-                        </a:lnSpc>
-                        <a:spcBef>
-                          <a:spcPts val="0"/>
-                        </a:spcBef>
-                        <a:spcAft>
-                          <a:spcPts val="0"/>
-                        </a:spcAft>
-                      </a:pPr>
-                      <a:r>
-                        <a:rPr sz="500" b="0">
-                          <a:solidFill>
-                            <a:srgbClr val="962837"/>
-                          </a:solidFill>
-                          <a:latin typeface="Calibri"/>
-                        </a:rPr>
-                        <a:t>ППК Москва МСП</a:t>
-                      </a:r>
-                    </a:p>
-                  </a:txBody>
-                  <a:tcPr anchor="ctr" marL="25400" marR="25400" marT="12700" marB="12700">
-                    <a:solidFill>
-                      <a:srgbClr val="FFD2D8"/>
-                    </a:solidFill>
-                    <a:lnL w="6350" cap="flat" cmpd="sng" algn="ctr">
-                      <a:solidFill>
-                        <a:srgbClr val="E8C4C8"/>
-                      </a:solidFill>
-                    </a:lnL>
-                    <a:lnR w="6350" cap="flat" cmpd="sng" algn="ctr">
-                      <a:solidFill>
-                        <a:srgbClr val="E8C4C8"/>
-                      </a:solidFill>
-                    </a:lnR>
-                    <a:lnT w="6350" cap="flat" cmpd="sng" algn="ctr">
-                      <a:solidFill>
-                        <a:srgbClr val="E8C4C8"/>
-                      </a:solidFill>
-                    </a:lnT>
-                    <a:lnB w="6350" cap="flat" cmpd="sng" algn="ctr">
-                      <a:solidFill>
-                        <a:srgbClr val="E8C4C8"/>
-                      </a:solidFill>
-                    </a:lnB>
-                  </a:tcPr>
-                </a:tc>
-                <a:tc>
-                  <a:txBody>
-                    <a:bodyPr wrap="square"/>
-                    <a:lstStyle/>
-                    <a:p>
-                      <a:pPr algn="l">
-                        <a:lnSpc>
-                          <a:spcPct val="100000"/>
-                        </a:lnSpc>
-                        <a:spcBef>
-                          <a:spcPts val="0"/>
-                        </a:spcBef>
-                        <a:spcAft>
-                          <a:spcPts val="0"/>
-                        </a:spcAft>
-                      </a:pPr>
-                      <a:r>
-                        <a:rPr sz="500" b="0">
-                          <a:solidFill>
-                            <a:srgbClr val="323232"/>
-                          </a:solidFill>
-                          <a:latin typeface="Calibri"/>
-                        </a:rPr>
-                        <a:t/>
-                      </a:r>
-                    </a:p>
-                  </a:txBody>
-                  <a:tcPr anchor="ctr" marL="25400" marR="25400" marT="12700" marB="12700">
-                    <a:solidFill>
-                      <a:srgbClr val="FFFFFF"/>
-                    </a:solidFill>
-                    <a:lnL w="6350" cap="flat" cmpd="sng" algn="ctr">
-                      <a:solidFill>
-                        <a:srgbClr val="E8C4C8"/>
-                      </a:solidFill>
-                    </a:lnL>
-                    <a:lnR w="6350" cap="flat" cmpd="sng" algn="ctr">
-                      <a:solidFill>
-                        <a:srgbClr val="E8C4C8"/>
-                      </a:solidFill>
-                    </a:lnR>
-                    <a:lnT w="6350" cap="flat" cmpd="sng" algn="ctr">
-                      <a:solidFill>
-                        <a:srgbClr val="E8C4C8"/>
-                      </a:solidFill>
-                    </a:lnT>
-                    <a:lnB w="6350" cap="flat" cmpd="sng" algn="ctr">
-                      <a:solidFill>
-                        <a:srgbClr val="E8C4C8"/>
-                      </a:solidFill>
-                    </a:lnB>
-                  </a:tcPr>
-                </a:tc>
-                <a:tc>
-                  <a:txBody>
-                    <a:bodyPr wrap="square"/>
-                    <a:lstStyle/>
-                    <a:p>
-                      <a:pPr algn="ctr">
-                        <a:lnSpc>
-                          <a:spcPct val="100000"/>
-                        </a:lnSpc>
-                        <a:spcBef>
-                          <a:spcPts val="0"/>
-                        </a:spcBef>
-                        <a:spcAft>
-                          <a:spcPts val="0"/>
-                        </a:spcAft>
-                      </a:pPr>
-                      <a:r>
-                        <a:rPr sz="500" b="0">
-                          <a:solidFill>
-                            <a:srgbClr val="962837"/>
-                          </a:solidFill>
-                          <a:latin typeface="Calibri"/>
-                        </a:rPr>
-                        <a:t>КЦ</a:t>
-                      </a:r>
-                    </a:p>
-                  </a:txBody>
-                  <a:tcPr anchor="ctr" marL="25400" marR="25400" marT="12700" marB="12700">
-                    <a:solidFill>
-                      <a:srgbClr val="FFD2D8"/>
-                    </a:solidFill>
-                    <a:lnL w="6350" cap="flat" cmpd="sng" algn="ctr">
-                      <a:solidFill>
-                        <a:srgbClr val="E8C4C8"/>
-                      </a:solidFill>
-                    </a:lnL>
-                    <a:lnR w="6350" cap="flat" cmpd="sng" algn="ctr">
-                      <a:solidFill>
-                        <a:srgbClr val="E8C4C8"/>
-                      </a:solidFill>
-                    </a:lnR>
-                    <a:lnT w="6350" cap="flat" cmpd="sng" algn="ctr">
-                      <a:solidFill>
-                        <a:srgbClr val="E8C4C8"/>
-                      </a:solidFill>
-                    </a:lnT>
-                    <a:lnB w="6350" cap="flat" cmpd="sng" algn="ctr">
-                      <a:solidFill>
-                        <a:srgbClr val="E8C4C8"/>
-                      </a:solidFill>
-                    </a:lnB>
-                  </a:tcPr>
-                </a:tc>
-                <a:tc>
-                  <a:txBody>
-                    <a:bodyPr wrap="square"/>
-                    <a:lstStyle/>
-                    <a:p>
-                      <a:pPr algn="l">
-                        <a:lnSpc>
-                          <a:spcPct val="100000"/>
-                        </a:lnSpc>
-                        <a:spcBef>
-                          <a:spcPts val="0"/>
-                        </a:spcBef>
-                        <a:spcAft>
-                          <a:spcPts val="0"/>
-                        </a:spcAft>
-                      </a:pPr>
-                      <a:r>
-                        <a:rPr sz="500" b="0">
-                          <a:solidFill>
-                            <a:srgbClr val="323232"/>
-                          </a:solidFill>
-                          <a:latin typeface="Calibri"/>
-                        </a:rPr>
-                        <a:t/>
-                      </a:r>
-                    </a:p>
-                  </a:txBody>
-                  <a:tcPr anchor="ctr" marL="25400" marR="25400" marT="12700" marB="12700">
-                    <a:solidFill>
-                      <a:srgbClr val="FFFFFF"/>
                     </a:solidFill>
                     <a:lnL w="6350" cap="flat" cmpd="sng" algn="ctr">
                       <a:solidFill>
@@ -9785,6 +9761,165 @@
                     <a:bodyPr wrap="square"/>
                     <a:lstStyle/>
                     <a:p>
+                      <a:pPr algn="l">
+                        <a:lnSpc>
+                          <a:spcPct val="100000"/>
+                        </a:lnSpc>
+                        <a:spcBef>
+                          <a:spcPts val="0"/>
+                        </a:spcBef>
+                        <a:spcAft>
+                          <a:spcPts val="0"/>
+                        </a:spcAft>
+                      </a:pPr>
+                      <a:r>
+                        <a:rPr sz="500" b="0">
+                          <a:solidFill>
+                            <a:srgbClr val="323232"/>
+                          </a:solidFill>
+                          <a:latin typeface="Calibri"/>
+                        </a:rPr>
+                        <a:t/>
+                      </a:r>
+                    </a:p>
+                  </a:txBody>
+                  <a:tcPr anchor="ctr" marL="25400" marR="25400" marT="12700" marB="12700">
+                    <a:solidFill>
+                      <a:srgbClr val="FCF8F9"/>
+                    </a:solidFill>
+                    <a:lnL w="6350" cap="flat" cmpd="sng" algn="ctr">
+                      <a:solidFill>
+                        <a:srgbClr val="E8C4C8"/>
+                      </a:solidFill>
+                    </a:lnL>
+                    <a:lnR w="6350" cap="flat" cmpd="sng" algn="ctr">
+                      <a:solidFill>
+                        <a:srgbClr val="E8C4C8"/>
+                      </a:solidFill>
+                    </a:lnR>
+                    <a:lnT w="6350" cap="flat" cmpd="sng" algn="ctr">
+                      <a:solidFill>
+                        <a:srgbClr val="E8C4C8"/>
+                      </a:solidFill>
+                    </a:lnT>
+                    <a:lnB w="6350" cap="flat" cmpd="sng" algn="ctr">
+                      <a:solidFill>
+                        <a:srgbClr val="E8C4C8"/>
+                      </a:solidFill>
+                    </a:lnB>
+                  </a:tcPr>
+                </a:tc>
+                <a:tc>
+                  <a:txBody>
+                    <a:bodyPr wrap="square"/>
+                    <a:lstStyle/>
+                    <a:p>
+                      <a:pPr algn="l">
+                        <a:lnSpc>
+                          <a:spcPct val="100000"/>
+                        </a:lnSpc>
+                        <a:spcBef>
+                          <a:spcPts val="0"/>
+                        </a:spcBef>
+                        <a:spcAft>
+                          <a:spcPts val="0"/>
+                        </a:spcAft>
+                      </a:pPr>
+                      <a:r>
+                        <a:rPr sz="500" b="0">
+                          <a:solidFill>
+                            <a:srgbClr val="323232"/>
+                          </a:solidFill>
+                          <a:latin typeface="Calibri"/>
+                        </a:rPr>
+                        <a:t/>
+                      </a:r>
+                    </a:p>
+                  </a:txBody>
+                  <a:tcPr anchor="ctr" marL="25400" marR="25400" marT="12700" marB="12700">
+                    <a:solidFill>
+                      <a:srgbClr val="FCF8F9"/>
+                    </a:solidFill>
+                    <a:lnL w="6350" cap="flat" cmpd="sng" algn="ctr">
+                      <a:solidFill>
+                        <a:srgbClr val="E8C4C8"/>
+                      </a:solidFill>
+                    </a:lnL>
+                    <a:lnR w="6350" cap="flat" cmpd="sng" algn="ctr">
+                      <a:solidFill>
+                        <a:srgbClr val="E8C4C8"/>
+                      </a:solidFill>
+                    </a:lnR>
+                    <a:lnT w="6350" cap="flat" cmpd="sng" algn="ctr">
+                      <a:solidFill>
+                        <a:srgbClr val="E8C4C8"/>
+                      </a:solidFill>
+                    </a:lnT>
+                    <a:lnB w="6350" cap="flat" cmpd="sng" algn="ctr">
+                      <a:solidFill>
+                        <a:srgbClr val="E8C4C8"/>
+                      </a:solidFill>
+                    </a:lnB>
+                  </a:tcPr>
+                </a:tc>
+                <a:tc>
+                  <a:txBody>
+                    <a:bodyPr wrap="square"/>
+                    <a:lstStyle/>
+                    <a:p>
+                      <a:pPr algn="l">
+                        <a:lnSpc>
+                          <a:spcPct val="100000"/>
+                        </a:lnSpc>
+                        <a:spcBef>
+                          <a:spcPts val="0"/>
+                        </a:spcBef>
+                        <a:spcAft>
+                          <a:spcPts val="0"/>
+                        </a:spcAft>
+                      </a:pPr>
+                      <a:r>
+                        <a:rPr sz="500" b="0">
+                          <a:solidFill>
+                            <a:srgbClr val="323232"/>
+                          </a:solidFill>
+                          <a:latin typeface="Calibri"/>
+                        </a:rPr>
+                        <a:t/>
+                      </a:r>
+                    </a:p>
+                  </a:txBody>
+                  <a:tcPr anchor="ctr" marL="25400" marR="25400" marT="12700" marB="12700">
+                    <a:solidFill>
+                      <a:srgbClr val="FCF8F9"/>
+                    </a:solidFill>
+                    <a:lnL w="6350" cap="flat" cmpd="sng" algn="ctr">
+                      <a:solidFill>
+                        <a:srgbClr val="E8C4C8"/>
+                      </a:solidFill>
+                    </a:lnL>
+                    <a:lnR w="6350" cap="flat" cmpd="sng" algn="ctr">
+                      <a:solidFill>
+                        <a:srgbClr val="E8C4C8"/>
+                      </a:solidFill>
+                    </a:lnR>
+                    <a:lnT w="6350" cap="flat" cmpd="sng" algn="ctr">
+                      <a:solidFill>
+                        <a:srgbClr val="E8C4C8"/>
+                      </a:solidFill>
+                    </a:lnT>
+                    <a:lnB w="6350" cap="flat" cmpd="sng" algn="ctr">
+                      <a:solidFill>
+                        <a:srgbClr val="E8C4C8"/>
+                      </a:solidFill>
+                    </a:lnB>
+                  </a:tcPr>
+                </a:tc>
+                <a:tc>
+                  <a:txBody>
+                    <a:bodyPr wrap="square"/>
+                    <a:lstStyle/>
+                    <a:p>
                       <a:pPr algn="ctr">
                         <a:lnSpc>
                           <a:spcPct val="100000"/>
@@ -9803,6 +9938,112 @@
                           </a:solidFill>
                           <a:latin typeface="Calibri"/>
                         </a:rPr>
+                        <a:t>КЦ</a:t>
+                      </a:r>
+                    </a:p>
+                  </a:txBody>
+                  <a:tcPr anchor="ctr" marL="25400" marR="25400" marT="12700" marB="12700">
+                    <a:solidFill>
+                      <a:srgbClr val="FFD2D8"/>
+                    </a:solidFill>
+                    <a:lnL w="6350" cap="flat" cmpd="sng" algn="ctr">
+                      <a:solidFill>
+                        <a:srgbClr val="E8C4C8"/>
+                      </a:solidFill>
+                    </a:lnL>
+                    <a:lnR w="6350" cap="flat" cmpd="sng" algn="ctr">
+                      <a:solidFill>
+                        <a:srgbClr val="E8C4C8"/>
+                      </a:solidFill>
+                    </a:lnR>
+                    <a:lnT w="6350" cap="flat" cmpd="sng" algn="ctr">
+                      <a:solidFill>
+                        <a:srgbClr val="E8C4C8"/>
+                      </a:solidFill>
+                    </a:lnT>
+                    <a:lnB w="6350" cap="flat" cmpd="sng" algn="ctr">
+                      <a:solidFill>
+                        <a:srgbClr val="E8C4C8"/>
+                      </a:solidFill>
+                    </a:lnB>
+                  </a:tcPr>
+                </a:tc>
+                <a:tc>
+                  <a:txBody>
+                    <a:bodyPr wrap="square"/>
+                    <a:lstStyle/>
+                    <a:p>
+                      <a:pPr algn="l">
+                        <a:lnSpc>
+                          <a:spcPct val="100000"/>
+                        </a:lnSpc>
+                        <a:spcBef>
+                          <a:spcPts val="0"/>
+                        </a:spcBef>
+                        <a:spcAft>
+                          <a:spcPts val="0"/>
+                        </a:spcAft>
+                      </a:pPr>
+                      <a:r>
+                        <a:rPr sz="500" b="0">
+                          <a:solidFill>
+                            <a:srgbClr val="323232"/>
+                          </a:solidFill>
+                          <a:latin typeface="Calibri"/>
+                        </a:rPr>
+                        <a:t/>
+                      </a:r>
+                    </a:p>
+                  </a:txBody>
+                  <a:tcPr anchor="ctr" marL="25400" marR="25400" marT="12700" marB="12700">
+                    <a:solidFill>
+                      <a:srgbClr val="FCF8F9"/>
+                    </a:solidFill>
+                    <a:lnL w="6350" cap="flat" cmpd="sng" algn="ctr">
+                      <a:solidFill>
+                        <a:srgbClr val="E8C4C8"/>
+                      </a:solidFill>
+                    </a:lnL>
+                    <a:lnR w="6350" cap="flat" cmpd="sng" algn="ctr">
+                      <a:solidFill>
+                        <a:srgbClr val="E8C4C8"/>
+                      </a:solidFill>
+                    </a:lnR>
+                    <a:lnT w="6350" cap="flat" cmpd="sng" algn="ctr">
+                      <a:solidFill>
+                        <a:srgbClr val="E8C4C8"/>
+                      </a:solidFill>
+                    </a:lnT>
+                    <a:lnB w="6350" cap="flat" cmpd="sng" algn="ctr">
+                      <a:solidFill>
+                        <a:srgbClr val="E8C4C8"/>
+                      </a:solidFill>
+                    </a:lnB>
+                  </a:tcPr>
+                </a:tc>
+                <a:tc>
+                  <a:txBody>
+                    <a:bodyPr wrap="square"/>
+                    <a:lstStyle/>
+                    <a:p>
+                      <a:pPr algn="ctr">
+                        <a:lnSpc>
+                          <a:spcPct val="100000"/>
+                        </a:lnSpc>
+                        <a:spcBef>
+                          <a:spcPts val="0"/>
+                        </a:spcBef>
+                        <a:spcAft>
+                          <a:spcPts val="0"/>
+                        </a:spcAft>
+                      </a:pPr>
+                      <a:r>
+                        <a:rPr sz="500" b="0">
+                          <a:solidFill>
+                            <a:srgbClr val="962837"/>
+                          </a:solidFill>
+                          <a:latin typeface="Calibri"/>
+                        </a:rPr>
                         <a:t>Честный знак</a:t>
                       </a:r>
                     </a:p>
@@ -9810,271 +10051,6 @@
                   <a:tcPr anchor="ctr" marL="25400" marR="25400" marT="12700" marB="12700">
                     <a:solidFill>
                       <a:srgbClr val="FFD2D8"/>
-                    </a:solidFill>
-                    <a:lnL w="6350" cap="flat" cmpd="sng" algn="ctr">
-                      <a:solidFill>
-                        <a:srgbClr val="E8C4C8"/>
-                      </a:solidFill>
-                    </a:lnL>
-                    <a:lnR w="6350" cap="flat" cmpd="sng" algn="ctr">
-                      <a:solidFill>
-                        <a:srgbClr val="E8C4C8"/>
-                      </a:solidFill>
-                    </a:lnR>
-                    <a:lnT w="6350" cap="flat" cmpd="sng" algn="ctr">
-                      <a:solidFill>
-                        <a:srgbClr val="E8C4C8"/>
-                      </a:solidFill>
-                    </a:lnT>
-                    <a:lnB w="6350" cap="flat" cmpd="sng" algn="ctr">
-                      <a:solidFill>
-                        <a:srgbClr val="E8C4C8"/>
-                      </a:solidFill>
-                    </a:lnB>
-                  </a:tcPr>
-                </a:tc>
-                <a:tc>
-                  <a:txBody>
-                    <a:bodyPr wrap="square"/>
-                    <a:lstStyle/>
-                    <a:p>
-                      <a:pPr algn="l">
-                        <a:lnSpc>
-                          <a:spcPct val="100000"/>
-                        </a:lnSpc>
-                        <a:spcBef>
-                          <a:spcPts val="0"/>
-                        </a:spcBef>
-                        <a:spcAft>
-                          <a:spcPts val="0"/>
-                        </a:spcAft>
-                      </a:pPr>
-                      <a:r>
-                        <a:rPr sz="500" b="0">
-                          <a:solidFill>
-                            <a:srgbClr val="323232"/>
-                          </a:solidFill>
-                          <a:latin typeface="Calibri"/>
-                        </a:rPr>
-                        <a:t/>
-                      </a:r>
-                    </a:p>
-                  </a:txBody>
-                  <a:tcPr anchor="ctr" marL="25400" marR="25400" marT="12700" marB="12700">
-                    <a:solidFill>
-                      <a:srgbClr val="FCF8F9"/>
-                    </a:solidFill>
-                    <a:lnL w="6350" cap="flat" cmpd="sng" algn="ctr">
-                      <a:solidFill>
-                        <a:srgbClr val="E8C4C8"/>
-                      </a:solidFill>
-                    </a:lnL>
-                    <a:lnR w="6350" cap="flat" cmpd="sng" algn="ctr">
-                      <a:solidFill>
-                        <a:srgbClr val="E8C4C8"/>
-                      </a:solidFill>
-                    </a:lnR>
-                    <a:lnT w="6350" cap="flat" cmpd="sng" algn="ctr">
-                      <a:solidFill>
-                        <a:srgbClr val="E8C4C8"/>
-                      </a:solidFill>
-                    </a:lnT>
-                    <a:lnB w="6350" cap="flat" cmpd="sng" algn="ctr">
-                      <a:solidFill>
-                        <a:srgbClr val="E8C4C8"/>
-                      </a:solidFill>
-                    </a:lnB>
-                  </a:tcPr>
-                </a:tc>
-                <a:tc>
-                  <a:txBody>
-                    <a:bodyPr wrap="square"/>
-                    <a:lstStyle/>
-                    <a:p>
-                      <a:pPr algn="l">
-                        <a:lnSpc>
-                          <a:spcPct val="100000"/>
-                        </a:lnSpc>
-                        <a:spcBef>
-                          <a:spcPts val="0"/>
-                        </a:spcBef>
-                        <a:spcAft>
-                          <a:spcPts val="0"/>
-                        </a:spcAft>
-                      </a:pPr>
-                      <a:r>
-                        <a:rPr sz="500" b="0">
-                          <a:solidFill>
-                            <a:srgbClr val="323232"/>
-                          </a:solidFill>
-                          <a:latin typeface="Calibri"/>
-                        </a:rPr>
-                        <a:t/>
-                      </a:r>
-                    </a:p>
-                  </a:txBody>
-                  <a:tcPr anchor="ctr" marL="25400" marR="25400" marT="12700" marB="12700">
-                    <a:solidFill>
-                      <a:srgbClr val="FCF8F9"/>
-                    </a:solidFill>
-                    <a:lnL w="6350" cap="flat" cmpd="sng" algn="ctr">
-                      <a:solidFill>
-                        <a:srgbClr val="E8C4C8"/>
-                      </a:solidFill>
-                    </a:lnL>
-                    <a:lnR w="6350" cap="flat" cmpd="sng" algn="ctr">
-                      <a:solidFill>
-                        <a:srgbClr val="E8C4C8"/>
-                      </a:solidFill>
-                    </a:lnR>
-                    <a:lnT w="6350" cap="flat" cmpd="sng" algn="ctr">
-                      <a:solidFill>
-                        <a:srgbClr val="E8C4C8"/>
-                      </a:solidFill>
-                    </a:lnT>
-                    <a:lnB w="6350" cap="flat" cmpd="sng" algn="ctr">
-                      <a:solidFill>
-                        <a:srgbClr val="E8C4C8"/>
-                      </a:solidFill>
-                    </a:lnB>
-                  </a:tcPr>
-                </a:tc>
-                <a:tc>
-                  <a:txBody>
-                    <a:bodyPr wrap="square"/>
-                    <a:lstStyle/>
-                    <a:p>
-                      <a:pPr algn="l">
-                        <a:lnSpc>
-                          <a:spcPct val="100000"/>
-                        </a:lnSpc>
-                        <a:spcBef>
-                          <a:spcPts val="0"/>
-                        </a:spcBef>
-                        <a:spcAft>
-                          <a:spcPts val="0"/>
-                        </a:spcAft>
-                      </a:pPr>
-                      <a:r>
-                        <a:rPr sz="500" b="0">
-                          <a:solidFill>
-                            <a:srgbClr val="323232"/>
-                          </a:solidFill>
-                          <a:latin typeface="Calibri"/>
-                        </a:rPr>
-                        <a:t/>
-                      </a:r>
-                    </a:p>
-                  </a:txBody>
-                  <a:tcPr anchor="ctr" marL="25400" marR="25400" marT="12700" marB="12700">
-                    <a:solidFill>
-                      <a:srgbClr val="FCF8F9"/>
-                    </a:solidFill>
-                    <a:lnL w="6350" cap="flat" cmpd="sng" algn="ctr">
-                      <a:solidFill>
-                        <a:srgbClr val="E8C4C8"/>
-                      </a:solidFill>
-                    </a:lnL>
-                    <a:lnR w="6350" cap="flat" cmpd="sng" algn="ctr">
-                      <a:solidFill>
-                        <a:srgbClr val="E8C4C8"/>
-                      </a:solidFill>
-                    </a:lnR>
-                    <a:lnT w="6350" cap="flat" cmpd="sng" algn="ctr">
-                      <a:solidFill>
-                        <a:srgbClr val="E8C4C8"/>
-                      </a:solidFill>
-                    </a:lnT>
-                    <a:lnB w="6350" cap="flat" cmpd="sng" algn="ctr">
-                      <a:solidFill>
-                        <a:srgbClr val="E8C4C8"/>
-                      </a:solidFill>
-                    </a:lnB>
-                  </a:tcPr>
-                </a:tc>
-                <a:tc>
-                  <a:txBody>
-                    <a:bodyPr wrap="square"/>
-                    <a:lstStyle/>
-                    <a:p>
-                      <a:pPr algn="ctr">
-                        <a:lnSpc>
-                          <a:spcPct val="100000"/>
-                        </a:lnSpc>
-                        <a:spcBef>
-                          <a:spcPts val="0"/>
-                        </a:spcBef>
-                        <a:spcAft>
-                          <a:spcPts val="0"/>
-                        </a:spcAft>
-                      </a:pPr>
-                      <a:r>
-                        <a:rPr sz="500" b="0">
-                          <a:solidFill>
-                            <a:srgbClr val="962837"/>
-                          </a:solidFill>
-                          <a:latin typeface="Calibri"/>
-                        </a:rPr>
-                        <a:t>КЦ</a:t>
-                      </a:r>
-                    </a:p>
-                  </a:txBody>
-                  <a:tcPr anchor="ctr" marL="25400" marR="25400" marT="12700" marB="12700">
-                    <a:solidFill>
-                      <a:srgbClr val="FFD2D8"/>
-                    </a:solidFill>
-                    <a:lnL w="6350" cap="flat" cmpd="sng" algn="ctr">
-                      <a:solidFill>
-                        <a:srgbClr val="E8C4C8"/>
-                      </a:solidFill>
-                    </a:lnL>
-                    <a:lnR w="6350" cap="flat" cmpd="sng" algn="ctr">
-                      <a:solidFill>
-                        <a:srgbClr val="E8C4C8"/>
-                      </a:solidFill>
-                    </a:lnR>
-                    <a:lnT w="6350" cap="flat" cmpd="sng" algn="ctr">
-                      <a:solidFill>
-                        <a:srgbClr val="E8C4C8"/>
-                      </a:solidFill>
-                    </a:lnT>
-                    <a:lnB w="6350" cap="flat" cmpd="sng" algn="ctr">
-                      <a:solidFill>
-                        <a:srgbClr val="E8C4C8"/>
-                      </a:solidFill>
-                    </a:lnB>
-                  </a:tcPr>
-                </a:tc>
-                <a:tc>
-                  <a:txBody>
-                    <a:bodyPr wrap="square"/>
-                    <a:lstStyle/>
-                    <a:p>
-                      <a:pPr algn="l">
-                        <a:lnSpc>
-                          <a:spcPct val="100000"/>
-                        </a:lnSpc>
-                        <a:spcBef>
-                          <a:spcPts val="0"/>
-                        </a:spcBef>
-                        <a:spcAft>
-                          <a:spcPts val="0"/>
-                        </a:spcAft>
-                      </a:pPr>
-                      <a:r>
-                        <a:rPr sz="500" b="0">
-                          <a:solidFill>
-                            <a:srgbClr val="323232"/>
-                          </a:solidFill>
-                          <a:latin typeface="Calibri"/>
-                        </a:rPr>
-                        <a:t/>
-                      </a:r>
-                    </a:p>
-                  </a:txBody>
-                  <a:tcPr anchor="ctr" marL="25400" marR="25400" marT="12700" marB="12700">
-                    <a:solidFill>
-                      <a:srgbClr val="FCF8F9"/>
                     </a:solidFill>
                     <a:lnL w="6350" cap="flat" cmpd="sng" algn="ctr">
                       <a:solidFill>
@@ -11609,59 +11585,6 @@
                           </a:solidFill>
                           <a:latin typeface="Calibri"/>
                         </a:rPr>
-                        <a:t>Честный знак</a:t>
-                      </a:r>
-                    </a:p>
-                  </a:txBody>
-                  <a:tcPr anchor="ctr" marL="25400" marR="25400" marT="12700" marB="12700">
-                    <a:solidFill>
-                      <a:srgbClr val="FFD2D8"/>
-                    </a:solidFill>
-                    <a:lnL w="6350" cap="flat" cmpd="sng" algn="ctr">
-                      <a:solidFill>
-                        <a:srgbClr val="E8C4C8"/>
-                      </a:solidFill>
-                    </a:lnL>
-                    <a:lnR w="6350" cap="flat" cmpd="sng" algn="ctr">
-                      <a:solidFill>
-                        <a:srgbClr val="E8C4C8"/>
-                      </a:solidFill>
-                    </a:lnR>
-                    <a:lnT w="6350" cap="flat" cmpd="sng" algn="ctr">
-                      <a:solidFill>
-                        <a:srgbClr val="E8C4C8"/>
-                      </a:solidFill>
-                    </a:lnT>
-                    <a:lnB w="6350" cap="flat" cmpd="sng" algn="ctr">
-                      <a:solidFill>
-                        <a:srgbClr val="E8C4C8"/>
-                      </a:solidFill>
-                    </a:lnB>
-                  </a:tcPr>
-                </a:tc>
-                <a:tc>
-                  <a:txBody>
-                    <a:bodyPr wrap="square"/>
-                    <a:lstStyle/>
-                    <a:p>
-                      <a:pPr algn="ctr">
-                        <a:lnSpc>
-                          <a:spcPct val="100000"/>
-                        </a:lnSpc>
-                        <a:spcBef>
-                          <a:spcPts val="0"/>
-                        </a:spcBef>
-                        <a:spcAft>
-                          <a:spcPts val="0"/>
-                        </a:spcAft>
-                      </a:pPr>
-                      <a:r>
-                        <a:rPr sz="500" b="0">
-                          <a:solidFill>
-                            <a:srgbClr val="962837"/>
-                          </a:solidFill>
-                          <a:latin typeface="Calibri"/>
-                        </a:rPr>
                         <a:t>ЦИ Липецк</a:t>
                       </a:r>
                     </a:p>
@@ -11906,6 +11829,59 @@
                     </a:lnB>
                   </a:tcPr>
                 </a:tc>
+                <a:tc>
+                  <a:txBody>
+                    <a:bodyPr wrap="square"/>
+                    <a:lstStyle/>
+                    <a:p>
+                      <a:pPr algn="ctr">
+                        <a:lnSpc>
+                          <a:spcPct val="100000"/>
+                        </a:lnSpc>
+                        <a:spcBef>
+                          <a:spcPts val="0"/>
+                        </a:spcBef>
+                        <a:spcAft>
+                          <a:spcPts val="0"/>
+                        </a:spcAft>
+                      </a:pPr>
+                      <a:r>
+                        <a:rPr sz="500" b="0">
+                          <a:solidFill>
+                            <a:srgbClr val="962837"/>
+                          </a:solidFill>
+                          <a:latin typeface="Calibri"/>
+                        </a:rPr>
+                        <a:t>Честный знак</a:t>
+                      </a:r>
+                    </a:p>
+                  </a:txBody>
+                  <a:tcPr anchor="ctr" marL="25400" marR="25400" marT="12700" marB="12700">
+                    <a:solidFill>
+                      <a:srgbClr val="FFD2D8"/>
+                    </a:solidFill>
+                    <a:lnL w="6350" cap="flat" cmpd="sng" algn="ctr">
+                      <a:solidFill>
+                        <a:srgbClr val="E8C4C8"/>
+                      </a:solidFill>
+                    </a:lnL>
+                    <a:lnR w="6350" cap="flat" cmpd="sng" algn="ctr">
+                      <a:solidFill>
+                        <a:srgbClr val="E8C4C8"/>
+                      </a:solidFill>
+                    </a:lnR>
+                    <a:lnT w="6350" cap="flat" cmpd="sng" algn="ctr">
+                      <a:solidFill>
+                        <a:srgbClr val="E8C4C8"/>
+                      </a:solidFill>
+                    </a:lnT>
+                    <a:lnB w="6350" cap="flat" cmpd="sng" algn="ctr">
+                      <a:solidFill>
+                        <a:srgbClr val="E8C4C8"/>
+                      </a:solidFill>
+                    </a:lnB>
+                  </a:tcPr>
+                </a:tc>
               </a:tr>
               <a:tr h="182880">
                 <a:tc>
@@ -12497,6 +12473,112 @@
                     <a:bodyPr wrap="square"/>
                     <a:lstStyle/>
                     <a:p>
+                      <a:pPr algn="ctr">
+                        <a:lnSpc>
+                          <a:spcPct val="100000"/>
+                        </a:lnSpc>
+                        <a:spcBef>
+                          <a:spcPts val="0"/>
+                        </a:spcBef>
+                        <a:spcAft>
+                          <a:spcPts val="0"/>
+                        </a:spcAft>
+                      </a:pPr>
+                      <a:r>
+                        <a:rPr sz="500" b="0">
+                          <a:solidFill>
+                            <a:srgbClr val="962837"/>
+                          </a:solidFill>
+                          <a:latin typeface="Calibri"/>
+                        </a:rPr>
+                        <a:t>ОП Тюмень</a:t>
+                      </a:r>
+                    </a:p>
+                  </a:txBody>
+                  <a:tcPr anchor="ctr" marL="25400" marR="25400" marT="12700" marB="12700">
+                    <a:solidFill>
+                      <a:srgbClr val="FFD2D8"/>
+                    </a:solidFill>
+                    <a:lnL w="6350" cap="flat" cmpd="sng" algn="ctr">
+                      <a:solidFill>
+                        <a:srgbClr val="E8C4C8"/>
+                      </a:solidFill>
+                    </a:lnL>
+                    <a:lnR w="6350" cap="flat" cmpd="sng" algn="ctr">
+                      <a:solidFill>
+                        <a:srgbClr val="E8C4C8"/>
+                      </a:solidFill>
+                    </a:lnR>
+                    <a:lnT w="6350" cap="flat" cmpd="sng" algn="ctr">
+                      <a:solidFill>
+                        <a:srgbClr val="E8C4C8"/>
+                      </a:solidFill>
+                    </a:lnT>
+                    <a:lnB w="6350" cap="flat" cmpd="sng" algn="ctr">
+                      <a:solidFill>
+                        <a:srgbClr val="E8C4C8"/>
+                      </a:solidFill>
+                    </a:lnB>
+                  </a:tcPr>
+                </a:tc>
+                <a:tc>
+                  <a:txBody>
+                    <a:bodyPr wrap="square"/>
+                    <a:lstStyle/>
+                    <a:p>
+                      <a:pPr algn="ctr">
+                        <a:lnSpc>
+                          <a:spcPct val="100000"/>
+                        </a:lnSpc>
+                        <a:spcBef>
+                          <a:spcPts val="0"/>
+                        </a:spcBef>
+                        <a:spcAft>
+                          <a:spcPts val="0"/>
+                        </a:spcAft>
+                      </a:pPr>
+                      <a:r>
+                        <a:rPr sz="500" b="0">
+                          <a:solidFill>
+                            <a:srgbClr val="962837"/>
+                          </a:solidFill>
+                          <a:latin typeface="Calibri"/>
+                        </a:rPr>
+                        <a:t>ОП Москва МСП</a:t>
+                      </a:r>
+                    </a:p>
+                  </a:txBody>
+                  <a:tcPr anchor="ctr" marL="25400" marR="25400" marT="12700" marB="12700">
+                    <a:solidFill>
+                      <a:srgbClr val="FFD2D8"/>
+                    </a:solidFill>
+                    <a:lnL w="6350" cap="flat" cmpd="sng" algn="ctr">
+                      <a:solidFill>
+                        <a:srgbClr val="E8C4C8"/>
+                      </a:solidFill>
+                    </a:lnL>
+                    <a:lnR w="6350" cap="flat" cmpd="sng" algn="ctr">
+                      <a:solidFill>
+                        <a:srgbClr val="E8C4C8"/>
+                      </a:solidFill>
+                    </a:lnR>
+                    <a:lnT w="6350" cap="flat" cmpd="sng" algn="ctr">
+                      <a:solidFill>
+                        <a:srgbClr val="E8C4C8"/>
+                      </a:solidFill>
+                    </a:lnT>
+                    <a:lnB w="6350" cap="flat" cmpd="sng" algn="ctr">
+                      <a:solidFill>
+                        <a:srgbClr val="E8C4C8"/>
+                      </a:solidFill>
+                    </a:lnB>
+                  </a:tcPr>
+                </a:tc>
+                <a:tc>
+                  <a:txBody>
+                    <a:bodyPr wrap="square"/>
+                    <a:lstStyle/>
+                    <a:p>
                       <a:pPr algn="l">
                         <a:lnSpc>
                           <a:spcPct val="100000"/>
@@ -12568,7 +12650,7 @@
                           </a:solidFill>
                           <a:latin typeface="Calibri"/>
                         </a:rPr>
-                        <a:t>ОП Тюмень</a:t>
+                        <a:t>КЦ</a:t>
                       </a:r>
                     </a:p>
                   </a:txBody>
@@ -12603,59 +12685,6 @@
                     <a:bodyPr wrap="square"/>
                     <a:lstStyle/>
                     <a:p>
-                      <a:pPr algn="ctr">
-                        <a:lnSpc>
-                          <a:spcPct val="100000"/>
-                        </a:lnSpc>
-                        <a:spcBef>
-                          <a:spcPts val="0"/>
-                        </a:spcBef>
-                        <a:spcAft>
-                          <a:spcPts val="0"/>
-                        </a:spcAft>
-                      </a:pPr>
-                      <a:r>
-                        <a:rPr sz="500" b="0">
-                          <a:solidFill>
-                            <a:srgbClr val="962837"/>
-                          </a:solidFill>
-                          <a:latin typeface="Calibri"/>
-                        </a:rPr>
-                        <a:t>ОП Москва МСП</a:t>
-                      </a:r>
-                    </a:p>
-                  </a:txBody>
-                  <a:tcPr anchor="ctr" marL="25400" marR="25400" marT="12700" marB="12700">
-                    <a:solidFill>
-                      <a:srgbClr val="FFD2D8"/>
-                    </a:solidFill>
-                    <a:lnL w="6350" cap="flat" cmpd="sng" algn="ctr">
-                      <a:solidFill>
-                        <a:srgbClr val="E8C4C8"/>
-                      </a:solidFill>
-                    </a:lnL>
-                    <a:lnR w="6350" cap="flat" cmpd="sng" algn="ctr">
-                      <a:solidFill>
-                        <a:srgbClr val="E8C4C8"/>
-                      </a:solidFill>
-                    </a:lnR>
-                    <a:lnT w="6350" cap="flat" cmpd="sng" algn="ctr">
-                      <a:solidFill>
-                        <a:srgbClr val="E8C4C8"/>
-                      </a:solidFill>
-                    </a:lnT>
-                    <a:lnB w="6350" cap="flat" cmpd="sng" algn="ctr">
-                      <a:solidFill>
-                        <a:srgbClr val="E8C4C8"/>
-                      </a:solidFill>
-                    </a:lnB>
-                  </a:tcPr>
-                </a:tc>
-                <a:tc>
-                  <a:txBody>
-                    <a:bodyPr wrap="square"/>
-                    <a:lstStyle/>
-                    <a:p>
                       <a:pPr algn="l">
                         <a:lnSpc>
                           <a:spcPct val="100000"/>
@@ -12681,59 +12710,6 @@
                   <a:tcPr anchor="ctr" marL="25400" marR="25400" marT="12700" marB="12700">
                     <a:solidFill>
                       <a:srgbClr val="FFFFFF"/>
-                    </a:solidFill>
-                    <a:lnL w="6350" cap="flat" cmpd="sng" algn="ctr">
-                      <a:solidFill>
-                        <a:srgbClr val="E8C4C8"/>
-                      </a:solidFill>
-                    </a:lnL>
-                    <a:lnR w="6350" cap="flat" cmpd="sng" algn="ctr">
-                      <a:solidFill>
-                        <a:srgbClr val="E8C4C8"/>
-                      </a:solidFill>
-                    </a:lnR>
-                    <a:lnT w="6350" cap="flat" cmpd="sng" algn="ctr">
-                      <a:solidFill>
-                        <a:srgbClr val="E8C4C8"/>
-                      </a:solidFill>
-                    </a:lnT>
-                    <a:lnB w="6350" cap="flat" cmpd="sng" algn="ctr">
-                      <a:solidFill>
-                        <a:srgbClr val="E8C4C8"/>
-                      </a:solidFill>
-                    </a:lnB>
-                  </a:tcPr>
-                </a:tc>
-                <a:tc>
-                  <a:txBody>
-                    <a:bodyPr wrap="square"/>
-                    <a:lstStyle/>
-                    <a:p>
-                      <a:pPr algn="ctr">
-                        <a:lnSpc>
-                          <a:spcPct val="100000"/>
-                        </a:lnSpc>
-                        <a:spcBef>
-                          <a:spcPts val="0"/>
-                        </a:spcBef>
-                        <a:spcAft>
-                          <a:spcPts val="0"/>
-                        </a:spcAft>
-                      </a:pPr>
-                      <a:r>
-                        <a:rPr sz="500" b="0">
-                          <a:solidFill>
-                            <a:srgbClr val="962837"/>
-                          </a:solidFill>
-                          <a:latin typeface="Calibri"/>
-                        </a:rPr>
-                        <a:t>КЦ</a:t>
-                      </a:r>
-                    </a:p>
-                  </a:txBody>
-                  <a:tcPr anchor="ctr" marL="25400" marR="25400" marT="12700" marB="12700">
-                    <a:solidFill>
-                      <a:srgbClr val="FFD2D8"/>
                     </a:solidFill>
                     <a:lnL w="6350" cap="flat" cmpd="sng" algn="ctr">
                       <a:solidFill>
@@ -13401,6 +13377,112 @@
                     <a:bodyPr wrap="square"/>
                     <a:lstStyle/>
                     <a:p>
+                      <a:pPr algn="ctr">
+                        <a:lnSpc>
+                          <a:spcPct val="100000"/>
+                        </a:lnSpc>
+                        <a:spcBef>
+                          <a:spcPts val="0"/>
+                        </a:spcBef>
+                        <a:spcAft>
+                          <a:spcPts val="0"/>
+                        </a:spcAft>
+                      </a:pPr>
+                      <a:r>
+                        <a:rPr sz="500" b="0">
+                          <a:solidFill>
+                            <a:srgbClr val="962837"/>
+                          </a:solidFill>
+                          <a:latin typeface="Calibri"/>
+                        </a:rPr>
+                        <a:t>БЦ Тюмень</a:t>
+                      </a:r>
+                    </a:p>
+                  </a:txBody>
+                  <a:tcPr anchor="ctr" marL="25400" marR="25400" marT="12700" marB="12700">
+                    <a:solidFill>
+                      <a:srgbClr val="FFD2D8"/>
+                    </a:solidFill>
+                    <a:lnL w="6350" cap="flat" cmpd="sng" algn="ctr">
+                      <a:solidFill>
+                        <a:srgbClr val="E8C4C8"/>
+                      </a:solidFill>
+                    </a:lnL>
+                    <a:lnR w="6350" cap="flat" cmpd="sng" algn="ctr">
+                      <a:solidFill>
+                        <a:srgbClr val="E8C4C8"/>
+                      </a:solidFill>
+                    </a:lnR>
+                    <a:lnT w="6350" cap="flat" cmpd="sng" algn="ctr">
+                      <a:solidFill>
+                        <a:srgbClr val="E8C4C8"/>
+                      </a:solidFill>
+                    </a:lnT>
+                    <a:lnB w="6350" cap="flat" cmpd="sng" algn="ctr">
+                      <a:solidFill>
+                        <a:srgbClr val="E8C4C8"/>
+                      </a:solidFill>
+                    </a:lnB>
+                  </a:tcPr>
+                </a:tc>
+                <a:tc>
+                  <a:txBody>
+                    <a:bodyPr wrap="square"/>
+                    <a:lstStyle/>
+                    <a:p>
+                      <a:pPr algn="ctr">
+                        <a:lnSpc>
+                          <a:spcPct val="100000"/>
+                        </a:lnSpc>
+                        <a:spcBef>
+                          <a:spcPts val="0"/>
+                        </a:spcBef>
+                        <a:spcAft>
+                          <a:spcPts val="0"/>
+                        </a:spcAft>
+                      </a:pPr>
+                      <a:r>
+                        <a:rPr sz="500" b="0">
+                          <a:solidFill>
+                            <a:srgbClr val="962837"/>
+                          </a:solidFill>
+                          <a:latin typeface="Calibri"/>
+                        </a:rPr>
+                        <a:t>БЦ Москва МСП</a:t>
+                      </a:r>
+                    </a:p>
+                  </a:txBody>
+                  <a:tcPr anchor="ctr" marL="25400" marR="25400" marT="12700" marB="12700">
+                    <a:solidFill>
+                      <a:srgbClr val="FFD2D8"/>
+                    </a:solidFill>
+                    <a:lnL w="6350" cap="flat" cmpd="sng" algn="ctr">
+                      <a:solidFill>
+                        <a:srgbClr val="E8C4C8"/>
+                      </a:solidFill>
+                    </a:lnL>
+                    <a:lnR w="6350" cap="flat" cmpd="sng" algn="ctr">
+                      <a:solidFill>
+                        <a:srgbClr val="E8C4C8"/>
+                      </a:solidFill>
+                    </a:lnR>
+                    <a:lnT w="6350" cap="flat" cmpd="sng" algn="ctr">
+                      <a:solidFill>
+                        <a:srgbClr val="E8C4C8"/>
+                      </a:solidFill>
+                    </a:lnT>
+                    <a:lnB w="6350" cap="flat" cmpd="sng" algn="ctr">
+                      <a:solidFill>
+                        <a:srgbClr val="E8C4C8"/>
+                      </a:solidFill>
+                    </a:lnB>
+                  </a:tcPr>
+                </a:tc>
+                <a:tc>
+                  <a:txBody>
+                    <a:bodyPr wrap="square"/>
+                    <a:lstStyle/>
+                    <a:p>
                       <a:pPr algn="l">
                         <a:lnSpc>
                           <a:spcPct val="100000"/>
@@ -13426,112 +13508,6 @@
                   <a:tcPr anchor="ctr" marL="25400" marR="25400" marT="12700" marB="12700">
                     <a:solidFill>
                       <a:srgbClr val="FCF8F9"/>
-                    </a:solidFill>
-                    <a:lnL w="6350" cap="flat" cmpd="sng" algn="ctr">
-                      <a:solidFill>
-                        <a:srgbClr val="E8C4C8"/>
-                      </a:solidFill>
-                    </a:lnL>
-                    <a:lnR w="6350" cap="flat" cmpd="sng" algn="ctr">
-                      <a:solidFill>
-                        <a:srgbClr val="E8C4C8"/>
-                      </a:solidFill>
-                    </a:lnR>
-                    <a:lnT w="6350" cap="flat" cmpd="sng" algn="ctr">
-                      <a:solidFill>
-                        <a:srgbClr val="E8C4C8"/>
-                      </a:solidFill>
-                    </a:lnT>
-                    <a:lnB w="6350" cap="flat" cmpd="sng" algn="ctr">
-                      <a:solidFill>
-                        <a:srgbClr val="E8C4C8"/>
-                      </a:solidFill>
-                    </a:lnB>
-                  </a:tcPr>
-                </a:tc>
-                <a:tc>
-                  <a:txBody>
-                    <a:bodyPr wrap="square"/>
-                    <a:lstStyle/>
-                    <a:p>
-                      <a:pPr algn="ctr">
-                        <a:lnSpc>
-                          <a:spcPct val="100000"/>
-                        </a:lnSpc>
-                        <a:spcBef>
-                          <a:spcPts val="0"/>
-                        </a:spcBef>
-                        <a:spcAft>
-                          <a:spcPts val="0"/>
-                        </a:spcAft>
-                      </a:pPr>
-                      <a:r>
-                        <a:rPr sz="500" b="0">
-                          <a:solidFill>
-                            <a:srgbClr val="962837"/>
-                          </a:solidFill>
-                          <a:latin typeface="Calibri"/>
-                        </a:rPr>
-                        <a:t>БЦ Тюмень</a:t>
-                      </a:r>
-                    </a:p>
-                  </a:txBody>
-                  <a:tcPr anchor="ctr" marL="25400" marR="25400" marT="12700" marB="12700">
-                    <a:solidFill>
-                      <a:srgbClr val="FFD2D8"/>
-                    </a:solidFill>
-                    <a:lnL w="6350" cap="flat" cmpd="sng" algn="ctr">
-                      <a:solidFill>
-                        <a:srgbClr val="E8C4C8"/>
-                      </a:solidFill>
-                    </a:lnL>
-                    <a:lnR w="6350" cap="flat" cmpd="sng" algn="ctr">
-                      <a:solidFill>
-                        <a:srgbClr val="E8C4C8"/>
-                      </a:solidFill>
-                    </a:lnR>
-                    <a:lnT w="6350" cap="flat" cmpd="sng" algn="ctr">
-                      <a:solidFill>
-                        <a:srgbClr val="E8C4C8"/>
-                      </a:solidFill>
-                    </a:lnT>
-                    <a:lnB w="6350" cap="flat" cmpd="sng" algn="ctr">
-                      <a:solidFill>
-                        <a:srgbClr val="E8C4C8"/>
-                      </a:solidFill>
-                    </a:lnB>
-                  </a:tcPr>
-                </a:tc>
-                <a:tc>
-                  <a:txBody>
-                    <a:bodyPr wrap="square"/>
-                    <a:lstStyle/>
-                    <a:p>
-                      <a:pPr algn="ctr">
-                        <a:lnSpc>
-                          <a:spcPct val="100000"/>
-                        </a:lnSpc>
-                        <a:spcBef>
-                          <a:spcPts val="0"/>
-                        </a:spcBef>
-                        <a:spcAft>
-                          <a:spcPts val="0"/>
-                        </a:spcAft>
-                      </a:pPr>
-                      <a:r>
-                        <a:rPr sz="500" b="0">
-                          <a:solidFill>
-                            <a:srgbClr val="962837"/>
-                          </a:solidFill>
-                          <a:latin typeface="Calibri"/>
-                        </a:rPr>
-                        <a:t>БЦ Москва МСП</a:t>
-                      </a:r>
-                    </a:p>
-                  </a:txBody>
-                  <a:tcPr anchor="ctr" marL="25400" marR="25400" marT="12700" marB="12700">
-                    <a:solidFill>
-                      <a:srgbClr val="FFD2D8"/>
                     </a:solidFill>
                     <a:lnL w="6350" cap="flat" cmpd="sng" algn="ctr">
                       <a:solidFill>
@@ -14305,6 +14281,112 @@
                     <a:bodyPr wrap="square"/>
                     <a:lstStyle/>
                     <a:p>
+                      <a:pPr algn="ctr">
+                        <a:lnSpc>
+                          <a:spcPct val="100000"/>
+                        </a:lnSpc>
+                        <a:spcBef>
+                          <a:spcPts val="0"/>
+                        </a:spcBef>
+                        <a:spcAft>
+                          <a:spcPts val="0"/>
+                        </a:spcAft>
+                      </a:pPr>
+                      <a:r>
+                        <a:rPr sz="500" b="0">
+                          <a:solidFill>
+                            <a:srgbClr val="962837"/>
+                          </a:solidFill>
+                          <a:latin typeface="Calibri"/>
+                        </a:rPr>
+                        <a:t>РС Тюмень</a:t>
+                      </a:r>
+                    </a:p>
+                  </a:txBody>
+                  <a:tcPr anchor="ctr" marL="25400" marR="25400" marT="12700" marB="12700">
+                    <a:solidFill>
+                      <a:srgbClr val="FFD2D8"/>
+                    </a:solidFill>
+                    <a:lnL w="6350" cap="flat" cmpd="sng" algn="ctr">
+                      <a:solidFill>
+                        <a:srgbClr val="E8C4C8"/>
+                      </a:solidFill>
+                    </a:lnL>
+                    <a:lnR w="6350" cap="flat" cmpd="sng" algn="ctr">
+                      <a:solidFill>
+                        <a:srgbClr val="E8C4C8"/>
+                      </a:solidFill>
+                    </a:lnR>
+                    <a:lnT w="6350" cap="flat" cmpd="sng" algn="ctr">
+                      <a:solidFill>
+                        <a:srgbClr val="E8C4C8"/>
+                      </a:solidFill>
+                    </a:lnT>
+                    <a:lnB w="6350" cap="flat" cmpd="sng" algn="ctr">
+                      <a:solidFill>
+                        <a:srgbClr val="E8C4C8"/>
+                      </a:solidFill>
+                    </a:lnB>
+                  </a:tcPr>
+                </a:tc>
+                <a:tc>
+                  <a:txBody>
+                    <a:bodyPr wrap="square"/>
+                    <a:lstStyle/>
+                    <a:p>
+                      <a:pPr algn="ctr">
+                        <a:lnSpc>
+                          <a:spcPct val="100000"/>
+                        </a:lnSpc>
+                        <a:spcBef>
+                          <a:spcPts val="0"/>
+                        </a:spcBef>
+                        <a:spcAft>
+                          <a:spcPts val="0"/>
+                        </a:spcAft>
+                      </a:pPr>
+                      <a:r>
+                        <a:rPr sz="500" b="0">
+                          <a:solidFill>
+                            <a:srgbClr val="962837"/>
+                          </a:solidFill>
+                          <a:latin typeface="Calibri"/>
+                        </a:rPr>
+                        <a:t>РС Липецк</a:t>
+                      </a:r>
+                    </a:p>
+                  </a:txBody>
+                  <a:tcPr anchor="ctr" marL="25400" marR="25400" marT="12700" marB="12700">
+                    <a:solidFill>
+                      <a:srgbClr val="FFD2D8"/>
+                    </a:solidFill>
+                    <a:lnL w="6350" cap="flat" cmpd="sng" algn="ctr">
+                      <a:solidFill>
+                        <a:srgbClr val="E8C4C8"/>
+                      </a:solidFill>
+                    </a:lnL>
+                    <a:lnR w="6350" cap="flat" cmpd="sng" algn="ctr">
+                      <a:solidFill>
+                        <a:srgbClr val="E8C4C8"/>
+                      </a:solidFill>
+                    </a:lnR>
+                    <a:lnT w="6350" cap="flat" cmpd="sng" algn="ctr">
+                      <a:solidFill>
+                        <a:srgbClr val="E8C4C8"/>
+                      </a:solidFill>
+                    </a:lnT>
+                    <a:lnB w="6350" cap="flat" cmpd="sng" algn="ctr">
+                      <a:solidFill>
+                        <a:srgbClr val="E8C4C8"/>
+                      </a:solidFill>
+                    </a:lnB>
+                  </a:tcPr>
+                </a:tc>
+                <a:tc>
+                  <a:txBody>
+                    <a:bodyPr wrap="square"/>
+                    <a:lstStyle/>
+                    <a:p>
                       <a:pPr algn="l">
                         <a:lnSpc>
                           <a:spcPct val="100000"/>
@@ -14330,112 +14412,6 @@
                   <a:tcPr anchor="ctr" marL="25400" marR="25400" marT="12700" marB="12700">
                     <a:solidFill>
                       <a:srgbClr val="FFFFFF"/>
-                    </a:solidFill>
-                    <a:lnL w="6350" cap="flat" cmpd="sng" algn="ctr">
-                      <a:solidFill>
-                        <a:srgbClr val="E8C4C8"/>
-                      </a:solidFill>
-                    </a:lnL>
-                    <a:lnR w="6350" cap="flat" cmpd="sng" algn="ctr">
-                      <a:solidFill>
-                        <a:srgbClr val="E8C4C8"/>
-                      </a:solidFill>
-                    </a:lnR>
-                    <a:lnT w="6350" cap="flat" cmpd="sng" algn="ctr">
-                      <a:solidFill>
-                        <a:srgbClr val="E8C4C8"/>
-                      </a:solidFill>
-                    </a:lnT>
-                    <a:lnB w="6350" cap="flat" cmpd="sng" algn="ctr">
-                      <a:solidFill>
-                        <a:srgbClr val="E8C4C8"/>
-                      </a:solidFill>
-                    </a:lnB>
-                  </a:tcPr>
-                </a:tc>
-                <a:tc>
-                  <a:txBody>
-                    <a:bodyPr wrap="square"/>
-                    <a:lstStyle/>
-                    <a:p>
-                      <a:pPr algn="ctr">
-                        <a:lnSpc>
-                          <a:spcPct val="100000"/>
-                        </a:lnSpc>
-                        <a:spcBef>
-                          <a:spcPts val="0"/>
-                        </a:spcBef>
-                        <a:spcAft>
-                          <a:spcPts val="0"/>
-                        </a:spcAft>
-                      </a:pPr>
-                      <a:r>
-                        <a:rPr sz="500" b="0">
-                          <a:solidFill>
-                            <a:srgbClr val="962837"/>
-                          </a:solidFill>
-                          <a:latin typeface="Calibri"/>
-                        </a:rPr>
-                        <a:t>РС Тюмень</a:t>
-                      </a:r>
-                    </a:p>
-                  </a:txBody>
-                  <a:tcPr anchor="ctr" marL="25400" marR="25400" marT="12700" marB="12700">
-                    <a:solidFill>
-                      <a:srgbClr val="FFD2D8"/>
-                    </a:solidFill>
-                    <a:lnL w="6350" cap="flat" cmpd="sng" algn="ctr">
-                      <a:solidFill>
-                        <a:srgbClr val="E8C4C8"/>
-                      </a:solidFill>
-                    </a:lnL>
-                    <a:lnR w="6350" cap="flat" cmpd="sng" algn="ctr">
-                      <a:solidFill>
-                        <a:srgbClr val="E8C4C8"/>
-                      </a:solidFill>
-                    </a:lnR>
-                    <a:lnT w="6350" cap="flat" cmpd="sng" algn="ctr">
-                      <a:solidFill>
-                        <a:srgbClr val="E8C4C8"/>
-                      </a:solidFill>
-                    </a:lnT>
-                    <a:lnB w="6350" cap="flat" cmpd="sng" algn="ctr">
-                      <a:solidFill>
-                        <a:srgbClr val="E8C4C8"/>
-                      </a:solidFill>
-                    </a:lnB>
-                  </a:tcPr>
-                </a:tc>
-                <a:tc>
-                  <a:txBody>
-                    <a:bodyPr wrap="square"/>
-                    <a:lstStyle/>
-                    <a:p>
-                      <a:pPr algn="ctr">
-                        <a:lnSpc>
-                          <a:spcPct val="100000"/>
-                        </a:lnSpc>
-                        <a:spcBef>
-                          <a:spcPts val="0"/>
-                        </a:spcBef>
-                        <a:spcAft>
-                          <a:spcPts val="0"/>
-                        </a:spcAft>
-                      </a:pPr>
-                      <a:r>
-                        <a:rPr sz="500" b="0">
-                          <a:solidFill>
-                            <a:srgbClr val="962837"/>
-                          </a:solidFill>
-                          <a:latin typeface="Calibri"/>
-                        </a:rPr>
-                        <a:t>РС Липецк</a:t>
-                      </a:r>
-                    </a:p>
-                  </a:txBody>
-                  <a:tcPr anchor="ctr" marL="25400" marR="25400" marT="12700" marB="12700">
-                    <a:solidFill>
-                      <a:srgbClr val="FFD2D8"/>
                     </a:solidFill>
                     <a:lnL w="6350" cap="flat" cmpd="sng" algn="ctr">
                       <a:solidFill>
@@ -16270,6 +16246,59 @@
                     <a:bodyPr wrap="square"/>
                     <a:lstStyle/>
                     <a:p>
+                      <a:pPr algn="ctr">
+                        <a:lnSpc>
+                          <a:spcPct val="100000"/>
+                        </a:lnSpc>
+                        <a:spcBef>
+                          <a:spcPts val="0"/>
+                        </a:spcBef>
+                        <a:spcAft>
+                          <a:spcPts val="0"/>
+                        </a:spcAft>
+                      </a:pPr>
+                      <a:r>
+                        <a:rPr sz="500" b="0">
+                          <a:solidFill>
+                            <a:srgbClr val="962837"/>
+                          </a:solidFill>
+                          <a:latin typeface="Calibri"/>
+                        </a:rPr>
+                        <a:t>КЦ</a:t>
+                      </a:r>
+                    </a:p>
+                  </a:txBody>
+                  <a:tcPr anchor="ctr" marL="25400" marR="25400" marT="12700" marB="12700">
+                    <a:solidFill>
+                      <a:srgbClr val="FFD2D8"/>
+                    </a:solidFill>
+                    <a:lnL w="6350" cap="flat" cmpd="sng" algn="ctr">
+                      <a:solidFill>
+                        <a:srgbClr val="E8C4C8"/>
+                      </a:solidFill>
+                    </a:lnL>
+                    <a:lnR w="6350" cap="flat" cmpd="sng" algn="ctr">
+                      <a:solidFill>
+                        <a:srgbClr val="E8C4C8"/>
+                      </a:solidFill>
+                    </a:lnR>
+                    <a:lnT w="6350" cap="flat" cmpd="sng" algn="ctr">
+                      <a:solidFill>
+                        <a:srgbClr val="E8C4C8"/>
+                      </a:solidFill>
+                    </a:lnT>
+                    <a:lnB w="6350" cap="flat" cmpd="sng" algn="ctr">
+                      <a:solidFill>
+                        <a:srgbClr val="E8C4C8"/>
+                      </a:solidFill>
+                    </a:lnB>
+                  </a:tcPr>
+                </a:tc>
+                <a:tc>
+                  <a:txBody>
+                    <a:bodyPr wrap="square"/>
+                    <a:lstStyle/>
+                    <a:p>
                       <a:pPr algn="l">
                         <a:lnSpc>
                           <a:spcPct val="100000"/>
@@ -16295,59 +16324,6 @@
                   <a:tcPr anchor="ctr" marL="25400" marR="25400" marT="12700" marB="12700">
                     <a:solidFill>
                       <a:srgbClr val="FFFFFF"/>
-                    </a:solidFill>
-                    <a:lnL w="6350" cap="flat" cmpd="sng" algn="ctr">
-                      <a:solidFill>
-                        <a:srgbClr val="E8C4C8"/>
-                      </a:solidFill>
-                    </a:lnL>
-                    <a:lnR w="6350" cap="flat" cmpd="sng" algn="ctr">
-                      <a:solidFill>
-                        <a:srgbClr val="E8C4C8"/>
-                      </a:solidFill>
-                    </a:lnR>
-                    <a:lnT w="6350" cap="flat" cmpd="sng" algn="ctr">
-                      <a:solidFill>
-                        <a:srgbClr val="E8C4C8"/>
-                      </a:solidFill>
-                    </a:lnT>
-                    <a:lnB w="6350" cap="flat" cmpd="sng" algn="ctr">
-                      <a:solidFill>
-                        <a:srgbClr val="E8C4C8"/>
-                      </a:solidFill>
-                    </a:lnB>
-                  </a:tcPr>
-                </a:tc>
-                <a:tc>
-                  <a:txBody>
-                    <a:bodyPr wrap="square"/>
-                    <a:lstStyle/>
-                    <a:p>
-                      <a:pPr algn="ctr">
-                        <a:lnSpc>
-                          <a:spcPct val="100000"/>
-                        </a:lnSpc>
-                        <a:spcBef>
-                          <a:spcPts val="0"/>
-                        </a:spcBef>
-                        <a:spcAft>
-                          <a:spcPts val="0"/>
-                        </a:spcAft>
-                      </a:pPr>
-                      <a:r>
-                        <a:rPr sz="500" b="0">
-                          <a:solidFill>
-                            <a:srgbClr val="962837"/>
-                          </a:solidFill>
-                          <a:latin typeface="Calibri"/>
-                        </a:rPr>
-                        <a:t>КЦ</a:t>
-                      </a:r>
-                    </a:p>
-                  </a:txBody>
-                  <a:tcPr anchor="ctr" marL="25400" marR="25400" marT="12700" marB="12700">
-                    <a:solidFill>
-                      <a:srgbClr val="FFD2D8"/>
                     </a:solidFill>
                     <a:lnL w="6350" cap="flat" cmpd="sng" algn="ctr">
                       <a:solidFill>
@@ -22406,59 +22382,6 @@
                   <a:tcPr anchor="ctr" marL="25400" marR="25400" marT="12700" marB="12700">
                     <a:solidFill>
                       <a:srgbClr val="FFD2D8"/>
-                    </a:solidFill>
-                    <a:lnL w="6350" cap="flat" cmpd="sng" algn="ctr">
-                      <a:solidFill>
-                        <a:srgbClr val="E8C4C8"/>
-                      </a:solidFill>
-                    </a:lnL>
-                    <a:lnR w="6350" cap="flat" cmpd="sng" algn="ctr">
-                      <a:solidFill>
-                        <a:srgbClr val="E8C4C8"/>
-                      </a:solidFill>
-                    </a:lnR>
-                    <a:lnT w="6350" cap="flat" cmpd="sng" algn="ctr">
-                      <a:solidFill>
-                        <a:srgbClr val="E8C4C8"/>
-                      </a:solidFill>
-                    </a:lnT>
-                    <a:lnB w="6350" cap="flat" cmpd="sng" algn="ctr">
-                      <a:solidFill>
-                        <a:srgbClr val="E8C4C8"/>
-                      </a:solidFill>
-                    </a:lnB>
-                  </a:tcPr>
-                </a:tc>
-                <a:tc>
-                  <a:txBody>
-                    <a:bodyPr wrap="square"/>
-                    <a:lstStyle/>
-                    <a:p>
-                      <a:pPr algn="l">
-                        <a:lnSpc>
-                          <a:spcPct val="100000"/>
-                        </a:lnSpc>
-                        <a:spcBef>
-                          <a:spcPts val="0"/>
-                        </a:spcBef>
-                        <a:spcAft>
-                          <a:spcPts val="0"/>
-                        </a:spcAft>
-                      </a:pPr>
-                      <a:r>
-                        <a:rPr sz="500" b="0">
-                          <a:solidFill>
-                            <a:srgbClr val="323232"/>
-                          </a:solidFill>
-                          <a:latin typeface="Calibri"/>
-                        </a:rPr>
-                        <a:t/>
-                      </a:r>
-                    </a:p>
-                  </a:txBody>
-                  <a:tcPr anchor="ctr" marL="25400" marR="25400" marT="12700" marB="12700">
-                    <a:solidFill>
-                      <a:srgbClr val="FCF8F9"/>
                     </a:solidFill>
                     <a:lnL w="6350" cap="flat" cmpd="sng" algn="ctr">
                       <a:solidFill>
@@ -22751,6 +22674,59 @@
                     </a:lnB>
                   </a:tcPr>
                 </a:tc>
+                <a:tc>
+                  <a:txBody>
+                    <a:bodyPr wrap="square"/>
+                    <a:lstStyle/>
+                    <a:p>
+                      <a:pPr algn="l">
+                        <a:lnSpc>
+                          <a:spcPct val="100000"/>
+                        </a:lnSpc>
+                        <a:spcBef>
+                          <a:spcPts val="0"/>
+                        </a:spcBef>
+                        <a:spcAft>
+                          <a:spcPts val="0"/>
+                        </a:spcAft>
+                      </a:pPr>
+                      <a:r>
+                        <a:rPr sz="500" b="0">
+                          <a:solidFill>
+                            <a:srgbClr val="323232"/>
+                          </a:solidFill>
+                          <a:latin typeface="Calibri"/>
+                        </a:rPr>
+                        <a:t/>
+                      </a:r>
+                    </a:p>
+                  </a:txBody>
+                  <a:tcPr anchor="ctr" marL="25400" marR="25400" marT="12700" marB="12700">
+                    <a:solidFill>
+                      <a:srgbClr val="FCF8F9"/>
+                    </a:solidFill>
+                    <a:lnL w="6350" cap="flat" cmpd="sng" algn="ctr">
+                      <a:solidFill>
+                        <a:srgbClr val="E8C4C8"/>
+                      </a:solidFill>
+                    </a:lnL>
+                    <a:lnR w="6350" cap="flat" cmpd="sng" algn="ctr">
+                      <a:solidFill>
+                        <a:srgbClr val="E8C4C8"/>
+                      </a:solidFill>
+                    </a:lnR>
+                    <a:lnT w="6350" cap="flat" cmpd="sng" algn="ctr">
+                      <a:solidFill>
+                        <a:srgbClr val="E8C4C8"/>
+                      </a:solidFill>
+                    </a:lnT>
+                    <a:lnB w="6350" cap="flat" cmpd="sng" algn="ctr">
+                      <a:solidFill>
+                        <a:srgbClr val="E8C4C8"/>
+                      </a:solidFill>
+                    </a:lnB>
+                  </a:tcPr>
+                </a:tc>
               </a:tr>
               <a:tr h="256032">
                 <a:tc>
@@ -25359,6 +25335,59 @@
                     <a:bodyPr wrap="square"/>
                     <a:lstStyle/>
                     <a:p>
+                      <a:pPr algn="ctr">
+                        <a:lnSpc>
+                          <a:spcPct val="100000"/>
+                        </a:lnSpc>
+                        <a:spcBef>
+                          <a:spcPts val="0"/>
+                        </a:spcBef>
+                        <a:spcAft>
+                          <a:spcPts val="0"/>
+                        </a:spcAft>
+                      </a:pPr>
+                      <a:r>
+                        <a:rPr sz="500" b="0">
+                          <a:solidFill>
+                            <a:srgbClr val="962837"/>
+                          </a:solidFill>
+                          <a:latin typeface="Calibri"/>
+                        </a:rPr>
+                        <a:t>КЦ</a:t>
+                      </a:r>
+                    </a:p>
+                  </a:txBody>
+                  <a:tcPr anchor="ctr" marL="25400" marR="25400" marT="12700" marB="12700">
+                    <a:solidFill>
+                      <a:srgbClr val="FFD2D8"/>
+                    </a:solidFill>
+                    <a:lnL w="6350" cap="flat" cmpd="sng" algn="ctr">
+                      <a:solidFill>
+                        <a:srgbClr val="E8C4C8"/>
+                      </a:solidFill>
+                    </a:lnL>
+                    <a:lnR w="6350" cap="flat" cmpd="sng" algn="ctr">
+                      <a:solidFill>
+                        <a:srgbClr val="E8C4C8"/>
+                      </a:solidFill>
+                    </a:lnR>
+                    <a:lnT w="6350" cap="flat" cmpd="sng" algn="ctr">
+                      <a:solidFill>
+                        <a:srgbClr val="E8C4C8"/>
+                      </a:solidFill>
+                    </a:lnT>
+                    <a:lnB w="6350" cap="flat" cmpd="sng" algn="ctr">
+                      <a:solidFill>
+                        <a:srgbClr val="E8C4C8"/>
+                      </a:solidFill>
+                    </a:lnB>
+                  </a:tcPr>
+                </a:tc>
+                <a:tc>
+                  <a:txBody>
+                    <a:bodyPr wrap="square"/>
+                    <a:lstStyle/>
+                    <a:p>
                       <a:pPr algn="l">
                         <a:lnSpc>
                           <a:spcPct val="100000"/>
@@ -25384,59 +25413,6 @@
                   <a:tcPr anchor="ctr" marL="25400" marR="25400" marT="12700" marB="12700">
                     <a:solidFill>
                       <a:srgbClr val="FFFFFF"/>
-                    </a:solidFill>
-                    <a:lnL w="6350" cap="flat" cmpd="sng" algn="ctr">
-                      <a:solidFill>
-                        <a:srgbClr val="E8C4C8"/>
-                      </a:solidFill>
-                    </a:lnL>
-                    <a:lnR w="6350" cap="flat" cmpd="sng" algn="ctr">
-                      <a:solidFill>
-                        <a:srgbClr val="E8C4C8"/>
-                      </a:solidFill>
-                    </a:lnR>
-                    <a:lnT w="6350" cap="flat" cmpd="sng" algn="ctr">
-                      <a:solidFill>
-                        <a:srgbClr val="E8C4C8"/>
-                      </a:solidFill>
-                    </a:lnT>
-                    <a:lnB w="6350" cap="flat" cmpd="sng" algn="ctr">
-                      <a:solidFill>
-                        <a:srgbClr val="E8C4C8"/>
-                      </a:solidFill>
-                    </a:lnB>
-                  </a:tcPr>
-                </a:tc>
-                <a:tc>
-                  <a:txBody>
-                    <a:bodyPr wrap="square"/>
-                    <a:lstStyle/>
-                    <a:p>
-                      <a:pPr algn="ctr">
-                        <a:lnSpc>
-                          <a:spcPct val="100000"/>
-                        </a:lnSpc>
-                        <a:spcBef>
-                          <a:spcPts val="0"/>
-                        </a:spcBef>
-                        <a:spcAft>
-                          <a:spcPts val="0"/>
-                        </a:spcAft>
-                      </a:pPr>
-                      <a:r>
-                        <a:rPr sz="500" b="0">
-                          <a:solidFill>
-                            <a:srgbClr val="962837"/>
-                          </a:solidFill>
-                          <a:latin typeface="Calibri"/>
-                        </a:rPr>
-                        <a:t>КЦ</a:t>
-                      </a:r>
-                    </a:p>
-                  </a:txBody>
-                  <a:tcPr anchor="ctr" marL="25400" marR="25400" marT="12700" marB="12700">
-                    <a:solidFill>
-                      <a:srgbClr val="FFD2D8"/>
                     </a:solidFill>
                     <a:lnL w="6350" cap="flat" cmpd="sng" algn="ctr">
                       <a:solidFill>
@@ -26787,7 +26763,7 @@
                     </a:lnB>
                   </a:tcPr>
                 </a:tc>
-                <a:tc gridSpan="3">
+                <a:tc gridSpan="8">
                   <a:txBody>
                     <a:bodyPr wrap="square"/>
                     <a:lstStyle/>
@@ -26898,6 +26874,151 @@
                     </a:lnB>
                   </a:tcPr>
                 </a:tc>
+                <a:tc hMerge="1">
+                  <a:txBody>
+                    <a:bodyPr/>
+                    <a:lstStyle/>
+                    <a:p/>
+                  </a:txBody>
+                  <a:tcPr>
+                    <a:lnL w="6350" cap="flat" cmpd="sng" algn="ctr">
+                      <a:solidFill>
+                        <a:srgbClr val="E8C4C8"/>
+                      </a:solidFill>
+                    </a:lnL>
+                    <a:lnR w="6350" cap="flat" cmpd="sng" algn="ctr">
+                      <a:solidFill>
+                        <a:srgbClr val="E8C4C8"/>
+                      </a:solidFill>
+                    </a:lnR>
+                    <a:lnT w="6350" cap="flat" cmpd="sng" algn="ctr">
+                      <a:solidFill>
+                        <a:srgbClr val="E8C4C8"/>
+                      </a:solidFill>
+                    </a:lnT>
+                    <a:lnB w="6350" cap="flat" cmpd="sng" algn="ctr">
+                      <a:solidFill>
+                        <a:srgbClr val="E8C4C8"/>
+                      </a:solidFill>
+                    </a:lnB>
+                  </a:tcPr>
+                </a:tc>
+                <a:tc hMerge="1">
+                  <a:txBody>
+                    <a:bodyPr/>
+                    <a:lstStyle/>
+                    <a:p/>
+                  </a:txBody>
+                  <a:tcPr>
+                    <a:lnL w="6350" cap="flat" cmpd="sng" algn="ctr">
+                      <a:solidFill>
+                        <a:srgbClr val="E8C4C8"/>
+                      </a:solidFill>
+                    </a:lnL>
+                    <a:lnR w="6350" cap="flat" cmpd="sng" algn="ctr">
+                      <a:solidFill>
+                        <a:srgbClr val="E8C4C8"/>
+                      </a:solidFill>
+                    </a:lnR>
+                    <a:lnT w="6350" cap="flat" cmpd="sng" algn="ctr">
+                      <a:solidFill>
+                        <a:srgbClr val="E8C4C8"/>
+                      </a:solidFill>
+                    </a:lnT>
+                    <a:lnB w="6350" cap="flat" cmpd="sng" algn="ctr">
+                      <a:solidFill>
+                        <a:srgbClr val="E8C4C8"/>
+                      </a:solidFill>
+                    </a:lnB>
+                  </a:tcPr>
+                </a:tc>
+                <a:tc hMerge="1">
+                  <a:txBody>
+                    <a:bodyPr/>
+                    <a:lstStyle/>
+                    <a:p/>
+                  </a:txBody>
+                  <a:tcPr>
+                    <a:lnL w="6350" cap="flat" cmpd="sng" algn="ctr">
+                      <a:solidFill>
+                        <a:srgbClr val="E8C4C8"/>
+                      </a:solidFill>
+                    </a:lnL>
+                    <a:lnR w="6350" cap="flat" cmpd="sng" algn="ctr">
+                      <a:solidFill>
+                        <a:srgbClr val="E8C4C8"/>
+                      </a:solidFill>
+                    </a:lnR>
+                    <a:lnT w="6350" cap="flat" cmpd="sng" algn="ctr">
+                      <a:solidFill>
+                        <a:srgbClr val="E8C4C8"/>
+                      </a:solidFill>
+                    </a:lnT>
+                    <a:lnB w="6350" cap="flat" cmpd="sng" algn="ctr">
+                      <a:solidFill>
+                        <a:srgbClr val="E8C4C8"/>
+                      </a:solidFill>
+                    </a:lnB>
+                  </a:tcPr>
+                </a:tc>
+                <a:tc hMerge="1">
+                  <a:txBody>
+                    <a:bodyPr/>
+                    <a:lstStyle/>
+                    <a:p/>
+                  </a:txBody>
+                  <a:tcPr>
+                    <a:lnL w="6350" cap="flat" cmpd="sng" algn="ctr">
+                      <a:solidFill>
+                        <a:srgbClr val="E8C4C8"/>
+                      </a:solidFill>
+                    </a:lnL>
+                    <a:lnR w="6350" cap="flat" cmpd="sng" algn="ctr">
+                      <a:solidFill>
+                        <a:srgbClr val="E8C4C8"/>
+                      </a:solidFill>
+                    </a:lnR>
+                    <a:lnT w="6350" cap="flat" cmpd="sng" algn="ctr">
+                      <a:solidFill>
+                        <a:srgbClr val="E8C4C8"/>
+                      </a:solidFill>
+                    </a:lnT>
+                    <a:lnB w="6350" cap="flat" cmpd="sng" algn="ctr">
+                      <a:solidFill>
+                        <a:srgbClr val="E8C4C8"/>
+                      </a:solidFill>
+                    </a:lnB>
+                  </a:tcPr>
+                </a:tc>
+                <a:tc hMerge="1">
+                  <a:txBody>
+                    <a:bodyPr/>
+                    <a:lstStyle/>
+                    <a:p/>
+                  </a:txBody>
+                  <a:tcPr>
+                    <a:lnL w="6350" cap="flat" cmpd="sng" algn="ctr">
+                      <a:solidFill>
+                        <a:srgbClr val="E8C4C8"/>
+                      </a:solidFill>
+                    </a:lnL>
+                    <a:lnR w="6350" cap="flat" cmpd="sng" algn="ctr">
+                      <a:solidFill>
+                        <a:srgbClr val="E8C4C8"/>
+                      </a:solidFill>
+                    </a:lnR>
+                    <a:lnT w="6350" cap="flat" cmpd="sng" algn="ctr">
+                      <a:solidFill>
+                        <a:srgbClr val="E8C4C8"/>
+                      </a:solidFill>
+                    </a:lnT>
+                    <a:lnB w="6350" cap="flat" cmpd="sng" algn="ctr">
+                      <a:solidFill>
+                        <a:srgbClr val="E8C4C8"/>
+                      </a:solidFill>
+                    </a:lnB>
+                  </a:tcPr>
+                </a:tc>
                 <a:tc>
                   <a:txBody>
                     <a:bodyPr wrap="square"/>
@@ -26929,175 +27050,6 @@
                     <a:solidFill>
                       <a:srgbClr val="570C17"/>
                     </a:solidFill>
-                    <a:lnL w="6350" cap="flat" cmpd="sng" algn="ctr">
-                      <a:solidFill>
-                        <a:srgbClr val="E8C4C8"/>
-                      </a:solidFill>
-                    </a:lnL>
-                    <a:lnR w="6350" cap="flat" cmpd="sng" algn="ctr">
-                      <a:solidFill>
-                        <a:srgbClr val="E8C4C8"/>
-                      </a:solidFill>
-                    </a:lnR>
-                    <a:lnT w="6350" cap="flat" cmpd="sng" algn="ctr">
-                      <a:solidFill>
-                        <a:srgbClr val="E8C4C8"/>
-                      </a:solidFill>
-                    </a:lnT>
-                    <a:lnB w="6350" cap="flat" cmpd="sng" algn="ctr">
-                      <a:solidFill>
-                        <a:srgbClr val="E8C4C8"/>
-                      </a:solidFill>
-                    </a:lnB>
-                  </a:tcPr>
-                </a:tc>
-                <a:tc gridSpan="5">
-                  <a:txBody>
-                    <a:bodyPr wrap="square"/>
-                    <a:lstStyle/>
-                    <a:p>
-                      <a:pPr algn="ctr">
-                        <a:lnSpc>
-                          <a:spcPct val="100000"/>
-                        </a:lnSpc>
-                        <a:spcBef>
-                          <a:spcPts val="0"/>
-                        </a:spcBef>
-                        <a:spcAft>
-                          <a:spcPts val="0"/>
-                        </a:spcAft>
-                      </a:pPr>
-                      <a:r>
-                        <a:rPr sz="700" b="1">
-                          <a:solidFill>
-                            <a:srgbClr val="FFFFFF"/>
-                          </a:solidFill>
-                          <a:latin typeface="Calibri"/>
-                        </a:rPr>
-                        <a:t>2027</a:t>
-                      </a:r>
-                    </a:p>
-                  </a:txBody>
-                  <a:tcPr anchor="ctr" marL="25400" marR="25400" marT="12700" marB="12700">
-                    <a:solidFill>
-                      <a:srgbClr val="570C17"/>
-                    </a:solidFill>
-                    <a:lnL w="6350" cap="flat" cmpd="sng" algn="ctr">
-                      <a:solidFill>
-                        <a:srgbClr val="E8C4C8"/>
-                      </a:solidFill>
-                    </a:lnL>
-                    <a:lnR w="6350" cap="flat" cmpd="sng" algn="ctr">
-                      <a:solidFill>
-                        <a:srgbClr val="E8C4C8"/>
-                      </a:solidFill>
-                    </a:lnR>
-                    <a:lnT w="6350" cap="flat" cmpd="sng" algn="ctr">
-                      <a:solidFill>
-                        <a:srgbClr val="E8C4C8"/>
-                      </a:solidFill>
-                    </a:lnT>
-                    <a:lnB w="6350" cap="flat" cmpd="sng" algn="ctr">
-                      <a:solidFill>
-                        <a:srgbClr val="E8C4C8"/>
-                      </a:solidFill>
-                    </a:lnB>
-                  </a:tcPr>
-                </a:tc>
-                <a:tc hMerge="1">
-                  <a:txBody>
-                    <a:bodyPr/>
-                    <a:lstStyle/>
-                    <a:p/>
-                  </a:txBody>
-                  <a:tcPr>
-                    <a:lnL w="6350" cap="flat" cmpd="sng" algn="ctr">
-                      <a:solidFill>
-                        <a:srgbClr val="E8C4C8"/>
-                      </a:solidFill>
-                    </a:lnL>
-                    <a:lnR w="6350" cap="flat" cmpd="sng" algn="ctr">
-                      <a:solidFill>
-                        <a:srgbClr val="E8C4C8"/>
-                      </a:solidFill>
-                    </a:lnR>
-                    <a:lnT w="6350" cap="flat" cmpd="sng" algn="ctr">
-                      <a:solidFill>
-                        <a:srgbClr val="E8C4C8"/>
-                      </a:solidFill>
-                    </a:lnT>
-                    <a:lnB w="6350" cap="flat" cmpd="sng" algn="ctr">
-                      <a:solidFill>
-                        <a:srgbClr val="E8C4C8"/>
-                      </a:solidFill>
-                    </a:lnB>
-                  </a:tcPr>
-                </a:tc>
-                <a:tc hMerge="1">
-                  <a:txBody>
-                    <a:bodyPr/>
-                    <a:lstStyle/>
-                    <a:p/>
-                  </a:txBody>
-                  <a:tcPr>
-                    <a:lnL w="6350" cap="flat" cmpd="sng" algn="ctr">
-                      <a:solidFill>
-                        <a:srgbClr val="E8C4C8"/>
-                      </a:solidFill>
-                    </a:lnL>
-                    <a:lnR w="6350" cap="flat" cmpd="sng" algn="ctr">
-                      <a:solidFill>
-                        <a:srgbClr val="E8C4C8"/>
-                      </a:solidFill>
-                    </a:lnR>
-                    <a:lnT w="6350" cap="flat" cmpd="sng" algn="ctr">
-                      <a:solidFill>
-                        <a:srgbClr val="E8C4C8"/>
-                      </a:solidFill>
-                    </a:lnT>
-                    <a:lnB w="6350" cap="flat" cmpd="sng" algn="ctr">
-                      <a:solidFill>
-                        <a:srgbClr val="E8C4C8"/>
-                      </a:solidFill>
-                    </a:lnB>
-                  </a:tcPr>
-                </a:tc>
-                <a:tc hMerge="1">
-                  <a:txBody>
-                    <a:bodyPr/>
-                    <a:lstStyle/>
-                    <a:p/>
-                  </a:txBody>
-                  <a:tcPr>
-                    <a:lnL w="6350" cap="flat" cmpd="sng" algn="ctr">
-                      <a:solidFill>
-                        <a:srgbClr val="E8C4C8"/>
-                      </a:solidFill>
-                    </a:lnL>
-                    <a:lnR w="6350" cap="flat" cmpd="sng" algn="ctr">
-                      <a:solidFill>
-                        <a:srgbClr val="E8C4C8"/>
-                      </a:solidFill>
-                    </a:lnR>
-                    <a:lnT w="6350" cap="flat" cmpd="sng" algn="ctr">
-                      <a:solidFill>
-                        <a:srgbClr val="E8C4C8"/>
-                      </a:solidFill>
-                    </a:lnT>
-                    <a:lnB w="6350" cap="flat" cmpd="sng" algn="ctr">
-                      <a:solidFill>
-                        <a:srgbClr val="E8C4C8"/>
-                      </a:solidFill>
-                    </a:lnB>
-                  </a:tcPr>
-                </a:tc>
-                <a:tc hMerge="1">
-                  <a:txBody>
-                    <a:bodyPr/>
-                    <a:lstStyle/>
-                    <a:p/>
-                  </a:txBody>
-                  <a:tcPr>
                     <a:lnL w="6350" cap="flat" cmpd="sng" algn="ctr">
                       <a:solidFill>
                         <a:srgbClr val="E8C4C8"/>
@@ -27680,272 +27632,272 @@
                           </a:solidFill>
                           <a:latin typeface="Calibri"/>
                         </a:rPr>
+                        <a:t>05.27</a:t>
+                      </a:r>
+                    </a:p>
+                  </a:txBody>
+                  <a:tcPr anchor="ctr" marL="25400" marR="25400" marT="12700" marB="12700">
+                    <a:solidFill>
+                      <a:srgbClr val="570C17"/>
+                    </a:solidFill>
+                    <a:lnL w="6350" cap="flat" cmpd="sng" algn="ctr">
+                      <a:solidFill>
+                        <a:srgbClr val="E8C4C8"/>
+                      </a:solidFill>
+                    </a:lnL>
+                    <a:lnR w="6350" cap="flat" cmpd="sng" algn="ctr">
+                      <a:solidFill>
+                        <a:srgbClr val="E8C4C8"/>
+                      </a:solidFill>
+                    </a:lnR>
+                    <a:lnT w="6350" cap="flat" cmpd="sng" algn="ctr">
+                      <a:solidFill>
+                        <a:srgbClr val="E8C4C8"/>
+                      </a:solidFill>
+                    </a:lnT>
+                    <a:lnB w="6350" cap="flat" cmpd="sng" algn="ctr">
+                      <a:solidFill>
+                        <a:srgbClr val="E8C4C8"/>
+                      </a:solidFill>
+                    </a:lnB>
+                  </a:tcPr>
+                </a:tc>
+                <a:tc>
+                  <a:txBody>
+                    <a:bodyPr wrap="square"/>
+                    <a:lstStyle/>
+                    <a:p>
+                      <a:pPr algn="ctr">
+                        <a:lnSpc>
+                          <a:spcPct val="100000"/>
+                        </a:lnSpc>
+                        <a:spcBef>
+                          <a:spcPts val="0"/>
+                        </a:spcBef>
+                        <a:spcAft>
+                          <a:spcPts val="0"/>
+                        </a:spcAft>
+                      </a:pPr>
+                      <a:r>
+                        <a:rPr sz="600" b="1">
+                          <a:solidFill>
+                            <a:srgbClr val="FFFFFF"/>
+                          </a:solidFill>
+                          <a:latin typeface="Calibri"/>
+                        </a:rPr>
+                        <a:t>06.27</a:t>
+                      </a:r>
+                    </a:p>
+                  </a:txBody>
+                  <a:tcPr anchor="ctr" marL="25400" marR="25400" marT="12700" marB="12700">
+                    <a:solidFill>
+                      <a:srgbClr val="570C17"/>
+                    </a:solidFill>
+                    <a:lnL w="6350" cap="flat" cmpd="sng" algn="ctr">
+                      <a:solidFill>
+                        <a:srgbClr val="E8C4C8"/>
+                      </a:solidFill>
+                    </a:lnL>
+                    <a:lnR w="6350" cap="flat" cmpd="sng" algn="ctr">
+                      <a:solidFill>
+                        <a:srgbClr val="E8C4C8"/>
+                      </a:solidFill>
+                    </a:lnR>
+                    <a:lnT w="6350" cap="flat" cmpd="sng" algn="ctr">
+                      <a:solidFill>
+                        <a:srgbClr val="E8C4C8"/>
+                      </a:solidFill>
+                    </a:lnT>
+                    <a:lnB w="6350" cap="flat" cmpd="sng" algn="ctr">
+                      <a:solidFill>
+                        <a:srgbClr val="E8C4C8"/>
+                      </a:solidFill>
+                    </a:lnB>
+                  </a:tcPr>
+                </a:tc>
+                <a:tc>
+                  <a:txBody>
+                    <a:bodyPr wrap="square"/>
+                    <a:lstStyle/>
+                    <a:p>
+                      <a:pPr algn="ctr">
+                        <a:lnSpc>
+                          <a:spcPct val="100000"/>
+                        </a:lnSpc>
+                        <a:spcBef>
+                          <a:spcPts val="0"/>
+                        </a:spcBef>
+                        <a:spcAft>
+                          <a:spcPts val="0"/>
+                        </a:spcAft>
+                      </a:pPr>
+                      <a:r>
+                        <a:rPr sz="600" b="1">
+                          <a:solidFill>
+                            <a:srgbClr val="FFFFFF"/>
+                          </a:solidFill>
+                          <a:latin typeface="Calibri"/>
+                        </a:rPr>
+                        <a:t>07.27</a:t>
+                      </a:r>
+                    </a:p>
+                  </a:txBody>
+                  <a:tcPr anchor="ctr" marL="25400" marR="25400" marT="12700" marB="12700">
+                    <a:solidFill>
+                      <a:srgbClr val="570C17"/>
+                    </a:solidFill>
+                    <a:lnL w="6350" cap="flat" cmpd="sng" algn="ctr">
+                      <a:solidFill>
+                        <a:srgbClr val="E8C4C8"/>
+                      </a:solidFill>
+                    </a:lnL>
+                    <a:lnR w="6350" cap="flat" cmpd="sng" algn="ctr">
+                      <a:solidFill>
+                        <a:srgbClr val="E8C4C8"/>
+                      </a:solidFill>
+                    </a:lnR>
+                    <a:lnT w="6350" cap="flat" cmpd="sng" algn="ctr">
+                      <a:solidFill>
+                        <a:srgbClr val="E8C4C8"/>
+                      </a:solidFill>
+                    </a:lnT>
+                    <a:lnB w="6350" cap="flat" cmpd="sng" algn="ctr">
+                      <a:solidFill>
+                        <a:srgbClr val="E8C4C8"/>
+                      </a:solidFill>
+                    </a:lnB>
+                  </a:tcPr>
+                </a:tc>
+                <a:tc>
+                  <a:txBody>
+                    <a:bodyPr wrap="square"/>
+                    <a:lstStyle/>
+                    <a:p>
+                      <a:pPr algn="ctr">
+                        <a:lnSpc>
+                          <a:spcPct val="100000"/>
+                        </a:lnSpc>
+                        <a:spcBef>
+                          <a:spcPts val="0"/>
+                        </a:spcBef>
+                        <a:spcAft>
+                          <a:spcPts val="0"/>
+                        </a:spcAft>
+                      </a:pPr>
+                      <a:r>
+                        <a:rPr sz="600" b="1">
+                          <a:solidFill>
+                            <a:srgbClr val="FFFFFF"/>
+                          </a:solidFill>
+                          <a:latin typeface="Calibri"/>
+                        </a:rPr>
+                        <a:t>08.27</a:t>
+                      </a:r>
+                    </a:p>
+                  </a:txBody>
+                  <a:tcPr anchor="ctr" marL="25400" marR="25400" marT="12700" marB="12700">
+                    <a:solidFill>
+                      <a:srgbClr val="570C17"/>
+                    </a:solidFill>
+                    <a:lnL w="6350" cap="flat" cmpd="sng" algn="ctr">
+                      <a:solidFill>
+                        <a:srgbClr val="E8C4C8"/>
+                      </a:solidFill>
+                    </a:lnL>
+                    <a:lnR w="6350" cap="flat" cmpd="sng" algn="ctr">
+                      <a:solidFill>
+                        <a:srgbClr val="E8C4C8"/>
+                      </a:solidFill>
+                    </a:lnR>
+                    <a:lnT w="6350" cap="flat" cmpd="sng" algn="ctr">
+                      <a:solidFill>
+                        <a:srgbClr val="E8C4C8"/>
+                      </a:solidFill>
+                    </a:lnT>
+                    <a:lnB w="6350" cap="flat" cmpd="sng" algn="ctr">
+                      <a:solidFill>
+                        <a:srgbClr val="E8C4C8"/>
+                      </a:solidFill>
+                    </a:lnB>
+                  </a:tcPr>
+                </a:tc>
+                <a:tc>
+                  <a:txBody>
+                    <a:bodyPr wrap="square"/>
+                    <a:lstStyle/>
+                    <a:p>
+                      <a:pPr algn="ctr">
+                        <a:lnSpc>
+                          <a:spcPct val="100000"/>
+                        </a:lnSpc>
+                        <a:spcBef>
+                          <a:spcPts val="0"/>
+                        </a:spcBef>
+                        <a:spcAft>
+                          <a:spcPts val="0"/>
+                        </a:spcAft>
+                      </a:pPr>
+                      <a:r>
+                        <a:rPr sz="600" b="1">
+                          <a:solidFill>
+                            <a:srgbClr val="FFFFFF"/>
+                          </a:solidFill>
+                          <a:latin typeface="Calibri"/>
+                        </a:rPr>
+                        <a:t>09.27</a:t>
+                      </a:r>
+                    </a:p>
+                  </a:txBody>
+                  <a:tcPr anchor="ctr" marL="25400" marR="25400" marT="12700" marB="12700">
+                    <a:solidFill>
+                      <a:srgbClr val="570C17"/>
+                    </a:solidFill>
+                    <a:lnL w="6350" cap="flat" cmpd="sng" algn="ctr">
+                      <a:solidFill>
+                        <a:srgbClr val="E8C4C8"/>
+                      </a:solidFill>
+                    </a:lnL>
+                    <a:lnR w="6350" cap="flat" cmpd="sng" algn="ctr">
+                      <a:solidFill>
+                        <a:srgbClr val="E8C4C8"/>
+                      </a:solidFill>
+                    </a:lnR>
+                    <a:lnT w="6350" cap="flat" cmpd="sng" algn="ctr">
+                      <a:solidFill>
+                        <a:srgbClr val="E8C4C8"/>
+                      </a:solidFill>
+                    </a:lnT>
+                    <a:lnB w="6350" cap="flat" cmpd="sng" algn="ctr">
+                      <a:solidFill>
+                        <a:srgbClr val="E8C4C8"/>
+                      </a:solidFill>
+                    </a:lnB>
+                  </a:tcPr>
+                </a:tc>
+                <a:tc>
+                  <a:txBody>
+                    <a:bodyPr wrap="square"/>
+                    <a:lstStyle/>
+                    <a:p>
+                      <a:pPr algn="ctr">
+                        <a:lnSpc>
+                          <a:spcPct val="100000"/>
+                        </a:lnSpc>
+                        <a:spcBef>
+                          <a:spcPts val="0"/>
+                        </a:spcBef>
+                        <a:spcAft>
+                          <a:spcPts val="0"/>
+                        </a:spcAft>
+                      </a:pPr>
+                      <a:r>
+                        <a:rPr sz="600" b="1">
+                          <a:solidFill>
+                            <a:srgbClr val="FFFFFF"/>
+                          </a:solidFill>
+                          <a:latin typeface="Calibri"/>
+                        </a:rPr>
                         <a:t>04.28</a:t>
-                      </a:r>
-                    </a:p>
-                  </a:txBody>
-                  <a:tcPr anchor="ctr" marL="25400" marR="25400" marT="12700" marB="12700">
-                    <a:solidFill>
-                      <a:srgbClr val="570C17"/>
-                    </a:solidFill>
-                    <a:lnL w="6350" cap="flat" cmpd="sng" algn="ctr">
-                      <a:solidFill>
-                        <a:srgbClr val="E8C4C8"/>
-                      </a:solidFill>
-                    </a:lnL>
-                    <a:lnR w="6350" cap="flat" cmpd="sng" algn="ctr">
-                      <a:solidFill>
-                        <a:srgbClr val="E8C4C8"/>
-                      </a:solidFill>
-                    </a:lnR>
-                    <a:lnT w="6350" cap="flat" cmpd="sng" algn="ctr">
-                      <a:solidFill>
-                        <a:srgbClr val="E8C4C8"/>
-                      </a:solidFill>
-                    </a:lnT>
-                    <a:lnB w="6350" cap="flat" cmpd="sng" algn="ctr">
-                      <a:solidFill>
-                        <a:srgbClr val="E8C4C8"/>
-                      </a:solidFill>
-                    </a:lnB>
-                  </a:tcPr>
-                </a:tc>
-                <a:tc>
-                  <a:txBody>
-                    <a:bodyPr wrap="square"/>
-                    <a:lstStyle/>
-                    <a:p>
-                      <a:pPr algn="ctr">
-                        <a:lnSpc>
-                          <a:spcPct val="100000"/>
-                        </a:lnSpc>
-                        <a:spcBef>
-                          <a:spcPts val="0"/>
-                        </a:spcBef>
-                        <a:spcAft>
-                          <a:spcPts val="0"/>
-                        </a:spcAft>
-                      </a:pPr>
-                      <a:r>
-                        <a:rPr sz="600" b="1">
-                          <a:solidFill>
-                            <a:srgbClr val="FFFFFF"/>
-                          </a:solidFill>
-                          <a:latin typeface="Calibri"/>
-                        </a:rPr>
-                        <a:t>05.27</a:t>
-                      </a:r>
-                    </a:p>
-                  </a:txBody>
-                  <a:tcPr anchor="ctr" marL="25400" marR="25400" marT="12700" marB="12700">
-                    <a:solidFill>
-                      <a:srgbClr val="570C17"/>
-                    </a:solidFill>
-                    <a:lnL w="6350" cap="flat" cmpd="sng" algn="ctr">
-                      <a:solidFill>
-                        <a:srgbClr val="E8C4C8"/>
-                      </a:solidFill>
-                    </a:lnL>
-                    <a:lnR w="6350" cap="flat" cmpd="sng" algn="ctr">
-                      <a:solidFill>
-                        <a:srgbClr val="E8C4C8"/>
-                      </a:solidFill>
-                    </a:lnR>
-                    <a:lnT w="6350" cap="flat" cmpd="sng" algn="ctr">
-                      <a:solidFill>
-                        <a:srgbClr val="E8C4C8"/>
-                      </a:solidFill>
-                    </a:lnT>
-                    <a:lnB w="6350" cap="flat" cmpd="sng" algn="ctr">
-                      <a:solidFill>
-                        <a:srgbClr val="E8C4C8"/>
-                      </a:solidFill>
-                    </a:lnB>
-                  </a:tcPr>
-                </a:tc>
-                <a:tc>
-                  <a:txBody>
-                    <a:bodyPr wrap="square"/>
-                    <a:lstStyle/>
-                    <a:p>
-                      <a:pPr algn="ctr">
-                        <a:lnSpc>
-                          <a:spcPct val="100000"/>
-                        </a:lnSpc>
-                        <a:spcBef>
-                          <a:spcPts val="0"/>
-                        </a:spcBef>
-                        <a:spcAft>
-                          <a:spcPts val="0"/>
-                        </a:spcAft>
-                      </a:pPr>
-                      <a:r>
-                        <a:rPr sz="600" b="1">
-                          <a:solidFill>
-                            <a:srgbClr val="FFFFFF"/>
-                          </a:solidFill>
-                          <a:latin typeface="Calibri"/>
-                        </a:rPr>
-                        <a:t>06.27</a:t>
-                      </a:r>
-                    </a:p>
-                  </a:txBody>
-                  <a:tcPr anchor="ctr" marL="25400" marR="25400" marT="12700" marB="12700">
-                    <a:solidFill>
-                      <a:srgbClr val="570C17"/>
-                    </a:solidFill>
-                    <a:lnL w="6350" cap="flat" cmpd="sng" algn="ctr">
-                      <a:solidFill>
-                        <a:srgbClr val="E8C4C8"/>
-                      </a:solidFill>
-                    </a:lnL>
-                    <a:lnR w="6350" cap="flat" cmpd="sng" algn="ctr">
-                      <a:solidFill>
-                        <a:srgbClr val="E8C4C8"/>
-                      </a:solidFill>
-                    </a:lnR>
-                    <a:lnT w="6350" cap="flat" cmpd="sng" algn="ctr">
-                      <a:solidFill>
-                        <a:srgbClr val="E8C4C8"/>
-                      </a:solidFill>
-                    </a:lnT>
-                    <a:lnB w="6350" cap="flat" cmpd="sng" algn="ctr">
-                      <a:solidFill>
-                        <a:srgbClr val="E8C4C8"/>
-                      </a:solidFill>
-                    </a:lnB>
-                  </a:tcPr>
-                </a:tc>
-                <a:tc>
-                  <a:txBody>
-                    <a:bodyPr wrap="square"/>
-                    <a:lstStyle/>
-                    <a:p>
-                      <a:pPr algn="ctr">
-                        <a:lnSpc>
-                          <a:spcPct val="100000"/>
-                        </a:lnSpc>
-                        <a:spcBef>
-                          <a:spcPts val="0"/>
-                        </a:spcBef>
-                        <a:spcAft>
-                          <a:spcPts val="0"/>
-                        </a:spcAft>
-                      </a:pPr>
-                      <a:r>
-                        <a:rPr sz="600" b="1">
-                          <a:solidFill>
-                            <a:srgbClr val="FFFFFF"/>
-                          </a:solidFill>
-                          <a:latin typeface="Calibri"/>
-                        </a:rPr>
-                        <a:t>07.27</a:t>
-                      </a:r>
-                    </a:p>
-                  </a:txBody>
-                  <a:tcPr anchor="ctr" marL="25400" marR="25400" marT="12700" marB="12700">
-                    <a:solidFill>
-                      <a:srgbClr val="570C17"/>
-                    </a:solidFill>
-                    <a:lnL w="6350" cap="flat" cmpd="sng" algn="ctr">
-                      <a:solidFill>
-                        <a:srgbClr val="E8C4C8"/>
-                      </a:solidFill>
-                    </a:lnL>
-                    <a:lnR w="6350" cap="flat" cmpd="sng" algn="ctr">
-                      <a:solidFill>
-                        <a:srgbClr val="E8C4C8"/>
-                      </a:solidFill>
-                    </a:lnR>
-                    <a:lnT w="6350" cap="flat" cmpd="sng" algn="ctr">
-                      <a:solidFill>
-                        <a:srgbClr val="E8C4C8"/>
-                      </a:solidFill>
-                    </a:lnT>
-                    <a:lnB w="6350" cap="flat" cmpd="sng" algn="ctr">
-                      <a:solidFill>
-                        <a:srgbClr val="E8C4C8"/>
-                      </a:solidFill>
-                    </a:lnB>
-                  </a:tcPr>
-                </a:tc>
-                <a:tc>
-                  <a:txBody>
-                    <a:bodyPr wrap="square"/>
-                    <a:lstStyle/>
-                    <a:p>
-                      <a:pPr algn="ctr">
-                        <a:lnSpc>
-                          <a:spcPct val="100000"/>
-                        </a:lnSpc>
-                        <a:spcBef>
-                          <a:spcPts val="0"/>
-                        </a:spcBef>
-                        <a:spcAft>
-                          <a:spcPts val="0"/>
-                        </a:spcAft>
-                      </a:pPr>
-                      <a:r>
-                        <a:rPr sz="600" b="1">
-                          <a:solidFill>
-                            <a:srgbClr val="FFFFFF"/>
-                          </a:solidFill>
-                          <a:latin typeface="Calibri"/>
-                        </a:rPr>
-                        <a:t>08.27</a:t>
-                      </a:r>
-                    </a:p>
-                  </a:txBody>
-                  <a:tcPr anchor="ctr" marL="25400" marR="25400" marT="12700" marB="12700">
-                    <a:solidFill>
-                      <a:srgbClr val="570C17"/>
-                    </a:solidFill>
-                    <a:lnL w="6350" cap="flat" cmpd="sng" algn="ctr">
-                      <a:solidFill>
-                        <a:srgbClr val="E8C4C8"/>
-                      </a:solidFill>
-                    </a:lnL>
-                    <a:lnR w="6350" cap="flat" cmpd="sng" algn="ctr">
-                      <a:solidFill>
-                        <a:srgbClr val="E8C4C8"/>
-                      </a:solidFill>
-                    </a:lnR>
-                    <a:lnT w="6350" cap="flat" cmpd="sng" algn="ctr">
-                      <a:solidFill>
-                        <a:srgbClr val="E8C4C8"/>
-                      </a:solidFill>
-                    </a:lnT>
-                    <a:lnB w="6350" cap="flat" cmpd="sng" algn="ctr">
-                      <a:solidFill>
-                        <a:srgbClr val="E8C4C8"/>
-                      </a:solidFill>
-                    </a:lnB>
-                  </a:tcPr>
-                </a:tc>
-                <a:tc>
-                  <a:txBody>
-                    <a:bodyPr wrap="square"/>
-                    <a:lstStyle/>
-                    <a:p>
-                      <a:pPr algn="ctr">
-                        <a:lnSpc>
-                          <a:spcPct val="100000"/>
-                        </a:lnSpc>
-                        <a:spcBef>
-                          <a:spcPts val="0"/>
-                        </a:spcBef>
-                        <a:spcAft>
-                          <a:spcPts val="0"/>
-                        </a:spcAft>
-                      </a:pPr>
-                      <a:r>
-                        <a:rPr sz="600" b="1">
-                          <a:solidFill>
-                            <a:srgbClr val="FFFFFF"/>
-                          </a:solidFill>
-                          <a:latin typeface="Calibri"/>
-                        </a:rPr>
-                        <a:t>09.27</a:t>
                       </a:r>
                     </a:p>
                   </a:txBody>
@@ -31433,6 +31385,59 @@
                     <a:bodyPr wrap="square"/>
                     <a:lstStyle/>
                     <a:p>
+                      <a:pPr algn="ctr">
+                        <a:lnSpc>
+                          <a:spcPct val="100000"/>
+                        </a:lnSpc>
+                        <a:spcBef>
+                          <a:spcPts val="0"/>
+                        </a:spcBef>
+                        <a:spcAft>
+                          <a:spcPts val="0"/>
+                        </a:spcAft>
+                      </a:pPr>
+                      <a:r>
+                        <a:rPr sz="500" b="0">
+                          <a:solidFill>
+                            <a:srgbClr val="962837"/>
+                          </a:solidFill>
+                          <a:latin typeface="Calibri"/>
+                        </a:rPr>
+                        <a:t>КЦ</a:t>
+                      </a:r>
+                    </a:p>
+                  </a:txBody>
+                  <a:tcPr anchor="ctr" marL="25400" marR="25400" marT="12700" marB="12700">
+                    <a:solidFill>
+                      <a:srgbClr val="FFD2D8"/>
+                    </a:solidFill>
+                    <a:lnL w="6350" cap="flat" cmpd="sng" algn="ctr">
+                      <a:solidFill>
+                        <a:srgbClr val="E8C4C8"/>
+                      </a:solidFill>
+                    </a:lnL>
+                    <a:lnR w="6350" cap="flat" cmpd="sng" algn="ctr">
+                      <a:solidFill>
+                        <a:srgbClr val="E8C4C8"/>
+                      </a:solidFill>
+                    </a:lnR>
+                    <a:lnT w="6350" cap="flat" cmpd="sng" algn="ctr">
+                      <a:solidFill>
+                        <a:srgbClr val="E8C4C8"/>
+                      </a:solidFill>
+                    </a:lnT>
+                    <a:lnB w="6350" cap="flat" cmpd="sng" algn="ctr">
+                      <a:solidFill>
+                        <a:srgbClr val="E8C4C8"/>
+                      </a:solidFill>
+                    </a:lnB>
+                  </a:tcPr>
+                </a:tc>
+                <a:tc>
+                  <a:txBody>
+                    <a:bodyPr wrap="square"/>
+                    <a:lstStyle/>
+                    <a:p>
                       <a:pPr algn="l">
                         <a:lnSpc>
                           <a:spcPct val="100000"/>
@@ -31458,59 +31463,6 @@
                   <a:tcPr anchor="ctr" marL="25400" marR="25400" marT="12700" marB="12700">
                     <a:solidFill>
                       <a:srgbClr val="FCF8F9"/>
-                    </a:solidFill>
-                    <a:lnL w="6350" cap="flat" cmpd="sng" algn="ctr">
-                      <a:solidFill>
-                        <a:srgbClr val="E8C4C8"/>
-                      </a:solidFill>
-                    </a:lnL>
-                    <a:lnR w="6350" cap="flat" cmpd="sng" algn="ctr">
-                      <a:solidFill>
-                        <a:srgbClr val="E8C4C8"/>
-                      </a:solidFill>
-                    </a:lnR>
-                    <a:lnT w="6350" cap="flat" cmpd="sng" algn="ctr">
-                      <a:solidFill>
-                        <a:srgbClr val="E8C4C8"/>
-                      </a:solidFill>
-                    </a:lnT>
-                    <a:lnB w="6350" cap="flat" cmpd="sng" algn="ctr">
-                      <a:solidFill>
-                        <a:srgbClr val="E8C4C8"/>
-                      </a:solidFill>
-                    </a:lnB>
-                  </a:tcPr>
-                </a:tc>
-                <a:tc>
-                  <a:txBody>
-                    <a:bodyPr wrap="square"/>
-                    <a:lstStyle/>
-                    <a:p>
-                      <a:pPr algn="ctr">
-                        <a:lnSpc>
-                          <a:spcPct val="100000"/>
-                        </a:lnSpc>
-                        <a:spcBef>
-                          <a:spcPts val="0"/>
-                        </a:spcBef>
-                        <a:spcAft>
-                          <a:spcPts val="0"/>
-                        </a:spcAft>
-                      </a:pPr>
-                      <a:r>
-                        <a:rPr sz="500" b="0">
-                          <a:solidFill>
-                            <a:srgbClr val="962837"/>
-                          </a:solidFill>
-                          <a:latin typeface="Calibri"/>
-                        </a:rPr>
-                        <a:t>КЦ</a:t>
-                      </a:r>
-                    </a:p>
-                  </a:txBody>
-                  <a:tcPr anchor="ctr" marL="25400" marR="25400" marT="12700" marB="12700">
-                    <a:solidFill>
-                      <a:srgbClr val="FFD2D8"/>
                     </a:solidFill>
                     <a:lnL w="6350" cap="flat" cmpd="sng" algn="ctr">
                       <a:solidFill>

</xml_diff>